<commit_message>
P4: A-MEM+HippoRAG e2e通过 + SocialMem Mem0全量 + BM25vsMem0详细对比 + 时间戳
- A-MEM(run_amem.py)+HippoRAG(run_hipporag.py,conda hippo env+vllm桩+Contriever) 均e2e通过
- SocialMem Mem0全量: acc13.7% < BM25 28.6% (落在论文0.12-0.18,坐实motivation)
- 实验结果.md: 三数据集BM25vsMem0详细按类别表; V2 PPT新增详细表(13页)
- 所有 results/*.json 加时间戳; embed_server.py(本地Qwen嵌入服务); claude记忆快照入库
- GroupMem/EverMem 全量Mem0进行中

Co-Authored-By: Claude Opus 4.8 <noreply@anthropic.com>
</commit_message>
<xml_diff>
--- a/SpeakerMem-R1-汇报V2-问题导向.pptx
+++ b/SpeakerMem-R1-汇报V2-问题导向.pptx
@@ -17,9 +17,10 @@
     <p:sldId id="265" r:id="rId11"/>
     <p:sldId id="266" r:id="rId12"/>
     <p:sldId id="267" r:id="rId13"/>
+    <p:sldId id="268" r:id="rId14"/>
   </p:sldIdLst>
   <p:notesMasterIdLst>
-    <p:notesMasterId r:id="rId14"/>
+    <p:notesMasterId r:id="rId15"/>
   </p:notesMasterIdLst>
   <p:sldSz cx="9144000" cy="5143500"/>
   <p:notesSz cx="5143500" cy="9144000"/>
@@ -801,6 +802,94 @@
             <a:fld id="{F7021451-1387-4CA6-816F-3879F97B5CBC}" type="slidenum">
               <a:rPr lang="en-US"/>
               <a:t>12</a:t>
+            </a:fld>
+            <a:endParaRPr lang="en-US"/>
+          </a:p>
+        </p:txBody>
+      </p:sp>
+    </p:spTree>
+    <p:extLst>
+      <p:ext uri="{BB962C8B-B14F-4D97-AF65-F5344CB8AC3E}">
+        <p14:creationId xmlns:p14="http://schemas.microsoft.com/office/powerpoint/2010/main" val="1024086991"/>
+      </p:ext>
+    </p:extLst>
+  </p:cSld>
+  <p:clrMapOvr>
+    <a:masterClrMapping/>
+  </p:clrMapOvr>
+</p:notes>
+</file>
+
+<file path=ppt/notesSlides/notesSlide13.xml><?xml version="1.0" encoding="utf-8"?>
+<p:notes xmlns:a="http://schemas.openxmlformats.org/drawingml/2006/main" xmlns:r="http://schemas.openxmlformats.org/officeDocument/2006/relationships" xmlns:p="http://schemas.openxmlformats.org/presentationml/2006/main">
+  <p:cSld>
+    <p:spTree>
+      <p:nvGrpSpPr>
+        <p:cNvPr id="1" name=""/>
+        <p:cNvGrpSpPr/>
+        <p:nvPr/>
+      </p:nvGrpSpPr>
+      <p:grpSpPr>
+        <a:xfrm>
+          <a:off x="0" y="0"/>
+          <a:ext cx="0" cy="0"/>
+          <a:chOff x="0" y="0"/>
+          <a:chExt cx="0" cy="0"/>
+        </a:xfrm>
+      </p:grpSpPr>
+      <p:sp>
+        <p:nvSpPr>
+          <p:cNvPr id="2" name="Slide Image Placeholder 1"/>
+          <p:cNvSpPr>
+            <a:spLocks noGrp="1" noRot="1" noChangeAspect="1"/>
+          </p:cNvSpPr>
+          <p:nvPr>
+            <p:ph type="sldImg"/>
+          </p:nvPr>
+        </p:nvSpPr>
+        <p:spPr/>
+      </p:sp>
+      <p:sp>
+        <p:nvSpPr>
+          <p:cNvPr id="3" name="Notes Placeholder 2"/>
+          <p:cNvSpPr>
+            <a:spLocks noGrp="1"/>
+          </p:cNvSpPr>
+          <p:nvPr>
+            <p:ph type="body" idx="1"/>
+          </p:nvPr>
+        </p:nvSpPr>
+        <p:spPr/>
+        <p:txBody>
+          <a:bodyPr/>
+          <a:lstStyle/>
+          <a:p>
+            <a:r>
+              <a:rPr lang="en-US" dirty="0"/>
+              <a:t/>
+            </a:r>
+            <a:endParaRPr lang="en-US" dirty="0"/>
+          </a:p>
+        </p:txBody>
+      </p:sp>
+      <p:sp>
+        <p:nvSpPr>
+          <p:cNvPr id="4" name="Slide Number Placeholder 3"/>
+          <p:cNvSpPr>
+            <a:spLocks noGrp="1"/>
+          </p:cNvSpPr>
+          <p:nvPr>
+            <p:ph type="sldNum" sz="quarter" idx="10"/>
+          </p:nvPr>
+        </p:nvSpPr>
+        <p:spPr/>
+        <p:txBody>
+          <a:bodyPr/>
+          <a:lstStyle/>
+          <a:p>
+            <a:fld id="{F7021451-1387-4CA6-816F-3879F97B5CBC}" type="slidenum">
+              <a:rPr lang="en-US"/>
+              <a:t>13</a:t>
             </a:fld>
             <a:endParaRPr lang="en-US"/>
           </a:p>
@@ -2795,7 +2884,7 @@
                 <a:ea typeface="Microsoft YaHei" pitchFamily="34" charset="-122"/>
                 <a:cs typeface="Microsoft YaHei" pitchFamily="34" charset="-120"/>
               </a:rPr>
-              <a:t>1 / 12</a:t>
+              <a:t>1 / 13</a:t>
             </a:r>
             <a:endParaRPr lang="en-US" sz="800" dirty="0"/>
           </a:p>
@@ -4485,7 +4574,7 @@
                 <a:ea typeface="Microsoft YaHei" pitchFamily="34" charset="-122"/>
                 <a:cs typeface="Microsoft YaHei" pitchFamily="34" charset="-120"/>
               </a:rPr>
-              <a:t>10 / 12</a:t>
+              <a:t>10 / 13</a:t>
             </a:r>
             <a:endParaRPr lang="en-US" sz="800" dirty="0"/>
           </a:p>
@@ -5837,7 +5926,7 @@
                 <a:ea typeface="Microsoft YaHei" pitchFamily="34" charset="-122"/>
                 <a:cs typeface="Microsoft YaHei" pitchFamily="34" charset="-120"/>
               </a:rPr>
-              <a:t>11 / 12</a:t>
+              <a:t>11 / 13</a:t>
             </a:r>
             <a:endParaRPr lang="en-US" sz="800" dirty="0"/>
           </a:p>
@@ -5996,12 +6085,12 @@
             <a:tbl>
               <a:tblPr/>
               <a:tblGrid>
-                <a:gridCol w="1783080"/>
-                <a:gridCol w="731520"/>
-                <a:gridCol w="1417320"/>
+                <a:gridCol w="1691640"/>
                 <a:gridCol w="640080"/>
-                <a:gridCol w="640080"/>
-                <a:gridCol w="3017520"/>
+                <a:gridCol w="1051560"/>
+                <a:gridCol w="1051560"/>
+                <a:gridCol w="1234440"/>
+                <a:gridCol w="2560320"/>
               </a:tblGrid>
               <a:tr h="310896">
                 <a:tc>
@@ -6157,7 +6246,7 @@
                           <a:ea typeface="Microsoft YaHei" pitchFamily="34" charset="-122"/>
                           <a:cs typeface="Microsoft YaHei" pitchFamily="34" charset="-120"/>
                         </a:rPr>
-                        <a:t>judge准确率</a:t>
+                        <a:t>BM25 acc</a:t>
                       </a:r>
                       <a:endParaRPr lang="en-US" sz="950" dirty="0">
                         <a:latin typeface="Microsoft YaHei" charset="0"/>
@@ -6225,7 +6314,7 @@
                           <a:ea typeface="Microsoft YaHei" pitchFamily="34" charset="-122"/>
                           <a:cs typeface="Microsoft YaHei" pitchFamily="34" charset="-120"/>
                         </a:rPr>
-                        <a:t>EM</a:t>
+                        <a:t>Mem0 acc</a:t>
                       </a:r>
                       <a:endParaRPr lang="en-US" sz="950" dirty="0">
                         <a:latin typeface="Microsoft YaHei" charset="0"/>
@@ -6293,7 +6382,7 @@
                           <a:ea typeface="Microsoft YaHei" pitchFamily="34" charset="-122"/>
                           <a:cs typeface="Microsoft YaHei" pitchFamily="34" charset="-120"/>
                         </a:rPr>
-                        <a:t>F1</a:t>
+                        <a:t>BM25 EM/F1</a:t>
                       </a:r>
                       <a:endParaRPr lang="en-US" sz="950" dirty="0">
                         <a:latin typeface="Microsoft YaHei" charset="0"/>
@@ -6629,13 +6718,13 @@
                       <a:r>
                         <a:rPr lang="en-US" sz="860" dirty="0">
                           <a:solidFill>
-                            <a:srgbClr val="334155"/>
+                            <a:srgbClr val="64748B"/>
                           </a:solidFill>
                           <a:latin typeface="Microsoft YaHei" pitchFamily="34" charset="0"/>
                           <a:ea typeface="Microsoft YaHei" pitchFamily="34" charset="-122"/>
                           <a:cs typeface="Microsoft YaHei" pitchFamily="34" charset="-120"/>
                         </a:rPr>
-                        <a:t>13.8</a:t>
+                        <a:t>跑ing</a:t>
                       </a:r>
                       <a:endParaRPr lang="en-US" sz="860" dirty="0">
                         <a:latin typeface="Microsoft YaHei" charset="0"/>
@@ -6703,7 +6792,7 @@
                           <a:ea typeface="Microsoft YaHei" pitchFamily="34" charset="-122"/>
                           <a:cs typeface="Microsoft YaHei" pitchFamily="34" charset="-120"/>
                         </a:rPr>
-                        <a:t>25.0</a:t>
+                        <a:t>13.8 / 25.0</a:t>
                       </a:r>
                       <a:endParaRPr lang="en-US" sz="860" dirty="0">
                         <a:latin typeface="Microsoft YaHei" charset="0"/>
@@ -7037,15 +7126,15 @@
                         <a:buNone/>
                       </a:pPr>
                       <a:r>
-                        <a:rPr lang="en-US" sz="860" dirty="0">
+                        <a:rPr lang="en-US" sz="860" b="1" dirty="0">
                           <a:solidFill>
-                            <a:srgbClr val="334155"/>
+                            <a:srgbClr val="B45309"/>
                           </a:solidFill>
                           <a:latin typeface="Microsoft YaHei" pitchFamily="34" charset="0"/>
                           <a:ea typeface="Microsoft YaHei" pitchFamily="34" charset="-122"/>
                           <a:cs typeface="Microsoft YaHei" pitchFamily="34" charset="-120"/>
                         </a:rPr>
-                        <a:t>3.6</a:t>
+                        <a:t>13.7%</a:t>
                       </a:r>
                       <a:endParaRPr lang="en-US" sz="860" dirty="0">
                         <a:latin typeface="Microsoft YaHei" charset="0"/>
@@ -7113,7 +7202,7 @@
                           <a:ea typeface="Microsoft YaHei" pitchFamily="34" charset="-122"/>
                           <a:cs typeface="Microsoft YaHei" pitchFamily="34" charset="-120"/>
                         </a:rPr>
-                        <a:t>15.7</a:t>
+                        <a:t>3.6 / 15.7</a:t>
                       </a:r>
                       <a:endParaRPr lang="en-US" sz="860" dirty="0">
                         <a:latin typeface="Microsoft YaHei" charset="0"/>
@@ -7181,7 +7270,7 @@
                           <a:ea typeface="Microsoft YaHei" pitchFamily="34" charset="-122"/>
                           <a:cs typeface="Microsoft YaHei" pitchFamily="34" charset="-120"/>
                         </a:rPr>
-                        <a:t>&gt; 开源记忆系统 0.12–0.18</a:t>
+                        <a:t>BM25 完胜 Mem0；Mem0∈0.12–0.18</a:t>
                       </a:r>
                       <a:endParaRPr lang="en-US" sz="860" dirty="0">
                         <a:latin typeface="Microsoft YaHei" charset="0"/>
@@ -7449,13 +7538,13 @@
                       <a:r>
                         <a:rPr lang="en-US" sz="860" dirty="0">
                           <a:solidFill>
-                            <a:srgbClr val="334155"/>
+                            <a:srgbClr val="64748B"/>
                           </a:solidFill>
                           <a:latin typeface="Microsoft YaHei" pitchFamily="34" charset="0"/>
                           <a:ea typeface="Microsoft YaHei" pitchFamily="34" charset="-122"/>
                           <a:cs typeface="Microsoft YaHei" pitchFamily="34" charset="-120"/>
                         </a:rPr>
-                        <a:t>4.8</a:t>
+                        <a:t>跑ing</a:t>
                       </a:r>
                       <a:endParaRPr lang="en-US" sz="860" dirty="0">
                         <a:latin typeface="Microsoft YaHei" charset="0"/>
@@ -7523,7 +7612,7 @@
                           <a:ea typeface="Microsoft YaHei" pitchFamily="34" charset="-122"/>
                           <a:cs typeface="Microsoft YaHei" pitchFamily="34" charset="-120"/>
                         </a:rPr>
-                        <a:t>9.9</a:t>
+                        <a:t>4.8 / 9.9</a:t>
                       </a:r>
                       <a:endParaRPr lang="en-US" sz="860" dirty="0">
                         <a:latin typeface="Microsoft YaHei" charset="0"/>
@@ -7675,7 +7764,7 @@
               <a:buNone/>
             </a:pPr>
             <a:r>
-              <a:rPr lang="en-US" sz="850" i="1" dirty="0">
+              <a:rPr lang="en-US" sz="830" i="1" dirty="0">
                 <a:solidFill>
                   <a:srgbClr val="64748B"/>
                 </a:solidFill>
@@ -7683,9 +7772,9 @@
                 <a:ea typeface="Microsoft YaHei" pitchFamily="34" charset="-122"/>
                 <a:cs typeface="Microsoft YaHei" pitchFamily="34" charset="-120"/>
               </a:rPr>
-              <a:t>指标统一：bench_loaders 把三数据集归一化为同一 schema(多选选项拼进问题)，judge准确率(主)/EM/F1/per-category 一套代码通吃；BM25+DeepSeek，16 并发。</a:t>
+              <a:t>指标统一：bench_loaders 归一化为同一 schema(多选拼进问题)，judge acc(主)/EM/F1/per-category 一套代码通吃；agent+judge 均 DeepSeek，16 并发；Mem0=并行无合并变体。详见下一页按类别表。</a:t>
             </a:r>
-            <a:endParaRPr lang="en-US" sz="850" dirty="0"/>
+            <a:endParaRPr lang="en-US" sz="830" dirty="0"/>
           </a:p>
         </p:txBody>
       </p:sp>
@@ -7884,7 +7973,4116 @@
                 <a:ea typeface="Microsoft YaHei" pitchFamily="34" charset="-122"/>
                 <a:cs typeface="Microsoft YaHei" pitchFamily="34" charset="-120"/>
               </a:rPr>
-              <a:t>12 / 12</a:t>
+              <a:t>12 / 13</a:t>
+            </a:r>
+            <a:endParaRPr lang="en-US" sz="800" dirty="0"/>
+          </a:p>
+        </p:txBody>
+      </p:sp>
+    </p:spTree>
+  </p:cSld>
+  <p:clrMapOvr>
+    <a:masterClrMapping/>
+  </p:clrMapOvr>
+</p:sld>
+</file>
+
+<file path=ppt/slides/slide13.xml><?xml version="1.0" encoding="utf-8"?>
+<p:sld xmlns:a="http://schemas.openxmlformats.org/drawingml/2006/main" xmlns:r="http://schemas.openxmlformats.org/officeDocument/2006/relationships" xmlns:p="http://schemas.openxmlformats.org/presentationml/2006/main">
+  <p:cSld name="Slide 13">
+    <p:bg>
+      <p:bgPr>
+        <a:solidFill>
+          <a:srgbClr val="FFFFFF"/>
+        </a:solidFill>
+      </p:bgPr>
+    </p:bg>
+    <p:spTree>
+      <p:nvGrpSpPr>
+        <p:cNvPr id="1" name=""/>
+        <p:cNvGrpSpPr/>
+        <p:nvPr/>
+      </p:nvGrpSpPr>
+      <p:grpSpPr>
+        <a:xfrm>
+          <a:off x="0" y="0"/>
+          <a:ext cx="0" cy="0"/>
+          <a:chOff x="0" y="0"/>
+          <a:chExt cx="0" cy="0"/>
+        </a:xfrm>
+      </p:grpSpPr>
+      <p:sp>
+        <p:nvSpPr>
+          <p:cNvPr id="2" name="Shape 0"/>
+          <p:cNvSpPr/>
+          <p:nvPr/>
+        </p:nvSpPr>
+        <p:spPr>
+          <a:xfrm>
+            <a:off x="457200" y="402336"/>
+            <a:ext cx="137160" cy="137160"/>
+          </a:xfrm>
+          <a:prstGeom prst="rect">
+            <a:avLst/>
+          </a:prstGeom>
+          <a:solidFill>
+            <a:srgbClr val="0E9F6E"/>
+          </a:solidFill>
+          <a:ln/>
+        </p:spPr>
+      </p:sp>
+      <p:sp>
+        <p:nvSpPr>
+          <p:cNvPr id="3" name="Text 1"/>
+          <p:cNvSpPr/>
+          <p:nvPr/>
+        </p:nvSpPr>
+        <p:spPr>
+          <a:xfrm>
+            <a:off x="685800" y="338328"/>
+            <a:ext cx="8001000" cy="274320"/>
+          </a:xfrm>
+          <a:prstGeom prst="rect">
+            <a:avLst/>
+          </a:prstGeom>
+          <a:noFill/>
+          <a:ln/>
+        </p:spPr>
+        <p:txBody>
+          <a:bodyPr wrap="square" lIns="0" tIns="0" rIns="0" bIns="0" rtlCol="0" anchor="ctr"/>
+          <a:lstStyle/>
+          <a:p>
+            <a:pPr indent="0" marL="0">
+              <a:buNone/>
+            </a:pPr>
+            <a:r>
+              <a:rPr lang="en-US" sz="1100" b="1" spc="100" kern="0" dirty="0">
+                <a:solidFill>
+                  <a:srgbClr val="0E9F6E"/>
+                </a:solidFill>
+                <a:latin typeface="Microsoft YaHei" pitchFamily="34" charset="0"/>
+                <a:ea typeface="Microsoft YaHei" pitchFamily="34" charset="-122"/>
+                <a:cs typeface="Microsoft YaHei" pitchFamily="34" charset="-120"/>
+              </a:rPr>
+              <a:t>P4 · 详细结果（SocialMemBench 1031 题）</a:t>
+            </a:r>
+            <a:endParaRPr lang="en-US" sz="1100" dirty="0"/>
+          </a:p>
+        </p:txBody>
+      </p:sp>
+      <p:sp>
+        <p:nvSpPr>
+          <p:cNvPr id="4" name="Text 2"/>
+          <p:cNvSpPr/>
+          <p:nvPr/>
+        </p:nvSpPr>
+        <p:spPr>
+          <a:xfrm>
+            <a:off x="457200" y="676656"/>
+            <a:ext cx="8229600" cy="566928"/>
+          </a:xfrm>
+          <a:prstGeom prst="rect">
+            <a:avLst/>
+          </a:prstGeom>
+          <a:noFill/>
+          <a:ln/>
+        </p:spPr>
+        <p:txBody>
+          <a:bodyPr wrap="square" lIns="0" tIns="0" rIns="0" bIns="0" rtlCol="0" anchor="ctr"/>
+          <a:lstStyle/>
+          <a:p>
+            <a:pPr indent="0" marL="0">
+              <a:buNone/>
+            </a:pPr>
+            <a:r>
+              <a:rPr lang="en-US" sz="2300" b="1" dirty="0">
+                <a:solidFill>
+                  <a:srgbClr val="1E293B"/>
+                </a:solidFill>
+                <a:latin typeface="Microsoft YaHei" pitchFamily="34" charset="0"/>
+                <a:ea typeface="Microsoft YaHei" pitchFamily="34" charset="-122"/>
+                <a:cs typeface="Microsoft YaHei" pitchFamily="34" charset="-120"/>
+              </a:rPr>
+              <a:t>按 9 类拆：BM25 几乎全面压过 Mem0</a:t>
+            </a:r>
+            <a:endParaRPr lang="en-US" sz="2300" dirty="0"/>
+          </a:p>
+        </p:txBody>
+      </p:sp>
+      <p:graphicFrame>
+        <p:nvGraphicFramePr>
+          <p:cNvPr id="14" name="Table 0"/>
+          <p:cNvGraphicFramePr>
+            <a:graphicFrameLocks noGrp="1"/>
+          </p:cNvGraphicFramePr>
+          <p:nvPr>
+            <p:extLst>
+              <p:ext uri="{D42A27DB-BD31-4B8C-83A1-F6EECF244321}">
+                <p14:modId xmlns:p14="http://schemas.microsoft.com/office/powerpoint/2010/main" val="1579011935"/>
+              </p:ext>
+            </p:extLst>
+          </p:nvPr>
+        </p:nvGraphicFramePr>
+        <p:xfrm>
+          <a:off x="457200" y="1371600"/>
+          <a:ext cx="8229600" cy="914400"/>
+        </p:xfrm>
+        <a:graphic>
+          <a:graphicData uri="http://schemas.openxmlformats.org/drawingml/2006/table">
+            <a:tbl>
+              <a:tblPr/>
+              <a:tblGrid>
+                <a:gridCol w="2194560"/>
+                <a:gridCol w="1508760"/>
+                <a:gridCol w="1508760"/>
+                <a:gridCol w="1508760"/>
+                <a:gridCol w="1508760"/>
+              </a:tblGrid>
+              <a:tr h="274320">
+                <a:tc>
+                  <a:txBody>
+                    <a:bodyPr/>
+                    <a:lstStyle/>
+                    <a:p>
+                      <a:pPr algn="l" indent="0" marL="0">
+                        <a:buNone/>
+                      </a:pPr>
+                      <a:r>
+                        <a:rPr lang="en-US" sz="950" b="1" dirty="0">
+                          <a:solidFill>
+                            <a:srgbClr val="FFFFFF"/>
+                          </a:solidFill>
+                          <a:latin typeface="Microsoft YaHei" pitchFamily="34" charset="0"/>
+                          <a:ea typeface="Microsoft YaHei" pitchFamily="34" charset="-122"/>
+                          <a:cs typeface="Microsoft YaHei" pitchFamily="34" charset="-120"/>
+                        </a:rPr>
+                        <a:t>类别(Q1–Q9)</a:t>
+                      </a:r>
+                      <a:endParaRPr lang="en-US" sz="950" dirty="0">
+                        <a:latin typeface="Microsoft YaHei" charset="0"/>
+                        <a:ea typeface="Microsoft YaHei" charset="0"/>
+                        <a:cs typeface="Microsoft YaHei" charset="0"/>
+                      </a:endParaRPr>
+                    </a:p>
+                  </a:txBody>
+                  <a:tcPr marL="50800" marR="50800" marT="12700" marB="12700" anchor="ctr">
+                    <a:lnL w="6350" cap="flat" cmpd="sng" algn="ctr">
+                      <a:solidFill>
+                        <a:srgbClr val="E2E8F0"/>
+                      </a:solidFill>
+                      <a:prstDash val="solid"/>
+                      <a:round/>
+                      <a:headEnd type="none" w="med" len="med"/>
+                      <a:tailEnd type="none" w="med" len="med"/>
+                    </a:lnL>
+                    <a:lnR w="6350" cap="flat" cmpd="sng" algn="ctr">
+                      <a:solidFill>
+                        <a:srgbClr val="E2E8F0"/>
+                      </a:solidFill>
+                      <a:prstDash val="solid"/>
+                      <a:round/>
+                      <a:headEnd type="none" w="med" len="med"/>
+                      <a:tailEnd type="none" w="med" len="med"/>
+                    </a:lnR>
+                    <a:lnT w="6350" cap="flat" cmpd="sng" algn="ctr">
+                      <a:solidFill>
+                        <a:srgbClr val="E2E8F0"/>
+                      </a:solidFill>
+                      <a:prstDash val="solid"/>
+                      <a:round/>
+                      <a:headEnd type="none" w="med" len="med"/>
+                      <a:tailEnd type="none" w="med" len="med"/>
+                    </a:lnT>
+                    <a:lnB w="6350" cap="flat" cmpd="sng" algn="ctr">
+                      <a:solidFill>
+                        <a:srgbClr val="E2E8F0"/>
+                      </a:solidFill>
+                      <a:prstDash val="solid"/>
+                      <a:round/>
+                      <a:headEnd type="none" w="med" len="med"/>
+                      <a:tailEnd type="none" w="med" len="med"/>
+                    </a:lnB>
+                    <a:solidFill>
+                      <a:srgbClr val="12183A"/>
+                    </a:solidFill>
+                  </a:tcPr>
+                </a:tc>
+                <a:tc>
+                  <a:txBody>
+                    <a:bodyPr/>
+                    <a:lstStyle/>
+                    <a:p>
+                      <a:pPr algn="l" indent="0" marL="0">
+                        <a:buNone/>
+                      </a:pPr>
+                      <a:r>
+                        <a:rPr lang="en-US" sz="950" b="1" dirty="0">
+                          <a:solidFill>
+                            <a:srgbClr val="FFFFFF"/>
+                          </a:solidFill>
+                          <a:latin typeface="Microsoft YaHei" pitchFamily="34" charset="0"/>
+                          <a:ea typeface="Microsoft YaHei" pitchFamily="34" charset="-122"/>
+                          <a:cs typeface="Microsoft YaHei" pitchFamily="34" charset="-120"/>
+                        </a:rPr>
+                        <a:t>BM25 acc</a:t>
+                      </a:r>
+                      <a:endParaRPr lang="en-US" sz="950" dirty="0">
+                        <a:latin typeface="Microsoft YaHei" charset="0"/>
+                        <a:ea typeface="Microsoft YaHei" charset="0"/>
+                        <a:cs typeface="Microsoft YaHei" charset="0"/>
+                      </a:endParaRPr>
+                    </a:p>
+                  </a:txBody>
+                  <a:tcPr marL="50800" marR="50800" marT="12700" marB="12700" anchor="ctr">
+                    <a:lnL w="6350" cap="flat" cmpd="sng" algn="ctr">
+                      <a:solidFill>
+                        <a:srgbClr val="E2E8F0"/>
+                      </a:solidFill>
+                      <a:prstDash val="solid"/>
+                      <a:round/>
+                      <a:headEnd type="none" w="med" len="med"/>
+                      <a:tailEnd type="none" w="med" len="med"/>
+                    </a:lnL>
+                    <a:lnR w="6350" cap="flat" cmpd="sng" algn="ctr">
+                      <a:solidFill>
+                        <a:srgbClr val="E2E8F0"/>
+                      </a:solidFill>
+                      <a:prstDash val="solid"/>
+                      <a:round/>
+                      <a:headEnd type="none" w="med" len="med"/>
+                      <a:tailEnd type="none" w="med" len="med"/>
+                    </a:lnR>
+                    <a:lnT w="6350" cap="flat" cmpd="sng" algn="ctr">
+                      <a:solidFill>
+                        <a:srgbClr val="E2E8F0"/>
+                      </a:solidFill>
+                      <a:prstDash val="solid"/>
+                      <a:round/>
+                      <a:headEnd type="none" w="med" len="med"/>
+                      <a:tailEnd type="none" w="med" len="med"/>
+                    </a:lnT>
+                    <a:lnB w="6350" cap="flat" cmpd="sng" algn="ctr">
+                      <a:solidFill>
+                        <a:srgbClr val="E2E8F0"/>
+                      </a:solidFill>
+                      <a:prstDash val="solid"/>
+                      <a:round/>
+                      <a:headEnd type="none" w="med" len="med"/>
+                      <a:tailEnd type="none" w="med" len="med"/>
+                    </a:lnB>
+                    <a:solidFill>
+                      <a:srgbClr val="12183A"/>
+                    </a:solidFill>
+                  </a:tcPr>
+                </a:tc>
+                <a:tc>
+                  <a:txBody>
+                    <a:bodyPr/>
+                    <a:lstStyle/>
+                    <a:p>
+                      <a:pPr algn="l" indent="0" marL="0">
+                        <a:buNone/>
+                      </a:pPr>
+                      <a:r>
+                        <a:rPr lang="en-US" sz="950" b="1" dirty="0">
+                          <a:solidFill>
+                            <a:srgbClr val="FFFFFF"/>
+                          </a:solidFill>
+                          <a:latin typeface="Microsoft YaHei" pitchFamily="34" charset="0"/>
+                          <a:ea typeface="Microsoft YaHei" pitchFamily="34" charset="-122"/>
+                          <a:cs typeface="Microsoft YaHei" pitchFamily="34" charset="-120"/>
+                        </a:rPr>
+                        <a:t>Mem0 acc</a:t>
+                      </a:r>
+                      <a:endParaRPr lang="en-US" sz="950" dirty="0">
+                        <a:latin typeface="Microsoft YaHei" charset="0"/>
+                        <a:ea typeface="Microsoft YaHei" charset="0"/>
+                        <a:cs typeface="Microsoft YaHei" charset="0"/>
+                      </a:endParaRPr>
+                    </a:p>
+                  </a:txBody>
+                  <a:tcPr marL="50800" marR="50800" marT="12700" marB="12700" anchor="ctr">
+                    <a:lnL w="6350" cap="flat" cmpd="sng" algn="ctr">
+                      <a:solidFill>
+                        <a:srgbClr val="E2E8F0"/>
+                      </a:solidFill>
+                      <a:prstDash val="solid"/>
+                      <a:round/>
+                      <a:headEnd type="none" w="med" len="med"/>
+                      <a:tailEnd type="none" w="med" len="med"/>
+                    </a:lnL>
+                    <a:lnR w="6350" cap="flat" cmpd="sng" algn="ctr">
+                      <a:solidFill>
+                        <a:srgbClr val="E2E8F0"/>
+                      </a:solidFill>
+                      <a:prstDash val="solid"/>
+                      <a:round/>
+                      <a:headEnd type="none" w="med" len="med"/>
+                      <a:tailEnd type="none" w="med" len="med"/>
+                    </a:lnR>
+                    <a:lnT w="6350" cap="flat" cmpd="sng" algn="ctr">
+                      <a:solidFill>
+                        <a:srgbClr val="E2E8F0"/>
+                      </a:solidFill>
+                      <a:prstDash val="solid"/>
+                      <a:round/>
+                      <a:headEnd type="none" w="med" len="med"/>
+                      <a:tailEnd type="none" w="med" len="med"/>
+                    </a:lnT>
+                    <a:lnB w="6350" cap="flat" cmpd="sng" algn="ctr">
+                      <a:solidFill>
+                        <a:srgbClr val="E2E8F0"/>
+                      </a:solidFill>
+                      <a:prstDash val="solid"/>
+                      <a:round/>
+                      <a:headEnd type="none" w="med" len="med"/>
+                      <a:tailEnd type="none" w="med" len="med"/>
+                    </a:lnB>
+                    <a:solidFill>
+                      <a:srgbClr val="12183A"/>
+                    </a:solidFill>
+                  </a:tcPr>
+                </a:tc>
+                <a:tc>
+                  <a:txBody>
+                    <a:bodyPr/>
+                    <a:lstStyle/>
+                    <a:p>
+                      <a:pPr algn="l" indent="0" marL="0">
+                        <a:buNone/>
+                      </a:pPr>
+                      <a:r>
+                        <a:rPr lang="en-US" sz="950" b="1" dirty="0">
+                          <a:solidFill>
+                            <a:srgbClr val="FFFFFF"/>
+                          </a:solidFill>
+                          <a:latin typeface="Microsoft YaHei" pitchFamily="34" charset="0"/>
+                          <a:ea typeface="Microsoft YaHei" pitchFamily="34" charset="-122"/>
+                          <a:cs typeface="Microsoft YaHei" pitchFamily="34" charset="-120"/>
+                        </a:rPr>
+                        <a:t>BM25 F1</a:t>
+                      </a:r>
+                      <a:endParaRPr lang="en-US" sz="950" dirty="0">
+                        <a:latin typeface="Microsoft YaHei" charset="0"/>
+                        <a:ea typeface="Microsoft YaHei" charset="0"/>
+                        <a:cs typeface="Microsoft YaHei" charset="0"/>
+                      </a:endParaRPr>
+                    </a:p>
+                  </a:txBody>
+                  <a:tcPr marL="50800" marR="50800" marT="12700" marB="12700" anchor="ctr">
+                    <a:lnL w="6350" cap="flat" cmpd="sng" algn="ctr">
+                      <a:solidFill>
+                        <a:srgbClr val="E2E8F0"/>
+                      </a:solidFill>
+                      <a:prstDash val="solid"/>
+                      <a:round/>
+                      <a:headEnd type="none" w="med" len="med"/>
+                      <a:tailEnd type="none" w="med" len="med"/>
+                    </a:lnL>
+                    <a:lnR w="6350" cap="flat" cmpd="sng" algn="ctr">
+                      <a:solidFill>
+                        <a:srgbClr val="E2E8F0"/>
+                      </a:solidFill>
+                      <a:prstDash val="solid"/>
+                      <a:round/>
+                      <a:headEnd type="none" w="med" len="med"/>
+                      <a:tailEnd type="none" w="med" len="med"/>
+                    </a:lnR>
+                    <a:lnT w="6350" cap="flat" cmpd="sng" algn="ctr">
+                      <a:solidFill>
+                        <a:srgbClr val="E2E8F0"/>
+                      </a:solidFill>
+                      <a:prstDash val="solid"/>
+                      <a:round/>
+                      <a:headEnd type="none" w="med" len="med"/>
+                      <a:tailEnd type="none" w="med" len="med"/>
+                    </a:lnT>
+                    <a:lnB w="6350" cap="flat" cmpd="sng" algn="ctr">
+                      <a:solidFill>
+                        <a:srgbClr val="E2E8F0"/>
+                      </a:solidFill>
+                      <a:prstDash val="solid"/>
+                      <a:round/>
+                      <a:headEnd type="none" w="med" len="med"/>
+                      <a:tailEnd type="none" w="med" len="med"/>
+                    </a:lnB>
+                    <a:solidFill>
+                      <a:srgbClr val="12183A"/>
+                    </a:solidFill>
+                  </a:tcPr>
+                </a:tc>
+                <a:tc>
+                  <a:txBody>
+                    <a:bodyPr/>
+                    <a:lstStyle/>
+                    <a:p>
+                      <a:pPr algn="l" indent="0" marL="0">
+                        <a:buNone/>
+                      </a:pPr>
+                      <a:r>
+                        <a:rPr lang="en-US" sz="950" b="1" dirty="0">
+                          <a:solidFill>
+                            <a:srgbClr val="FFFFFF"/>
+                          </a:solidFill>
+                          <a:latin typeface="Microsoft YaHei" pitchFamily="34" charset="0"/>
+                          <a:ea typeface="Microsoft YaHei" pitchFamily="34" charset="-122"/>
+                          <a:cs typeface="Microsoft YaHei" pitchFamily="34" charset="-120"/>
+                        </a:rPr>
+                        <a:t>Mem0 F1</a:t>
+                      </a:r>
+                      <a:endParaRPr lang="en-US" sz="950" dirty="0">
+                        <a:latin typeface="Microsoft YaHei" charset="0"/>
+                        <a:ea typeface="Microsoft YaHei" charset="0"/>
+                        <a:cs typeface="Microsoft YaHei" charset="0"/>
+                      </a:endParaRPr>
+                    </a:p>
+                  </a:txBody>
+                  <a:tcPr marL="50800" marR="50800" marT="12700" marB="12700" anchor="ctr">
+                    <a:lnL w="6350" cap="flat" cmpd="sng" algn="ctr">
+                      <a:solidFill>
+                        <a:srgbClr val="E2E8F0"/>
+                      </a:solidFill>
+                      <a:prstDash val="solid"/>
+                      <a:round/>
+                      <a:headEnd type="none" w="med" len="med"/>
+                      <a:tailEnd type="none" w="med" len="med"/>
+                    </a:lnL>
+                    <a:lnR w="6350" cap="flat" cmpd="sng" algn="ctr">
+                      <a:solidFill>
+                        <a:srgbClr val="E2E8F0"/>
+                      </a:solidFill>
+                      <a:prstDash val="solid"/>
+                      <a:round/>
+                      <a:headEnd type="none" w="med" len="med"/>
+                      <a:tailEnd type="none" w="med" len="med"/>
+                    </a:lnR>
+                    <a:lnT w="6350" cap="flat" cmpd="sng" algn="ctr">
+                      <a:solidFill>
+                        <a:srgbClr val="E2E8F0"/>
+                      </a:solidFill>
+                      <a:prstDash val="solid"/>
+                      <a:round/>
+                      <a:headEnd type="none" w="med" len="med"/>
+                      <a:tailEnd type="none" w="med" len="med"/>
+                    </a:lnT>
+                    <a:lnB w="6350" cap="flat" cmpd="sng" algn="ctr">
+                      <a:solidFill>
+                        <a:srgbClr val="E2E8F0"/>
+                      </a:solidFill>
+                      <a:prstDash val="solid"/>
+                      <a:round/>
+                      <a:headEnd type="none" w="med" len="med"/>
+                      <a:tailEnd type="none" w="med" len="med"/>
+                    </a:lnB>
+                    <a:solidFill>
+                      <a:srgbClr val="12183A"/>
+                    </a:solidFill>
+                  </a:tcPr>
+                </a:tc>
+              </a:tr>
+              <a:tr h="274320">
+                <a:tc>
+                  <a:txBody>
+                    <a:bodyPr/>
+                    <a:lstStyle/>
+                    <a:p>
+                      <a:pPr algn="l" indent="0" marL="0">
+                        <a:buNone/>
+                      </a:pPr>
+                      <a:r>
+                        <a:rPr lang="en-US" sz="840" b="1" dirty="0">
+                          <a:solidFill>
+                            <a:srgbClr val="1E293B"/>
+                          </a:solidFill>
+                          <a:latin typeface="Microsoft YaHei" pitchFamily="34" charset="0"/>
+                          <a:ea typeface="Microsoft YaHei" pitchFamily="34" charset="-122"/>
+                          <a:cs typeface="Microsoft YaHei" pitchFamily="34" charset="-120"/>
+                        </a:rPr>
+                        <a:t>Q1 单人召回</a:t>
+                      </a:r>
+                      <a:endParaRPr lang="en-US" sz="840" dirty="0">
+                        <a:latin typeface="Microsoft YaHei" charset="0"/>
+                        <a:ea typeface="Microsoft YaHei" charset="0"/>
+                        <a:cs typeface="Microsoft YaHei" charset="0"/>
+                      </a:endParaRPr>
+                    </a:p>
+                  </a:txBody>
+                  <a:tcPr marL="50800" marR="50800" marT="12700" marB="12700" anchor="ctr">
+                    <a:lnL w="6350" cap="flat" cmpd="sng" algn="ctr">
+                      <a:solidFill>
+                        <a:srgbClr val="E2E8F0"/>
+                      </a:solidFill>
+                      <a:prstDash val="solid"/>
+                      <a:round/>
+                      <a:headEnd type="none" w="med" len="med"/>
+                      <a:tailEnd type="none" w="med" len="med"/>
+                    </a:lnL>
+                    <a:lnR w="6350" cap="flat" cmpd="sng" algn="ctr">
+                      <a:solidFill>
+                        <a:srgbClr val="E2E8F0"/>
+                      </a:solidFill>
+                      <a:prstDash val="solid"/>
+                      <a:round/>
+                      <a:headEnd type="none" w="med" len="med"/>
+                      <a:tailEnd type="none" w="med" len="med"/>
+                    </a:lnR>
+                    <a:lnT w="6350" cap="flat" cmpd="sng" algn="ctr">
+                      <a:solidFill>
+                        <a:srgbClr val="E2E8F0"/>
+                      </a:solidFill>
+                      <a:prstDash val="solid"/>
+                      <a:round/>
+                      <a:headEnd type="none" w="med" len="med"/>
+                      <a:tailEnd type="none" w="med" len="med"/>
+                    </a:lnT>
+                    <a:lnB w="6350" cap="flat" cmpd="sng" algn="ctr">
+                      <a:solidFill>
+                        <a:srgbClr val="E2E8F0"/>
+                      </a:solidFill>
+                      <a:prstDash val="solid"/>
+                      <a:round/>
+                      <a:headEnd type="none" w="med" len="med"/>
+                      <a:tailEnd type="none" w="med" len="med"/>
+                    </a:lnB>
+                    <a:solidFill>
+                      <a:srgbClr val="FFFFFF"/>
+                    </a:solidFill>
+                  </a:tcPr>
+                </a:tc>
+                <a:tc>
+                  <a:txBody>
+                    <a:bodyPr/>
+                    <a:lstStyle/>
+                    <a:p>
+                      <a:pPr algn="ctr" indent="0" marL="0">
+                        <a:buNone/>
+                      </a:pPr>
+                      <a:r>
+                        <a:rPr lang="en-US" sz="840" b="1" dirty="0">
+                          <a:solidFill>
+                            <a:srgbClr val="0E7490"/>
+                          </a:solidFill>
+                          <a:latin typeface="Microsoft YaHei" pitchFamily="34" charset="0"/>
+                          <a:ea typeface="Microsoft YaHei" pitchFamily="34" charset="-122"/>
+                          <a:cs typeface="Microsoft YaHei" pitchFamily="34" charset="-120"/>
+                        </a:rPr>
+                        <a:t>25.3%</a:t>
+                      </a:r>
+                      <a:endParaRPr lang="en-US" sz="840" dirty="0">
+                        <a:latin typeface="Microsoft YaHei" charset="0"/>
+                        <a:ea typeface="Microsoft YaHei" charset="0"/>
+                        <a:cs typeface="Microsoft YaHei" charset="0"/>
+                      </a:endParaRPr>
+                    </a:p>
+                  </a:txBody>
+                  <a:tcPr marL="50800" marR="50800" marT="12700" marB="12700" anchor="ctr">
+                    <a:lnL w="6350" cap="flat" cmpd="sng" algn="ctr">
+                      <a:solidFill>
+                        <a:srgbClr val="E2E8F0"/>
+                      </a:solidFill>
+                      <a:prstDash val="solid"/>
+                      <a:round/>
+                      <a:headEnd type="none" w="med" len="med"/>
+                      <a:tailEnd type="none" w="med" len="med"/>
+                    </a:lnL>
+                    <a:lnR w="6350" cap="flat" cmpd="sng" algn="ctr">
+                      <a:solidFill>
+                        <a:srgbClr val="E2E8F0"/>
+                      </a:solidFill>
+                      <a:prstDash val="solid"/>
+                      <a:round/>
+                      <a:headEnd type="none" w="med" len="med"/>
+                      <a:tailEnd type="none" w="med" len="med"/>
+                    </a:lnR>
+                    <a:lnT w="6350" cap="flat" cmpd="sng" algn="ctr">
+                      <a:solidFill>
+                        <a:srgbClr val="E2E8F0"/>
+                      </a:solidFill>
+                      <a:prstDash val="solid"/>
+                      <a:round/>
+                      <a:headEnd type="none" w="med" len="med"/>
+                      <a:tailEnd type="none" w="med" len="med"/>
+                    </a:lnT>
+                    <a:lnB w="6350" cap="flat" cmpd="sng" algn="ctr">
+                      <a:solidFill>
+                        <a:srgbClr val="E2E8F0"/>
+                      </a:solidFill>
+                      <a:prstDash val="solid"/>
+                      <a:round/>
+                      <a:headEnd type="none" w="med" len="med"/>
+                      <a:tailEnd type="none" w="med" len="med"/>
+                    </a:lnB>
+                    <a:solidFill>
+                      <a:srgbClr val="FFFFFF"/>
+                    </a:solidFill>
+                  </a:tcPr>
+                </a:tc>
+                <a:tc>
+                  <a:txBody>
+                    <a:bodyPr/>
+                    <a:lstStyle/>
+                    <a:p>
+                      <a:pPr algn="ctr" indent="0" marL="0">
+                        <a:buNone/>
+                      </a:pPr>
+                      <a:r>
+                        <a:rPr lang="en-US" sz="840" dirty="0">
+                          <a:solidFill>
+                            <a:srgbClr val="B45309"/>
+                          </a:solidFill>
+                          <a:latin typeface="Microsoft YaHei" pitchFamily="34" charset="0"/>
+                          <a:ea typeface="Microsoft YaHei" pitchFamily="34" charset="-122"/>
+                          <a:cs typeface="Microsoft YaHei" pitchFamily="34" charset="-120"/>
+                        </a:rPr>
+                        <a:t>20.9%</a:t>
+                      </a:r>
+                      <a:endParaRPr lang="en-US" sz="840" dirty="0">
+                        <a:latin typeface="Microsoft YaHei" charset="0"/>
+                        <a:ea typeface="Microsoft YaHei" charset="0"/>
+                        <a:cs typeface="Microsoft YaHei" charset="0"/>
+                      </a:endParaRPr>
+                    </a:p>
+                  </a:txBody>
+                  <a:tcPr marL="50800" marR="50800" marT="12700" marB="12700" anchor="ctr">
+                    <a:lnL w="6350" cap="flat" cmpd="sng" algn="ctr">
+                      <a:solidFill>
+                        <a:srgbClr val="E2E8F0"/>
+                      </a:solidFill>
+                      <a:prstDash val="solid"/>
+                      <a:round/>
+                      <a:headEnd type="none" w="med" len="med"/>
+                      <a:tailEnd type="none" w="med" len="med"/>
+                    </a:lnL>
+                    <a:lnR w="6350" cap="flat" cmpd="sng" algn="ctr">
+                      <a:solidFill>
+                        <a:srgbClr val="E2E8F0"/>
+                      </a:solidFill>
+                      <a:prstDash val="solid"/>
+                      <a:round/>
+                      <a:headEnd type="none" w="med" len="med"/>
+                      <a:tailEnd type="none" w="med" len="med"/>
+                    </a:lnR>
+                    <a:lnT w="6350" cap="flat" cmpd="sng" algn="ctr">
+                      <a:solidFill>
+                        <a:srgbClr val="E2E8F0"/>
+                      </a:solidFill>
+                      <a:prstDash val="solid"/>
+                      <a:round/>
+                      <a:headEnd type="none" w="med" len="med"/>
+                      <a:tailEnd type="none" w="med" len="med"/>
+                    </a:lnT>
+                    <a:lnB w="6350" cap="flat" cmpd="sng" algn="ctr">
+                      <a:solidFill>
+                        <a:srgbClr val="E2E8F0"/>
+                      </a:solidFill>
+                      <a:prstDash val="solid"/>
+                      <a:round/>
+                      <a:headEnd type="none" w="med" len="med"/>
+                      <a:tailEnd type="none" w="med" len="med"/>
+                    </a:lnB>
+                    <a:solidFill>
+                      <a:srgbClr val="FFFFFF"/>
+                    </a:solidFill>
+                  </a:tcPr>
+                </a:tc>
+                <a:tc>
+                  <a:txBody>
+                    <a:bodyPr/>
+                    <a:lstStyle/>
+                    <a:p>
+                      <a:pPr algn="ctr" indent="0" marL="0">
+                        <a:buNone/>
+                      </a:pPr>
+                      <a:r>
+                        <a:rPr lang="en-US" sz="840" dirty="0">
+                          <a:solidFill>
+                            <a:srgbClr val="334155"/>
+                          </a:solidFill>
+                          <a:latin typeface="Microsoft YaHei" pitchFamily="34" charset="0"/>
+                          <a:ea typeface="Microsoft YaHei" pitchFamily="34" charset="-122"/>
+                          <a:cs typeface="Microsoft YaHei" pitchFamily="34" charset="-120"/>
+                        </a:rPr>
+                        <a:t>13.8</a:t>
+                      </a:r>
+                      <a:endParaRPr lang="en-US" sz="840" dirty="0">
+                        <a:latin typeface="Microsoft YaHei" charset="0"/>
+                        <a:ea typeface="Microsoft YaHei" charset="0"/>
+                        <a:cs typeface="Microsoft YaHei" charset="0"/>
+                      </a:endParaRPr>
+                    </a:p>
+                  </a:txBody>
+                  <a:tcPr marL="50800" marR="50800" marT="12700" marB="12700" anchor="ctr">
+                    <a:lnL w="6350" cap="flat" cmpd="sng" algn="ctr">
+                      <a:solidFill>
+                        <a:srgbClr val="E2E8F0"/>
+                      </a:solidFill>
+                      <a:prstDash val="solid"/>
+                      <a:round/>
+                      <a:headEnd type="none" w="med" len="med"/>
+                      <a:tailEnd type="none" w="med" len="med"/>
+                    </a:lnL>
+                    <a:lnR w="6350" cap="flat" cmpd="sng" algn="ctr">
+                      <a:solidFill>
+                        <a:srgbClr val="E2E8F0"/>
+                      </a:solidFill>
+                      <a:prstDash val="solid"/>
+                      <a:round/>
+                      <a:headEnd type="none" w="med" len="med"/>
+                      <a:tailEnd type="none" w="med" len="med"/>
+                    </a:lnR>
+                    <a:lnT w="6350" cap="flat" cmpd="sng" algn="ctr">
+                      <a:solidFill>
+                        <a:srgbClr val="E2E8F0"/>
+                      </a:solidFill>
+                      <a:prstDash val="solid"/>
+                      <a:round/>
+                      <a:headEnd type="none" w="med" len="med"/>
+                      <a:tailEnd type="none" w="med" len="med"/>
+                    </a:lnT>
+                    <a:lnB w="6350" cap="flat" cmpd="sng" algn="ctr">
+                      <a:solidFill>
+                        <a:srgbClr val="E2E8F0"/>
+                      </a:solidFill>
+                      <a:prstDash val="solid"/>
+                      <a:round/>
+                      <a:headEnd type="none" w="med" len="med"/>
+                      <a:tailEnd type="none" w="med" len="med"/>
+                    </a:lnB>
+                    <a:solidFill>
+                      <a:srgbClr val="FFFFFF"/>
+                    </a:solidFill>
+                  </a:tcPr>
+                </a:tc>
+                <a:tc>
+                  <a:txBody>
+                    <a:bodyPr/>
+                    <a:lstStyle/>
+                    <a:p>
+                      <a:pPr algn="ctr" indent="0" marL="0">
+                        <a:buNone/>
+                      </a:pPr>
+                      <a:r>
+                        <a:rPr lang="en-US" sz="840" dirty="0">
+                          <a:solidFill>
+                            <a:srgbClr val="334155"/>
+                          </a:solidFill>
+                          <a:latin typeface="Microsoft YaHei" pitchFamily="34" charset="0"/>
+                          <a:ea typeface="Microsoft YaHei" pitchFamily="34" charset="-122"/>
+                          <a:cs typeface="Microsoft YaHei" pitchFamily="34" charset="-120"/>
+                        </a:rPr>
+                        <a:t>12.0</a:t>
+                      </a:r>
+                      <a:endParaRPr lang="en-US" sz="840" dirty="0">
+                        <a:latin typeface="Microsoft YaHei" charset="0"/>
+                        <a:ea typeface="Microsoft YaHei" charset="0"/>
+                        <a:cs typeface="Microsoft YaHei" charset="0"/>
+                      </a:endParaRPr>
+                    </a:p>
+                  </a:txBody>
+                  <a:tcPr marL="50800" marR="50800" marT="12700" marB="12700" anchor="ctr">
+                    <a:lnL w="6350" cap="flat" cmpd="sng" algn="ctr">
+                      <a:solidFill>
+                        <a:srgbClr val="E2E8F0"/>
+                      </a:solidFill>
+                      <a:prstDash val="solid"/>
+                      <a:round/>
+                      <a:headEnd type="none" w="med" len="med"/>
+                      <a:tailEnd type="none" w="med" len="med"/>
+                    </a:lnL>
+                    <a:lnR w="6350" cap="flat" cmpd="sng" algn="ctr">
+                      <a:solidFill>
+                        <a:srgbClr val="E2E8F0"/>
+                      </a:solidFill>
+                      <a:prstDash val="solid"/>
+                      <a:round/>
+                      <a:headEnd type="none" w="med" len="med"/>
+                      <a:tailEnd type="none" w="med" len="med"/>
+                    </a:lnR>
+                    <a:lnT w="6350" cap="flat" cmpd="sng" algn="ctr">
+                      <a:solidFill>
+                        <a:srgbClr val="E2E8F0"/>
+                      </a:solidFill>
+                      <a:prstDash val="solid"/>
+                      <a:round/>
+                      <a:headEnd type="none" w="med" len="med"/>
+                      <a:tailEnd type="none" w="med" len="med"/>
+                    </a:lnT>
+                    <a:lnB w="6350" cap="flat" cmpd="sng" algn="ctr">
+                      <a:solidFill>
+                        <a:srgbClr val="E2E8F0"/>
+                      </a:solidFill>
+                      <a:prstDash val="solid"/>
+                      <a:round/>
+                      <a:headEnd type="none" w="med" len="med"/>
+                      <a:tailEnd type="none" w="med" len="med"/>
+                    </a:lnB>
+                    <a:solidFill>
+                      <a:srgbClr val="FFFFFF"/>
+                    </a:solidFill>
+                  </a:tcPr>
+                </a:tc>
+              </a:tr>
+              <a:tr h="274320">
+                <a:tc>
+                  <a:txBody>
+                    <a:bodyPr/>
+                    <a:lstStyle/>
+                    <a:p>
+                      <a:pPr algn="l" indent="0" marL="0">
+                        <a:buNone/>
+                      </a:pPr>
+                      <a:r>
+                        <a:rPr lang="en-US" sz="840" b="1" dirty="0">
+                          <a:solidFill>
+                            <a:srgbClr val="1E293B"/>
+                          </a:solidFill>
+                          <a:latin typeface="Microsoft YaHei" pitchFamily="34" charset="0"/>
+                          <a:ea typeface="Microsoft YaHei" pitchFamily="34" charset="-122"/>
+                          <a:cs typeface="Microsoft YaHei" pitchFamily="34" charset="-120"/>
+                        </a:rPr>
+                        <a:t>Q2 群体决策</a:t>
+                      </a:r>
+                      <a:endParaRPr lang="en-US" sz="840" dirty="0">
+                        <a:latin typeface="Microsoft YaHei" charset="0"/>
+                        <a:ea typeface="Microsoft YaHei" charset="0"/>
+                        <a:cs typeface="Microsoft YaHei" charset="0"/>
+                      </a:endParaRPr>
+                    </a:p>
+                  </a:txBody>
+                  <a:tcPr marL="50800" marR="50800" marT="12700" marB="12700" anchor="ctr">
+                    <a:lnL w="6350" cap="flat" cmpd="sng" algn="ctr">
+                      <a:solidFill>
+                        <a:srgbClr val="E2E8F0"/>
+                      </a:solidFill>
+                      <a:prstDash val="solid"/>
+                      <a:round/>
+                      <a:headEnd type="none" w="med" len="med"/>
+                      <a:tailEnd type="none" w="med" len="med"/>
+                    </a:lnL>
+                    <a:lnR w="6350" cap="flat" cmpd="sng" algn="ctr">
+                      <a:solidFill>
+                        <a:srgbClr val="E2E8F0"/>
+                      </a:solidFill>
+                      <a:prstDash val="solid"/>
+                      <a:round/>
+                      <a:headEnd type="none" w="med" len="med"/>
+                      <a:tailEnd type="none" w="med" len="med"/>
+                    </a:lnR>
+                    <a:lnT w="6350" cap="flat" cmpd="sng" algn="ctr">
+                      <a:solidFill>
+                        <a:srgbClr val="E2E8F0"/>
+                      </a:solidFill>
+                      <a:prstDash val="solid"/>
+                      <a:round/>
+                      <a:headEnd type="none" w="med" len="med"/>
+                      <a:tailEnd type="none" w="med" len="med"/>
+                    </a:lnT>
+                    <a:lnB w="6350" cap="flat" cmpd="sng" algn="ctr">
+                      <a:solidFill>
+                        <a:srgbClr val="E2E8F0"/>
+                      </a:solidFill>
+                      <a:prstDash val="solid"/>
+                      <a:round/>
+                      <a:headEnd type="none" w="med" len="med"/>
+                      <a:tailEnd type="none" w="med" len="med"/>
+                    </a:lnB>
+                    <a:solidFill>
+                      <a:srgbClr val="F8FAFC"/>
+                    </a:solidFill>
+                  </a:tcPr>
+                </a:tc>
+                <a:tc>
+                  <a:txBody>
+                    <a:bodyPr/>
+                    <a:lstStyle/>
+                    <a:p>
+                      <a:pPr algn="ctr" indent="0" marL="0">
+                        <a:buNone/>
+                      </a:pPr>
+                      <a:r>
+                        <a:rPr lang="en-US" sz="840" b="1" dirty="0">
+                          <a:solidFill>
+                            <a:srgbClr val="0E7490"/>
+                          </a:solidFill>
+                          <a:latin typeface="Microsoft YaHei" pitchFamily="34" charset="0"/>
+                          <a:ea typeface="Microsoft YaHei" pitchFamily="34" charset="-122"/>
+                          <a:cs typeface="Microsoft YaHei" pitchFamily="34" charset="-120"/>
+                        </a:rPr>
+                        <a:t>24.7%</a:t>
+                      </a:r>
+                      <a:endParaRPr lang="en-US" sz="840" dirty="0">
+                        <a:latin typeface="Microsoft YaHei" charset="0"/>
+                        <a:ea typeface="Microsoft YaHei" charset="0"/>
+                        <a:cs typeface="Microsoft YaHei" charset="0"/>
+                      </a:endParaRPr>
+                    </a:p>
+                  </a:txBody>
+                  <a:tcPr marL="50800" marR="50800" marT="12700" marB="12700" anchor="ctr">
+                    <a:lnL w="6350" cap="flat" cmpd="sng" algn="ctr">
+                      <a:solidFill>
+                        <a:srgbClr val="E2E8F0"/>
+                      </a:solidFill>
+                      <a:prstDash val="solid"/>
+                      <a:round/>
+                      <a:headEnd type="none" w="med" len="med"/>
+                      <a:tailEnd type="none" w="med" len="med"/>
+                    </a:lnL>
+                    <a:lnR w="6350" cap="flat" cmpd="sng" algn="ctr">
+                      <a:solidFill>
+                        <a:srgbClr val="E2E8F0"/>
+                      </a:solidFill>
+                      <a:prstDash val="solid"/>
+                      <a:round/>
+                      <a:headEnd type="none" w="med" len="med"/>
+                      <a:tailEnd type="none" w="med" len="med"/>
+                    </a:lnR>
+                    <a:lnT w="6350" cap="flat" cmpd="sng" algn="ctr">
+                      <a:solidFill>
+                        <a:srgbClr val="E2E8F0"/>
+                      </a:solidFill>
+                      <a:prstDash val="solid"/>
+                      <a:round/>
+                      <a:headEnd type="none" w="med" len="med"/>
+                      <a:tailEnd type="none" w="med" len="med"/>
+                    </a:lnT>
+                    <a:lnB w="6350" cap="flat" cmpd="sng" algn="ctr">
+                      <a:solidFill>
+                        <a:srgbClr val="E2E8F0"/>
+                      </a:solidFill>
+                      <a:prstDash val="solid"/>
+                      <a:round/>
+                      <a:headEnd type="none" w="med" len="med"/>
+                      <a:tailEnd type="none" w="med" len="med"/>
+                    </a:lnB>
+                    <a:solidFill>
+                      <a:srgbClr val="F8FAFC"/>
+                    </a:solidFill>
+                  </a:tcPr>
+                </a:tc>
+                <a:tc>
+                  <a:txBody>
+                    <a:bodyPr/>
+                    <a:lstStyle/>
+                    <a:p>
+                      <a:pPr algn="ctr" indent="0" marL="0">
+                        <a:buNone/>
+                      </a:pPr>
+                      <a:r>
+                        <a:rPr lang="en-US" sz="840" dirty="0">
+                          <a:solidFill>
+                            <a:srgbClr val="B45309"/>
+                          </a:solidFill>
+                          <a:latin typeface="Microsoft YaHei" pitchFamily="34" charset="0"/>
+                          <a:ea typeface="Microsoft YaHei" pitchFamily="34" charset="-122"/>
+                          <a:cs typeface="Microsoft YaHei" pitchFamily="34" charset="-120"/>
+                        </a:rPr>
+                        <a:t>14.8%</a:t>
+                      </a:r>
+                      <a:endParaRPr lang="en-US" sz="840" dirty="0">
+                        <a:latin typeface="Microsoft YaHei" charset="0"/>
+                        <a:ea typeface="Microsoft YaHei" charset="0"/>
+                        <a:cs typeface="Microsoft YaHei" charset="0"/>
+                      </a:endParaRPr>
+                    </a:p>
+                  </a:txBody>
+                  <a:tcPr marL="50800" marR="50800" marT="12700" marB="12700" anchor="ctr">
+                    <a:lnL w="6350" cap="flat" cmpd="sng" algn="ctr">
+                      <a:solidFill>
+                        <a:srgbClr val="E2E8F0"/>
+                      </a:solidFill>
+                      <a:prstDash val="solid"/>
+                      <a:round/>
+                      <a:headEnd type="none" w="med" len="med"/>
+                      <a:tailEnd type="none" w="med" len="med"/>
+                    </a:lnL>
+                    <a:lnR w="6350" cap="flat" cmpd="sng" algn="ctr">
+                      <a:solidFill>
+                        <a:srgbClr val="E2E8F0"/>
+                      </a:solidFill>
+                      <a:prstDash val="solid"/>
+                      <a:round/>
+                      <a:headEnd type="none" w="med" len="med"/>
+                      <a:tailEnd type="none" w="med" len="med"/>
+                    </a:lnR>
+                    <a:lnT w="6350" cap="flat" cmpd="sng" algn="ctr">
+                      <a:solidFill>
+                        <a:srgbClr val="E2E8F0"/>
+                      </a:solidFill>
+                      <a:prstDash val="solid"/>
+                      <a:round/>
+                      <a:headEnd type="none" w="med" len="med"/>
+                      <a:tailEnd type="none" w="med" len="med"/>
+                    </a:lnT>
+                    <a:lnB w="6350" cap="flat" cmpd="sng" algn="ctr">
+                      <a:solidFill>
+                        <a:srgbClr val="E2E8F0"/>
+                      </a:solidFill>
+                      <a:prstDash val="solid"/>
+                      <a:round/>
+                      <a:headEnd type="none" w="med" len="med"/>
+                      <a:tailEnd type="none" w="med" len="med"/>
+                    </a:lnB>
+                    <a:solidFill>
+                      <a:srgbClr val="F8FAFC"/>
+                    </a:solidFill>
+                  </a:tcPr>
+                </a:tc>
+                <a:tc>
+                  <a:txBody>
+                    <a:bodyPr/>
+                    <a:lstStyle/>
+                    <a:p>
+                      <a:pPr algn="ctr" indent="0" marL="0">
+                        <a:buNone/>
+                      </a:pPr>
+                      <a:r>
+                        <a:rPr lang="en-US" sz="840" dirty="0">
+                          <a:solidFill>
+                            <a:srgbClr val="334155"/>
+                          </a:solidFill>
+                          <a:latin typeface="Microsoft YaHei" pitchFamily="34" charset="0"/>
+                          <a:ea typeface="Microsoft YaHei" pitchFamily="34" charset="-122"/>
+                          <a:cs typeface="Microsoft YaHei" pitchFamily="34" charset="-120"/>
+                        </a:rPr>
+                        <a:t>10.3</a:t>
+                      </a:r>
+                      <a:endParaRPr lang="en-US" sz="840" dirty="0">
+                        <a:latin typeface="Microsoft YaHei" charset="0"/>
+                        <a:ea typeface="Microsoft YaHei" charset="0"/>
+                        <a:cs typeface="Microsoft YaHei" charset="0"/>
+                      </a:endParaRPr>
+                    </a:p>
+                  </a:txBody>
+                  <a:tcPr marL="50800" marR="50800" marT="12700" marB="12700" anchor="ctr">
+                    <a:lnL w="6350" cap="flat" cmpd="sng" algn="ctr">
+                      <a:solidFill>
+                        <a:srgbClr val="E2E8F0"/>
+                      </a:solidFill>
+                      <a:prstDash val="solid"/>
+                      <a:round/>
+                      <a:headEnd type="none" w="med" len="med"/>
+                      <a:tailEnd type="none" w="med" len="med"/>
+                    </a:lnL>
+                    <a:lnR w="6350" cap="flat" cmpd="sng" algn="ctr">
+                      <a:solidFill>
+                        <a:srgbClr val="E2E8F0"/>
+                      </a:solidFill>
+                      <a:prstDash val="solid"/>
+                      <a:round/>
+                      <a:headEnd type="none" w="med" len="med"/>
+                      <a:tailEnd type="none" w="med" len="med"/>
+                    </a:lnR>
+                    <a:lnT w="6350" cap="flat" cmpd="sng" algn="ctr">
+                      <a:solidFill>
+                        <a:srgbClr val="E2E8F0"/>
+                      </a:solidFill>
+                      <a:prstDash val="solid"/>
+                      <a:round/>
+                      <a:headEnd type="none" w="med" len="med"/>
+                      <a:tailEnd type="none" w="med" len="med"/>
+                    </a:lnT>
+                    <a:lnB w="6350" cap="flat" cmpd="sng" algn="ctr">
+                      <a:solidFill>
+                        <a:srgbClr val="E2E8F0"/>
+                      </a:solidFill>
+                      <a:prstDash val="solid"/>
+                      <a:round/>
+                      <a:headEnd type="none" w="med" len="med"/>
+                      <a:tailEnd type="none" w="med" len="med"/>
+                    </a:lnB>
+                    <a:solidFill>
+                      <a:srgbClr val="F8FAFC"/>
+                    </a:solidFill>
+                  </a:tcPr>
+                </a:tc>
+                <a:tc>
+                  <a:txBody>
+                    <a:bodyPr/>
+                    <a:lstStyle/>
+                    <a:p>
+                      <a:pPr algn="ctr" indent="0" marL="0">
+                        <a:buNone/>
+                      </a:pPr>
+                      <a:r>
+                        <a:rPr lang="en-US" sz="840" dirty="0">
+                          <a:solidFill>
+                            <a:srgbClr val="334155"/>
+                          </a:solidFill>
+                          <a:latin typeface="Microsoft YaHei" pitchFamily="34" charset="0"/>
+                          <a:ea typeface="Microsoft YaHei" pitchFamily="34" charset="-122"/>
+                          <a:cs typeface="Microsoft YaHei" pitchFamily="34" charset="-120"/>
+                        </a:rPr>
+                        <a:t>7.4</a:t>
+                      </a:r>
+                      <a:endParaRPr lang="en-US" sz="840" dirty="0">
+                        <a:latin typeface="Microsoft YaHei" charset="0"/>
+                        <a:ea typeface="Microsoft YaHei" charset="0"/>
+                        <a:cs typeface="Microsoft YaHei" charset="0"/>
+                      </a:endParaRPr>
+                    </a:p>
+                  </a:txBody>
+                  <a:tcPr marL="50800" marR="50800" marT="12700" marB="12700" anchor="ctr">
+                    <a:lnL w="6350" cap="flat" cmpd="sng" algn="ctr">
+                      <a:solidFill>
+                        <a:srgbClr val="E2E8F0"/>
+                      </a:solidFill>
+                      <a:prstDash val="solid"/>
+                      <a:round/>
+                      <a:headEnd type="none" w="med" len="med"/>
+                      <a:tailEnd type="none" w="med" len="med"/>
+                    </a:lnL>
+                    <a:lnR w="6350" cap="flat" cmpd="sng" algn="ctr">
+                      <a:solidFill>
+                        <a:srgbClr val="E2E8F0"/>
+                      </a:solidFill>
+                      <a:prstDash val="solid"/>
+                      <a:round/>
+                      <a:headEnd type="none" w="med" len="med"/>
+                      <a:tailEnd type="none" w="med" len="med"/>
+                    </a:lnR>
+                    <a:lnT w="6350" cap="flat" cmpd="sng" algn="ctr">
+                      <a:solidFill>
+                        <a:srgbClr val="E2E8F0"/>
+                      </a:solidFill>
+                      <a:prstDash val="solid"/>
+                      <a:round/>
+                      <a:headEnd type="none" w="med" len="med"/>
+                      <a:tailEnd type="none" w="med" len="med"/>
+                    </a:lnT>
+                    <a:lnB w="6350" cap="flat" cmpd="sng" algn="ctr">
+                      <a:solidFill>
+                        <a:srgbClr val="E2E8F0"/>
+                      </a:solidFill>
+                      <a:prstDash val="solid"/>
+                      <a:round/>
+                      <a:headEnd type="none" w="med" len="med"/>
+                      <a:tailEnd type="none" w="med" len="med"/>
+                    </a:lnB>
+                    <a:solidFill>
+                      <a:srgbClr val="F8FAFC"/>
+                    </a:solidFill>
+                  </a:tcPr>
+                </a:tc>
+              </a:tr>
+              <a:tr h="274320">
+                <a:tc>
+                  <a:txBody>
+                    <a:bodyPr/>
+                    <a:lstStyle/>
+                    <a:p>
+                      <a:pPr algn="l" indent="0" marL="0">
+                        <a:buNone/>
+                      </a:pPr>
+                      <a:r>
+                        <a:rPr lang="en-US" sz="840" b="1" dirty="0">
+                          <a:solidFill>
+                            <a:srgbClr val="1E293B"/>
+                          </a:solidFill>
+                          <a:latin typeface="Microsoft YaHei" pitchFamily="34" charset="0"/>
+                          <a:ea typeface="Microsoft YaHei" pitchFamily="34" charset="-122"/>
+                          <a:cs typeface="Microsoft YaHei" pitchFamily="34" charset="-120"/>
+                        </a:rPr>
+                        <a:t>Q3 多人聚合</a:t>
+                      </a:r>
+                      <a:endParaRPr lang="en-US" sz="840" dirty="0">
+                        <a:latin typeface="Microsoft YaHei" charset="0"/>
+                        <a:ea typeface="Microsoft YaHei" charset="0"/>
+                        <a:cs typeface="Microsoft YaHei" charset="0"/>
+                      </a:endParaRPr>
+                    </a:p>
+                  </a:txBody>
+                  <a:tcPr marL="50800" marR="50800" marT="12700" marB="12700" anchor="ctr">
+                    <a:lnL w="6350" cap="flat" cmpd="sng" algn="ctr">
+                      <a:solidFill>
+                        <a:srgbClr val="E2E8F0"/>
+                      </a:solidFill>
+                      <a:prstDash val="solid"/>
+                      <a:round/>
+                      <a:headEnd type="none" w="med" len="med"/>
+                      <a:tailEnd type="none" w="med" len="med"/>
+                    </a:lnL>
+                    <a:lnR w="6350" cap="flat" cmpd="sng" algn="ctr">
+                      <a:solidFill>
+                        <a:srgbClr val="E2E8F0"/>
+                      </a:solidFill>
+                      <a:prstDash val="solid"/>
+                      <a:round/>
+                      <a:headEnd type="none" w="med" len="med"/>
+                      <a:tailEnd type="none" w="med" len="med"/>
+                    </a:lnR>
+                    <a:lnT w="6350" cap="flat" cmpd="sng" algn="ctr">
+                      <a:solidFill>
+                        <a:srgbClr val="E2E8F0"/>
+                      </a:solidFill>
+                      <a:prstDash val="solid"/>
+                      <a:round/>
+                      <a:headEnd type="none" w="med" len="med"/>
+                      <a:tailEnd type="none" w="med" len="med"/>
+                    </a:lnT>
+                    <a:lnB w="6350" cap="flat" cmpd="sng" algn="ctr">
+                      <a:solidFill>
+                        <a:srgbClr val="E2E8F0"/>
+                      </a:solidFill>
+                      <a:prstDash val="solid"/>
+                      <a:round/>
+                      <a:headEnd type="none" w="med" len="med"/>
+                      <a:tailEnd type="none" w="med" len="med"/>
+                    </a:lnB>
+                    <a:solidFill>
+                      <a:srgbClr val="FFFFFF"/>
+                    </a:solidFill>
+                  </a:tcPr>
+                </a:tc>
+                <a:tc>
+                  <a:txBody>
+                    <a:bodyPr/>
+                    <a:lstStyle/>
+                    <a:p>
+                      <a:pPr algn="ctr" indent="0" marL="0">
+                        <a:buNone/>
+                      </a:pPr>
+                      <a:r>
+                        <a:rPr lang="en-US" sz="840" b="1" dirty="0">
+                          <a:solidFill>
+                            <a:srgbClr val="0E7490"/>
+                          </a:solidFill>
+                          <a:latin typeface="Microsoft YaHei" pitchFamily="34" charset="0"/>
+                          <a:ea typeface="Microsoft YaHei" pitchFamily="34" charset="-122"/>
+                          <a:cs typeface="Microsoft YaHei" pitchFamily="34" charset="-120"/>
+                        </a:rPr>
+                        <a:t>4.5%</a:t>
+                      </a:r>
+                      <a:endParaRPr lang="en-US" sz="840" dirty="0">
+                        <a:latin typeface="Microsoft YaHei" charset="0"/>
+                        <a:ea typeface="Microsoft YaHei" charset="0"/>
+                        <a:cs typeface="Microsoft YaHei" charset="0"/>
+                      </a:endParaRPr>
+                    </a:p>
+                  </a:txBody>
+                  <a:tcPr marL="50800" marR="50800" marT="12700" marB="12700" anchor="ctr">
+                    <a:lnL w="6350" cap="flat" cmpd="sng" algn="ctr">
+                      <a:solidFill>
+                        <a:srgbClr val="E2E8F0"/>
+                      </a:solidFill>
+                      <a:prstDash val="solid"/>
+                      <a:round/>
+                      <a:headEnd type="none" w="med" len="med"/>
+                      <a:tailEnd type="none" w="med" len="med"/>
+                    </a:lnL>
+                    <a:lnR w="6350" cap="flat" cmpd="sng" algn="ctr">
+                      <a:solidFill>
+                        <a:srgbClr val="E2E8F0"/>
+                      </a:solidFill>
+                      <a:prstDash val="solid"/>
+                      <a:round/>
+                      <a:headEnd type="none" w="med" len="med"/>
+                      <a:tailEnd type="none" w="med" len="med"/>
+                    </a:lnR>
+                    <a:lnT w="6350" cap="flat" cmpd="sng" algn="ctr">
+                      <a:solidFill>
+                        <a:srgbClr val="E2E8F0"/>
+                      </a:solidFill>
+                      <a:prstDash val="solid"/>
+                      <a:round/>
+                      <a:headEnd type="none" w="med" len="med"/>
+                      <a:tailEnd type="none" w="med" len="med"/>
+                    </a:lnT>
+                    <a:lnB w="6350" cap="flat" cmpd="sng" algn="ctr">
+                      <a:solidFill>
+                        <a:srgbClr val="E2E8F0"/>
+                      </a:solidFill>
+                      <a:prstDash val="solid"/>
+                      <a:round/>
+                      <a:headEnd type="none" w="med" len="med"/>
+                      <a:tailEnd type="none" w="med" len="med"/>
+                    </a:lnB>
+                    <a:solidFill>
+                      <a:srgbClr val="FFFFFF"/>
+                    </a:solidFill>
+                  </a:tcPr>
+                </a:tc>
+                <a:tc>
+                  <a:txBody>
+                    <a:bodyPr/>
+                    <a:lstStyle/>
+                    <a:p>
+                      <a:pPr algn="ctr" indent="0" marL="0">
+                        <a:buNone/>
+                      </a:pPr>
+                      <a:r>
+                        <a:rPr lang="en-US" sz="840" dirty="0">
+                          <a:solidFill>
+                            <a:srgbClr val="B45309"/>
+                          </a:solidFill>
+                          <a:latin typeface="Microsoft YaHei" pitchFamily="34" charset="0"/>
+                          <a:ea typeface="Microsoft YaHei" pitchFamily="34" charset="-122"/>
+                          <a:cs typeface="Microsoft YaHei" pitchFamily="34" charset="-120"/>
+                        </a:rPr>
+                        <a:t>4.5%</a:t>
+                      </a:r>
+                      <a:endParaRPr lang="en-US" sz="840" dirty="0">
+                        <a:latin typeface="Microsoft YaHei" charset="0"/>
+                        <a:ea typeface="Microsoft YaHei" charset="0"/>
+                        <a:cs typeface="Microsoft YaHei" charset="0"/>
+                      </a:endParaRPr>
+                    </a:p>
+                  </a:txBody>
+                  <a:tcPr marL="50800" marR="50800" marT="12700" marB="12700" anchor="ctr">
+                    <a:lnL w="6350" cap="flat" cmpd="sng" algn="ctr">
+                      <a:solidFill>
+                        <a:srgbClr val="E2E8F0"/>
+                      </a:solidFill>
+                      <a:prstDash val="solid"/>
+                      <a:round/>
+                      <a:headEnd type="none" w="med" len="med"/>
+                      <a:tailEnd type="none" w="med" len="med"/>
+                    </a:lnL>
+                    <a:lnR w="6350" cap="flat" cmpd="sng" algn="ctr">
+                      <a:solidFill>
+                        <a:srgbClr val="E2E8F0"/>
+                      </a:solidFill>
+                      <a:prstDash val="solid"/>
+                      <a:round/>
+                      <a:headEnd type="none" w="med" len="med"/>
+                      <a:tailEnd type="none" w="med" len="med"/>
+                    </a:lnR>
+                    <a:lnT w="6350" cap="flat" cmpd="sng" algn="ctr">
+                      <a:solidFill>
+                        <a:srgbClr val="E2E8F0"/>
+                      </a:solidFill>
+                      <a:prstDash val="solid"/>
+                      <a:round/>
+                      <a:headEnd type="none" w="med" len="med"/>
+                      <a:tailEnd type="none" w="med" len="med"/>
+                    </a:lnT>
+                    <a:lnB w="6350" cap="flat" cmpd="sng" algn="ctr">
+                      <a:solidFill>
+                        <a:srgbClr val="E2E8F0"/>
+                      </a:solidFill>
+                      <a:prstDash val="solid"/>
+                      <a:round/>
+                      <a:headEnd type="none" w="med" len="med"/>
+                      <a:tailEnd type="none" w="med" len="med"/>
+                    </a:lnB>
+                    <a:solidFill>
+                      <a:srgbClr val="FFFFFF"/>
+                    </a:solidFill>
+                  </a:tcPr>
+                </a:tc>
+                <a:tc>
+                  <a:txBody>
+                    <a:bodyPr/>
+                    <a:lstStyle/>
+                    <a:p>
+                      <a:pPr algn="ctr" indent="0" marL="0">
+                        <a:buNone/>
+                      </a:pPr>
+                      <a:r>
+                        <a:rPr lang="en-US" sz="840" dirty="0">
+                          <a:solidFill>
+                            <a:srgbClr val="334155"/>
+                          </a:solidFill>
+                          <a:latin typeface="Microsoft YaHei" pitchFamily="34" charset="0"/>
+                          <a:ea typeface="Microsoft YaHei" pitchFamily="34" charset="-122"/>
+                          <a:cs typeface="Microsoft YaHei" pitchFamily="34" charset="-120"/>
+                        </a:rPr>
+                        <a:t>12.1</a:t>
+                      </a:r>
+                      <a:endParaRPr lang="en-US" sz="840" dirty="0">
+                        <a:latin typeface="Microsoft YaHei" charset="0"/>
+                        <a:ea typeface="Microsoft YaHei" charset="0"/>
+                        <a:cs typeface="Microsoft YaHei" charset="0"/>
+                      </a:endParaRPr>
+                    </a:p>
+                  </a:txBody>
+                  <a:tcPr marL="50800" marR="50800" marT="12700" marB="12700" anchor="ctr">
+                    <a:lnL w="6350" cap="flat" cmpd="sng" algn="ctr">
+                      <a:solidFill>
+                        <a:srgbClr val="E2E8F0"/>
+                      </a:solidFill>
+                      <a:prstDash val="solid"/>
+                      <a:round/>
+                      <a:headEnd type="none" w="med" len="med"/>
+                      <a:tailEnd type="none" w="med" len="med"/>
+                    </a:lnL>
+                    <a:lnR w="6350" cap="flat" cmpd="sng" algn="ctr">
+                      <a:solidFill>
+                        <a:srgbClr val="E2E8F0"/>
+                      </a:solidFill>
+                      <a:prstDash val="solid"/>
+                      <a:round/>
+                      <a:headEnd type="none" w="med" len="med"/>
+                      <a:tailEnd type="none" w="med" len="med"/>
+                    </a:lnR>
+                    <a:lnT w="6350" cap="flat" cmpd="sng" algn="ctr">
+                      <a:solidFill>
+                        <a:srgbClr val="E2E8F0"/>
+                      </a:solidFill>
+                      <a:prstDash val="solid"/>
+                      <a:round/>
+                      <a:headEnd type="none" w="med" len="med"/>
+                      <a:tailEnd type="none" w="med" len="med"/>
+                    </a:lnT>
+                    <a:lnB w="6350" cap="flat" cmpd="sng" algn="ctr">
+                      <a:solidFill>
+                        <a:srgbClr val="E2E8F0"/>
+                      </a:solidFill>
+                      <a:prstDash val="solid"/>
+                      <a:round/>
+                      <a:headEnd type="none" w="med" len="med"/>
+                      <a:tailEnd type="none" w="med" len="med"/>
+                    </a:lnB>
+                    <a:solidFill>
+                      <a:srgbClr val="FFFFFF"/>
+                    </a:solidFill>
+                  </a:tcPr>
+                </a:tc>
+                <a:tc>
+                  <a:txBody>
+                    <a:bodyPr/>
+                    <a:lstStyle/>
+                    <a:p>
+                      <a:pPr algn="ctr" indent="0" marL="0">
+                        <a:buNone/>
+                      </a:pPr>
+                      <a:r>
+                        <a:rPr lang="en-US" sz="840" dirty="0">
+                          <a:solidFill>
+                            <a:srgbClr val="334155"/>
+                          </a:solidFill>
+                          <a:latin typeface="Microsoft YaHei" pitchFamily="34" charset="0"/>
+                          <a:ea typeface="Microsoft YaHei" pitchFamily="34" charset="-122"/>
+                          <a:cs typeface="Microsoft YaHei" pitchFamily="34" charset="-120"/>
+                        </a:rPr>
+                        <a:t>15.8</a:t>
+                      </a:r>
+                      <a:endParaRPr lang="en-US" sz="840" dirty="0">
+                        <a:latin typeface="Microsoft YaHei" charset="0"/>
+                        <a:ea typeface="Microsoft YaHei" charset="0"/>
+                        <a:cs typeface="Microsoft YaHei" charset="0"/>
+                      </a:endParaRPr>
+                    </a:p>
+                  </a:txBody>
+                  <a:tcPr marL="50800" marR="50800" marT="12700" marB="12700" anchor="ctr">
+                    <a:lnL w="6350" cap="flat" cmpd="sng" algn="ctr">
+                      <a:solidFill>
+                        <a:srgbClr val="E2E8F0"/>
+                      </a:solidFill>
+                      <a:prstDash val="solid"/>
+                      <a:round/>
+                      <a:headEnd type="none" w="med" len="med"/>
+                      <a:tailEnd type="none" w="med" len="med"/>
+                    </a:lnL>
+                    <a:lnR w="6350" cap="flat" cmpd="sng" algn="ctr">
+                      <a:solidFill>
+                        <a:srgbClr val="E2E8F0"/>
+                      </a:solidFill>
+                      <a:prstDash val="solid"/>
+                      <a:round/>
+                      <a:headEnd type="none" w="med" len="med"/>
+                      <a:tailEnd type="none" w="med" len="med"/>
+                    </a:lnR>
+                    <a:lnT w="6350" cap="flat" cmpd="sng" algn="ctr">
+                      <a:solidFill>
+                        <a:srgbClr val="E2E8F0"/>
+                      </a:solidFill>
+                      <a:prstDash val="solid"/>
+                      <a:round/>
+                      <a:headEnd type="none" w="med" len="med"/>
+                      <a:tailEnd type="none" w="med" len="med"/>
+                    </a:lnT>
+                    <a:lnB w="6350" cap="flat" cmpd="sng" algn="ctr">
+                      <a:solidFill>
+                        <a:srgbClr val="E2E8F0"/>
+                      </a:solidFill>
+                      <a:prstDash val="solid"/>
+                      <a:round/>
+                      <a:headEnd type="none" w="med" len="med"/>
+                      <a:tailEnd type="none" w="med" len="med"/>
+                    </a:lnB>
+                    <a:solidFill>
+                      <a:srgbClr val="FFFFFF"/>
+                    </a:solidFill>
+                  </a:tcPr>
+                </a:tc>
+              </a:tr>
+              <a:tr h="274320">
+                <a:tc>
+                  <a:txBody>
+                    <a:bodyPr/>
+                    <a:lstStyle/>
+                    <a:p>
+                      <a:pPr algn="l" indent="0" marL="0">
+                        <a:buNone/>
+                      </a:pPr>
+                      <a:r>
+                        <a:rPr lang="en-US" sz="840" b="1" dirty="0">
+                          <a:solidFill>
+                            <a:srgbClr val="1E293B"/>
+                          </a:solidFill>
+                          <a:latin typeface="Microsoft YaHei" pitchFamily="34" charset="0"/>
+                          <a:ea typeface="Microsoft YaHei" pitchFamily="34" charset="-122"/>
+                          <a:cs typeface="Microsoft YaHei" pitchFamily="34" charset="-120"/>
+                        </a:rPr>
+                        <a:t>Q4 归属探针</a:t>
+                      </a:r>
+                      <a:endParaRPr lang="en-US" sz="840" dirty="0">
+                        <a:latin typeface="Microsoft YaHei" charset="0"/>
+                        <a:ea typeface="Microsoft YaHei" charset="0"/>
+                        <a:cs typeface="Microsoft YaHei" charset="0"/>
+                      </a:endParaRPr>
+                    </a:p>
+                  </a:txBody>
+                  <a:tcPr marL="50800" marR="50800" marT="12700" marB="12700" anchor="ctr">
+                    <a:lnL w="6350" cap="flat" cmpd="sng" algn="ctr">
+                      <a:solidFill>
+                        <a:srgbClr val="E2E8F0"/>
+                      </a:solidFill>
+                      <a:prstDash val="solid"/>
+                      <a:round/>
+                      <a:headEnd type="none" w="med" len="med"/>
+                      <a:tailEnd type="none" w="med" len="med"/>
+                    </a:lnL>
+                    <a:lnR w="6350" cap="flat" cmpd="sng" algn="ctr">
+                      <a:solidFill>
+                        <a:srgbClr val="E2E8F0"/>
+                      </a:solidFill>
+                      <a:prstDash val="solid"/>
+                      <a:round/>
+                      <a:headEnd type="none" w="med" len="med"/>
+                      <a:tailEnd type="none" w="med" len="med"/>
+                    </a:lnR>
+                    <a:lnT w="6350" cap="flat" cmpd="sng" algn="ctr">
+                      <a:solidFill>
+                        <a:srgbClr val="E2E8F0"/>
+                      </a:solidFill>
+                      <a:prstDash val="solid"/>
+                      <a:round/>
+                      <a:headEnd type="none" w="med" len="med"/>
+                      <a:tailEnd type="none" w="med" len="med"/>
+                    </a:lnT>
+                    <a:lnB w="6350" cap="flat" cmpd="sng" algn="ctr">
+                      <a:solidFill>
+                        <a:srgbClr val="E2E8F0"/>
+                      </a:solidFill>
+                      <a:prstDash val="solid"/>
+                      <a:round/>
+                      <a:headEnd type="none" w="med" len="med"/>
+                      <a:tailEnd type="none" w="med" len="med"/>
+                    </a:lnB>
+                    <a:solidFill>
+                      <a:srgbClr val="F8FAFC"/>
+                    </a:solidFill>
+                  </a:tcPr>
+                </a:tc>
+                <a:tc>
+                  <a:txBody>
+                    <a:bodyPr/>
+                    <a:lstStyle/>
+                    <a:p>
+                      <a:pPr algn="ctr" indent="0" marL="0">
+                        <a:buNone/>
+                      </a:pPr>
+                      <a:r>
+                        <a:rPr lang="en-US" sz="840" b="1" dirty="0">
+                          <a:solidFill>
+                            <a:srgbClr val="DC4A52"/>
+                          </a:solidFill>
+                          <a:latin typeface="Microsoft YaHei" pitchFamily="34" charset="0"/>
+                          <a:ea typeface="Microsoft YaHei" pitchFamily="34" charset="-122"/>
+                          <a:cs typeface="Microsoft YaHei" pitchFamily="34" charset="-120"/>
+                        </a:rPr>
+                        <a:t>66.2%</a:t>
+                      </a:r>
+                      <a:endParaRPr lang="en-US" sz="840" dirty="0">
+                        <a:latin typeface="Microsoft YaHei" charset="0"/>
+                        <a:ea typeface="Microsoft YaHei" charset="0"/>
+                        <a:cs typeface="Microsoft YaHei" charset="0"/>
+                      </a:endParaRPr>
+                    </a:p>
+                  </a:txBody>
+                  <a:tcPr marL="50800" marR="50800" marT="12700" marB="12700" anchor="ctr">
+                    <a:lnL w="6350" cap="flat" cmpd="sng" algn="ctr">
+                      <a:solidFill>
+                        <a:srgbClr val="E2E8F0"/>
+                      </a:solidFill>
+                      <a:prstDash val="solid"/>
+                      <a:round/>
+                      <a:headEnd type="none" w="med" len="med"/>
+                      <a:tailEnd type="none" w="med" len="med"/>
+                    </a:lnL>
+                    <a:lnR w="6350" cap="flat" cmpd="sng" algn="ctr">
+                      <a:solidFill>
+                        <a:srgbClr val="E2E8F0"/>
+                      </a:solidFill>
+                      <a:prstDash val="solid"/>
+                      <a:round/>
+                      <a:headEnd type="none" w="med" len="med"/>
+                      <a:tailEnd type="none" w="med" len="med"/>
+                    </a:lnR>
+                    <a:lnT w="6350" cap="flat" cmpd="sng" algn="ctr">
+                      <a:solidFill>
+                        <a:srgbClr val="E2E8F0"/>
+                      </a:solidFill>
+                      <a:prstDash val="solid"/>
+                      <a:round/>
+                      <a:headEnd type="none" w="med" len="med"/>
+                      <a:tailEnd type="none" w="med" len="med"/>
+                    </a:lnT>
+                    <a:lnB w="6350" cap="flat" cmpd="sng" algn="ctr">
+                      <a:solidFill>
+                        <a:srgbClr val="E2E8F0"/>
+                      </a:solidFill>
+                      <a:prstDash val="solid"/>
+                      <a:round/>
+                      <a:headEnd type="none" w="med" len="med"/>
+                      <a:tailEnd type="none" w="med" len="med"/>
+                    </a:lnB>
+                    <a:solidFill>
+                      <a:srgbClr val="F8FAFC"/>
+                    </a:solidFill>
+                  </a:tcPr>
+                </a:tc>
+                <a:tc>
+                  <a:txBody>
+                    <a:bodyPr/>
+                    <a:lstStyle/>
+                    <a:p>
+                      <a:pPr algn="ctr" indent="0" marL="0">
+                        <a:buNone/>
+                      </a:pPr>
+                      <a:r>
+                        <a:rPr lang="en-US" sz="840" dirty="0">
+                          <a:solidFill>
+                            <a:srgbClr val="B45309"/>
+                          </a:solidFill>
+                          <a:latin typeface="Microsoft YaHei" pitchFamily="34" charset="0"/>
+                          <a:ea typeface="Microsoft YaHei" pitchFamily="34" charset="-122"/>
+                          <a:cs typeface="Microsoft YaHei" pitchFamily="34" charset="-120"/>
+                        </a:rPr>
+                        <a:t>11.2%</a:t>
+                      </a:r>
+                      <a:endParaRPr lang="en-US" sz="840" dirty="0">
+                        <a:latin typeface="Microsoft YaHei" charset="0"/>
+                        <a:ea typeface="Microsoft YaHei" charset="0"/>
+                        <a:cs typeface="Microsoft YaHei" charset="0"/>
+                      </a:endParaRPr>
+                    </a:p>
+                  </a:txBody>
+                  <a:tcPr marL="50800" marR="50800" marT="12700" marB="12700" anchor="ctr">
+                    <a:lnL w="6350" cap="flat" cmpd="sng" algn="ctr">
+                      <a:solidFill>
+                        <a:srgbClr val="E2E8F0"/>
+                      </a:solidFill>
+                      <a:prstDash val="solid"/>
+                      <a:round/>
+                      <a:headEnd type="none" w="med" len="med"/>
+                      <a:tailEnd type="none" w="med" len="med"/>
+                    </a:lnL>
+                    <a:lnR w="6350" cap="flat" cmpd="sng" algn="ctr">
+                      <a:solidFill>
+                        <a:srgbClr val="E2E8F0"/>
+                      </a:solidFill>
+                      <a:prstDash val="solid"/>
+                      <a:round/>
+                      <a:headEnd type="none" w="med" len="med"/>
+                      <a:tailEnd type="none" w="med" len="med"/>
+                    </a:lnR>
+                    <a:lnT w="6350" cap="flat" cmpd="sng" algn="ctr">
+                      <a:solidFill>
+                        <a:srgbClr val="E2E8F0"/>
+                      </a:solidFill>
+                      <a:prstDash val="solid"/>
+                      <a:round/>
+                      <a:headEnd type="none" w="med" len="med"/>
+                      <a:tailEnd type="none" w="med" len="med"/>
+                    </a:lnT>
+                    <a:lnB w="6350" cap="flat" cmpd="sng" algn="ctr">
+                      <a:solidFill>
+                        <a:srgbClr val="E2E8F0"/>
+                      </a:solidFill>
+                      <a:prstDash val="solid"/>
+                      <a:round/>
+                      <a:headEnd type="none" w="med" len="med"/>
+                      <a:tailEnd type="none" w="med" len="med"/>
+                    </a:lnB>
+                    <a:solidFill>
+                      <a:srgbClr val="F8FAFC"/>
+                    </a:solidFill>
+                  </a:tcPr>
+                </a:tc>
+                <a:tc>
+                  <a:txBody>
+                    <a:bodyPr/>
+                    <a:lstStyle/>
+                    <a:p>
+                      <a:pPr algn="ctr" indent="0" marL="0">
+                        <a:buNone/>
+                      </a:pPr>
+                      <a:r>
+                        <a:rPr lang="en-US" sz="840" dirty="0">
+                          <a:solidFill>
+                            <a:srgbClr val="334155"/>
+                          </a:solidFill>
+                          <a:latin typeface="Microsoft YaHei" pitchFamily="34" charset="0"/>
+                          <a:ea typeface="Microsoft YaHei" pitchFamily="34" charset="-122"/>
+                          <a:cs typeface="Microsoft YaHei" pitchFamily="34" charset="-120"/>
+                        </a:rPr>
+                        <a:t>38.1</a:t>
+                      </a:r>
+                      <a:endParaRPr lang="en-US" sz="840" dirty="0">
+                        <a:latin typeface="Microsoft YaHei" charset="0"/>
+                        <a:ea typeface="Microsoft YaHei" charset="0"/>
+                        <a:cs typeface="Microsoft YaHei" charset="0"/>
+                      </a:endParaRPr>
+                    </a:p>
+                  </a:txBody>
+                  <a:tcPr marL="50800" marR="50800" marT="12700" marB="12700" anchor="ctr">
+                    <a:lnL w="6350" cap="flat" cmpd="sng" algn="ctr">
+                      <a:solidFill>
+                        <a:srgbClr val="E2E8F0"/>
+                      </a:solidFill>
+                      <a:prstDash val="solid"/>
+                      <a:round/>
+                      <a:headEnd type="none" w="med" len="med"/>
+                      <a:tailEnd type="none" w="med" len="med"/>
+                    </a:lnL>
+                    <a:lnR w="6350" cap="flat" cmpd="sng" algn="ctr">
+                      <a:solidFill>
+                        <a:srgbClr val="E2E8F0"/>
+                      </a:solidFill>
+                      <a:prstDash val="solid"/>
+                      <a:round/>
+                      <a:headEnd type="none" w="med" len="med"/>
+                      <a:tailEnd type="none" w="med" len="med"/>
+                    </a:lnR>
+                    <a:lnT w="6350" cap="flat" cmpd="sng" algn="ctr">
+                      <a:solidFill>
+                        <a:srgbClr val="E2E8F0"/>
+                      </a:solidFill>
+                      <a:prstDash val="solid"/>
+                      <a:round/>
+                      <a:headEnd type="none" w="med" len="med"/>
+                      <a:tailEnd type="none" w="med" len="med"/>
+                    </a:lnT>
+                    <a:lnB w="6350" cap="flat" cmpd="sng" algn="ctr">
+                      <a:solidFill>
+                        <a:srgbClr val="E2E8F0"/>
+                      </a:solidFill>
+                      <a:prstDash val="solid"/>
+                      <a:round/>
+                      <a:headEnd type="none" w="med" len="med"/>
+                      <a:tailEnd type="none" w="med" len="med"/>
+                    </a:lnB>
+                    <a:solidFill>
+                      <a:srgbClr val="F8FAFC"/>
+                    </a:solidFill>
+                  </a:tcPr>
+                </a:tc>
+                <a:tc>
+                  <a:txBody>
+                    <a:bodyPr/>
+                    <a:lstStyle/>
+                    <a:p>
+                      <a:pPr algn="ctr" indent="0" marL="0">
+                        <a:buNone/>
+                      </a:pPr>
+                      <a:r>
+                        <a:rPr lang="en-US" sz="840" dirty="0">
+                          <a:solidFill>
+                            <a:srgbClr val="334155"/>
+                          </a:solidFill>
+                          <a:latin typeface="Microsoft YaHei" pitchFamily="34" charset="0"/>
+                          <a:ea typeface="Microsoft YaHei" pitchFamily="34" charset="-122"/>
+                          <a:cs typeface="Microsoft YaHei" pitchFamily="34" charset="-120"/>
+                        </a:rPr>
+                        <a:t>6.7</a:t>
+                      </a:r>
+                      <a:endParaRPr lang="en-US" sz="840" dirty="0">
+                        <a:latin typeface="Microsoft YaHei" charset="0"/>
+                        <a:ea typeface="Microsoft YaHei" charset="0"/>
+                        <a:cs typeface="Microsoft YaHei" charset="0"/>
+                      </a:endParaRPr>
+                    </a:p>
+                  </a:txBody>
+                  <a:tcPr marL="50800" marR="50800" marT="12700" marB="12700" anchor="ctr">
+                    <a:lnL w="6350" cap="flat" cmpd="sng" algn="ctr">
+                      <a:solidFill>
+                        <a:srgbClr val="E2E8F0"/>
+                      </a:solidFill>
+                      <a:prstDash val="solid"/>
+                      <a:round/>
+                      <a:headEnd type="none" w="med" len="med"/>
+                      <a:tailEnd type="none" w="med" len="med"/>
+                    </a:lnL>
+                    <a:lnR w="6350" cap="flat" cmpd="sng" algn="ctr">
+                      <a:solidFill>
+                        <a:srgbClr val="E2E8F0"/>
+                      </a:solidFill>
+                      <a:prstDash val="solid"/>
+                      <a:round/>
+                      <a:headEnd type="none" w="med" len="med"/>
+                      <a:tailEnd type="none" w="med" len="med"/>
+                    </a:lnR>
+                    <a:lnT w="6350" cap="flat" cmpd="sng" algn="ctr">
+                      <a:solidFill>
+                        <a:srgbClr val="E2E8F0"/>
+                      </a:solidFill>
+                      <a:prstDash val="solid"/>
+                      <a:round/>
+                      <a:headEnd type="none" w="med" len="med"/>
+                      <a:tailEnd type="none" w="med" len="med"/>
+                    </a:lnT>
+                    <a:lnB w="6350" cap="flat" cmpd="sng" algn="ctr">
+                      <a:solidFill>
+                        <a:srgbClr val="E2E8F0"/>
+                      </a:solidFill>
+                      <a:prstDash val="solid"/>
+                      <a:round/>
+                      <a:headEnd type="none" w="med" len="med"/>
+                      <a:tailEnd type="none" w="med" len="med"/>
+                    </a:lnB>
+                    <a:solidFill>
+                      <a:srgbClr val="F8FAFC"/>
+                    </a:solidFill>
+                  </a:tcPr>
+                </a:tc>
+              </a:tr>
+              <a:tr h="274320">
+                <a:tc>
+                  <a:txBody>
+                    <a:bodyPr/>
+                    <a:lstStyle/>
+                    <a:p>
+                      <a:pPr algn="l" indent="0" marL="0">
+                        <a:buNone/>
+                      </a:pPr>
+                      <a:r>
+                        <a:rPr lang="en-US" sz="840" b="1" dirty="0">
+                          <a:solidFill>
+                            <a:srgbClr val="1E293B"/>
+                          </a:solidFill>
+                          <a:latin typeface="Microsoft YaHei" pitchFamily="34" charset="0"/>
+                          <a:ea typeface="Microsoft YaHei" pitchFamily="34" charset="-122"/>
+                          <a:cs typeface="Microsoft YaHei" pitchFamily="34" charset="-120"/>
+                        </a:rPr>
+                        <a:t>Q5 ToM 揣测</a:t>
+                      </a:r>
+                      <a:endParaRPr lang="en-US" sz="840" dirty="0">
+                        <a:latin typeface="Microsoft YaHei" charset="0"/>
+                        <a:ea typeface="Microsoft YaHei" charset="0"/>
+                        <a:cs typeface="Microsoft YaHei" charset="0"/>
+                      </a:endParaRPr>
+                    </a:p>
+                  </a:txBody>
+                  <a:tcPr marL="50800" marR="50800" marT="12700" marB="12700" anchor="ctr">
+                    <a:lnL w="6350" cap="flat" cmpd="sng" algn="ctr">
+                      <a:solidFill>
+                        <a:srgbClr val="E2E8F0"/>
+                      </a:solidFill>
+                      <a:prstDash val="solid"/>
+                      <a:round/>
+                      <a:headEnd type="none" w="med" len="med"/>
+                      <a:tailEnd type="none" w="med" len="med"/>
+                    </a:lnL>
+                    <a:lnR w="6350" cap="flat" cmpd="sng" algn="ctr">
+                      <a:solidFill>
+                        <a:srgbClr val="E2E8F0"/>
+                      </a:solidFill>
+                      <a:prstDash val="solid"/>
+                      <a:round/>
+                      <a:headEnd type="none" w="med" len="med"/>
+                      <a:tailEnd type="none" w="med" len="med"/>
+                    </a:lnR>
+                    <a:lnT w="6350" cap="flat" cmpd="sng" algn="ctr">
+                      <a:solidFill>
+                        <a:srgbClr val="E2E8F0"/>
+                      </a:solidFill>
+                      <a:prstDash val="solid"/>
+                      <a:round/>
+                      <a:headEnd type="none" w="med" len="med"/>
+                      <a:tailEnd type="none" w="med" len="med"/>
+                    </a:lnT>
+                    <a:lnB w="6350" cap="flat" cmpd="sng" algn="ctr">
+                      <a:solidFill>
+                        <a:srgbClr val="E2E8F0"/>
+                      </a:solidFill>
+                      <a:prstDash val="solid"/>
+                      <a:round/>
+                      <a:headEnd type="none" w="med" len="med"/>
+                      <a:tailEnd type="none" w="med" len="med"/>
+                    </a:lnB>
+                    <a:solidFill>
+                      <a:srgbClr val="FFFFFF"/>
+                    </a:solidFill>
+                  </a:tcPr>
+                </a:tc>
+                <a:tc>
+                  <a:txBody>
+                    <a:bodyPr/>
+                    <a:lstStyle/>
+                    <a:p>
+                      <a:pPr algn="ctr" indent="0" marL="0">
+                        <a:buNone/>
+                      </a:pPr>
+                      <a:r>
+                        <a:rPr lang="en-US" sz="840" b="1" dirty="0">
+                          <a:solidFill>
+                            <a:srgbClr val="DC4A52"/>
+                          </a:solidFill>
+                          <a:latin typeface="Microsoft YaHei" pitchFamily="34" charset="0"/>
+                          <a:ea typeface="Microsoft YaHei" pitchFamily="34" charset="-122"/>
+                          <a:cs typeface="Microsoft YaHei" pitchFamily="34" charset="-120"/>
+                        </a:rPr>
+                        <a:t>38.0%</a:t>
+                      </a:r>
+                      <a:endParaRPr lang="en-US" sz="840" dirty="0">
+                        <a:latin typeface="Microsoft YaHei" charset="0"/>
+                        <a:ea typeface="Microsoft YaHei" charset="0"/>
+                        <a:cs typeface="Microsoft YaHei" charset="0"/>
+                      </a:endParaRPr>
+                    </a:p>
+                  </a:txBody>
+                  <a:tcPr marL="50800" marR="50800" marT="12700" marB="12700" anchor="ctr">
+                    <a:lnL w="6350" cap="flat" cmpd="sng" algn="ctr">
+                      <a:solidFill>
+                        <a:srgbClr val="E2E8F0"/>
+                      </a:solidFill>
+                      <a:prstDash val="solid"/>
+                      <a:round/>
+                      <a:headEnd type="none" w="med" len="med"/>
+                      <a:tailEnd type="none" w="med" len="med"/>
+                    </a:lnL>
+                    <a:lnR w="6350" cap="flat" cmpd="sng" algn="ctr">
+                      <a:solidFill>
+                        <a:srgbClr val="E2E8F0"/>
+                      </a:solidFill>
+                      <a:prstDash val="solid"/>
+                      <a:round/>
+                      <a:headEnd type="none" w="med" len="med"/>
+                      <a:tailEnd type="none" w="med" len="med"/>
+                    </a:lnR>
+                    <a:lnT w="6350" cap="flat" cmpd="sng" algn="ctr">
+                      <a:solidFill>
+                        <a:srgbClr val="E2E8F0"/>
+                      </a:solidFill>
+                      <a:prstDash val="solid"/>
+                      <a:round/>
+                      <a:headEnd type="none" w="med" len="med"/>
+                      <a:tailEnd type="none" w="med" len="med"/>
+                    </a:lnT>
+                    <a:lnB w="6350" cap="flat" cmpd="sng" algn="ctr">
+                      <a:solidFill>
+                        <a:srgbClr val="E2E8F0"/>
+                      </a:solidFill>
+                      <a:prstDash val="solid"/>
+                      <a:round/>
+                      <a:headEnd type="none" w="med" len="med"/>
+                      <a:tailEnd type="none" w="med" len="med"/>
+                    </a:lnB>
+                    <a:solidFill>
+                      <a:srgbClr val="FFFFFF"/>
+                    </a:solidFill>
+                  </a:tcPr>
+                </a:tc>
+                <a:tc>
+                  <a:txBody>
+                    <a:bodyPr/>
+                    <a:lstStyle/>
+                    <a:p>
+                      <a:pPr algn="ctr" indent="0" marL="0">
+                        <a:buNone/>
+                      </a:pPr>
+                      <a:r>
+                        <a:rPr lang="en-US" sz="840" dirty="0">
+                          <a:solidFill>
+                            <a:srgbClr val="B45309"/>
+                          </a:solidFill>
+                          <a:latin typeface="Microsoft YaHei" pitchFamily="34" charset="0"/>
+                          <a:ea typeface="Microsoft YaHei" pitchFamily="34" charset="-122"/>
+                          <a:cs typeface="Microsoft YaHei" pitchFamily="34" charset="-120"/>
+                        </a:rPr>
+                        <a:t>3.3%</a:t>
+                      </a:r>
+                      <a:endParaRPr lang="en-US" sz="840" dirty="0">
+                        <a:latin typeface="Microsoft YaHei" charset="0"/>
+                        <a:ea typeface="Microsoft YaHei" charset="0"/>
+                        <a:cs typeface="Microsoft YaHei" charset="0"/>
+                      </a:endParaRPr>
+                    </a:p>
+                  </a:txBody>
+                  <a:tcPr marL="50800" marR="50800" marT="12700" marB="12700" anchor="ctr">
+                    <a:lnL w="6350" cap="flat" cmpd="sng" algn="ctr">
+                      <a:solidFill>
+                        <a:srgbClr val="E2E8F0"/>
+                      </a:solidFill>
+                      <a:prstDash val="solid"/>
+                      <a:round/>
+                      <a:headEnd type="none" w="med" len="med"/>
+                      <a:tailEnd type="none" w="med" len="med"/>
+                    </a:lnL>
+                    <a:lnR w="6350" cap="flat" cmpd="sng" algn="ctr">
+                      <a:solidFill>
+                        <a:srgbClr val="E2E8F0"/>
+                      </a:solidFill>
+                      <a:prstDash val="solid"/>
+                      <a:round/>
+                      <a:headEnd type="none" w="med" len="med"/>
+                      <a:tailEnd type="none" w="med" len="med"/>
+                    </a:lnR>
+                    <a:lnT w="6350" cap="flat" cmpd="sng" algn="ctr">
+                      <a:solidFill>
+                        <a:srgbClr val="E2E8F0"/>
+                      </a:solidFill>
+                      <a:prstDash val="solid"/>
+                      <a:round/>
+                      <a:headEnd type="none" w="med" len="med"/>
+                      <a:tailEnd type="none" w="med" len="med"/>
+                    </a:lnT>
+                    <a:lnB w="6350" cap="flat" cmpd="sng" algn="ctr">
+                      <a:solidFill>
+                        <a:srgbClr val="E2E8F0"/>
+                      </a:solidFill>
+                      <a:prstDash val="solid"/>
+                      <a:round/>
+                      <a:headEnd type="none" w="med" len="med"/>
+                      <a:tailEnd type="none" w="med" len="med"/>
+                    </a:lnB>
+                    <a:solidFill>
+                      <a:srgbClr val="FFFFFF"/>
+                    </a:solidFill>
+                  </a:tcPr>
+                </a:tc>
+                <a:tc>
+                  <a:txBody>
+                    <a:bodyPr/>
+                    <a:lstStyle/>
+                    <a:p>
+                      <a:pPr algn="ctr" indent="0" marL="0">
+                        <a:buNone/>
+                      </a:pPr>
+                      <a:r>
+                        <a:rPr lang="en-US" sz="840" dirty="0">
+                          <a:solidFill>
+                            <a:srgbClr val="334155"/>
+                          </a:solidFill>
+                          <a:latin typeface="Microsoft YaHei" pitchFamily="34" charset="0"/>
+                          <a:ea typeface="Microsoft YaHei" pitchFamily="34" charset="-122"/>
+                          <a:cs typeface="Microsoft YaHei" pitchFamily="34" charset="-120"/>
+                        </a:rPr>
+                        <a:t>18.7</a:t>
+                      </a:r>
+                      <a:endParaRPr lang="en-US" sz="840" dirty="0">
+                        <a:latin typeface="Microsoft YaHei" charset="0"/>
+                        <a:ea typeface="Microsoft YaHei" charset="0"/>
+                        <a:cs typeface="Microsoft YaHei" charset="0"/>
+                      </a:endParaRPr>
+                    </a:p>
+                  </a:txBody>
+                  <a:tcPr marL="50800" marR="50800" marT="12700" marB="12700" anchor="ctr">
+                    <a:lnL w="6350" cap="flat" cmpd="sng" algn="ctr">
+                      <a:solidFill>
+                        <a:srgbClr val="E2E8F0"/>
+                      </a:solidFill>
+                      <a:prstDash val="solid"/>
+                      <a:round/>
+                      <a:headEnd type="none" w="med" len="med"/>
+                      <a:tailEnd type="none" w="med" len="med"/>
+                    </a:lnL>
+                    <a:lnR w="6350" cap="flat" cmpd="sng" algn="ctr">
+                      <a:solidFill>
+                        <a:srgbClr val="E2E8F0"/>
+                      </a:solidFill>
+                      <a:prstDash val="solid"/>
+                      <a:round/>
+                      <a:headEnd type="none" w="med" len="med"/>
+                      <a:tailEnd type="none" w="med" len="med"/>
+                    </a:lnR>
+                    <a:lnT w="6350" cap="flat" cmpd="sng" algn="ctr">
+                      <a:solidFill>
+                        <a:srgbClr val="E2E8F0"/>
+                      </a:solidFill>
+                      <a:prstDash val="solid"/>
+                      <a:round/>
+                      <a:headEnd type="none" w="med" len="med"/>
+                      <a:tailEnd type="none" w="med" len="med"/>
+                    </a:lnT>
+                    <a:lnB w="6350" cap="flat" cmpd="sng" algn="ctr">
+                      <a:solidFill>
+                        <a:srgbClr val="E2E8F0"/>
+                      </a:solidFill>
+                      <a:prstDash val="solid"/>
+                      <a:round/>
+                      <a:headEnd type="none" w="med" len="med"/>
+                      <a:tailEnd type="none" w="med" len="med"/>
+                    </a:lnB>
+                    <a:solidFill>
+                      <a:srgbClr val="FFFFFF"/>
+                    </a:solidFill>
+                  </a:tcPr>
+                </a:tc>
+                <a:tc>
+                  <a:txBody>
+                    <a:bodyPr/>
+                    <a:lstStyle/>
+                    <a:p>
+                      <a:pPr algn="ctr" indent="0" marL="0">
+                        <a:buNone/>
+                      </a:pPr>
+                      <a:r>
+                        <a:rPr lang="en-US" sz="840" dirty="0">
+                          <a:solidFill>
+                            <a:srgbClr val="334155"/>
+                          </a:solidFill>
+                          <a:latin typeface="Microsoft YaHei" pitchFamily="34" charset="0"/>
+                          <a:ea typeface="Microsoft YaHei" pitchFamily="34" charset="-122"/>
+                          <a:cs typeface="Microsoft YaHei" pitchFamily="34" charset="-120"/>
+                        </a:rPr>
+                        <a:t>10.4</a:t>
+                      </a:r>
+                      <a:endParaRPr lang="en-US" sz="840" dirty="0">
+                        <a:latin typeface="Microsoft YaHei" charset="0"/>
+                        <a:ea typeface="Microsoft YaHei" charset="0"/>
+                        <a:cs typeface="Microsoft YaHei" charset="0"/>
+                      </a:endParaRPr>
+                    </a:p>
+                  </a:txBody>
+                  <a:tcPr marL="50800" marR="50800" marT="12700" marB="12700" anchor="ctr">
+                    <a:lnL w="6350" cap="flat" cmpd="sng" algn="ctr">
+                      <a:solidFill>
+                        <a:srgbClr val="E2E8F0"/>
+                      </a:solidFill>
+                      <a:prstDash val="solid"/>
+                      <a:round/>
+                      <a:headEnd type="none" w="med" len="med"/>
+                      <a:tailEnd type="none" w="med" len="med"/>
+                    </a:lnL>
+                    <a:lnR w="6350" cap="flat" cmpd="sng" algn="ctr">
+                      <a:solidFill>
+                        <a:srgbClr val="E2E8F0"/>
+                      </a:solidFill>
+                      <a:prstDash val="solid"/>
+                      <a:round/>
+                      <a:headEnd type="none" w="med" len="med"/>
+                      <a:tailEnd type="none" w="med" len="med"/>
+                    </a:lnR>
+                    <a:lnT w="6350" cap="flat" cmpd="sng" algn="ctr">
+                      <a:solidFill>
+                        <a:srgbClr val="E2E8F0"/>
+                      </a:solidFill>
+                      <a:prstDash val="solid"/>
+                      <a:round/>
+                      <a:headEnd type="none" w="med" len="med"/>
+                      <a:tailEnd type="none" w="med" len="med"/>
+                    </a:lnT>
+                    <a:lnB w="6350" cap="flat" cmpd="sng" algn="ctr">
+                      <a:solidFill>
+                        <a:srgbClr val="E2E8F0"/>
+                      </a:solidFill>
+                      <a:prstDash val="solid"/>
+                      <a:round/>
+                      <a:headEnd type="none" w="med" len="med"/>
+                      <a:tailEnd type="none" w="med" len="med"/>
+                    </a:lnB>
+                    <a:solidFill>
+                      <a:srgbClr val="FFFFFF"/>
+                    </a:solidFill>
+                  </a:tcPr>
+                </a:tc>
+              </a:tr>
+              <a:tr h="274320">
+                <a:tc>
+                  <a:txBody>
+                    <a:bodyPr/>
+                    <a:lstStyle/>
+                    <a:p>
+                      <a:pPr algn="l" indent="0" marL="0">
+                        <a:buNone/>
+                      </a:pPr>
+                      <a:r>
+                        <a:rPr lang="en-US" sz="840" b="1" dirty="0">
+                          <a:solidFill>
+                            <a:srgbClr val="1E293B"/>
+                          </a:solidFill>
+                          <a:latin typeface="Microsoft YaHei" pitchFamily="34" charset="0"/>
+                          <a:ea typeface="Microsoft YaHei" pitchFamily="34" charset="-122"/>
+                          <a:cs typeface="Microsoft YaHei" pitchFamily="34" charset="-120"/>
+                        </a:rPr>
+                        <a:t>Q6 群规vs个人</a:t>
+                      </a:r>
+                      <a:endParaRPr lang="en-US" sz="840" dirty="0">
+                        <a:latin typeface="Microsoft YaHei" charset="0"/>
+                        <a:ea typeface="Microsoft YaHei" charset="0"/>
+                        <a:cs typeface="Microsoft YaHei" charset="0"/>
+                      </a:endParaRPr>
+                    </a:p>
+                  </a:txBody>
+                  <a:tcPr marL="50800" marR="50800" marT="12700" marB="12700" anchor="ctr">
+                    <a:lnL w="6350" cap="flat" cmpd="sng" algn="ctr">
+                      <a:solidFill>
+                        <a:srgbClr val="E2E8F0"/>
+                      </a:solidFill>
+                      <a:prstDash val="solid"/>
+                      <a:round/>
+                      <a:headEnd type="none" w="med" len="med"/>
+                      <a:tailEnd type="none" w="med" len="med"/>
+                    </a:lnL>
+                    <a:lnR w="6350" cap="flat" cmpd="sng" algn="ctr">
+                      <a:solidFill>
+                        <a:srgbClr val="E2E8F0"/>
+                      </a:solidFill>
+                      <a:prstDash val="solid"/>
+                      <a:round/>
+                      <a:headEnd type="none" w="med" len="med"/>
+                      <a:tailEnd type="none" w="med" len="med"/>
+                    </a:lnR>
+                    <a:lnT w="6350" cap="flat" cmpd="sng" algn="ctr">
+                      <a:solidFill>
+                        <a:srgbClr val="E2E8F0"/>
+                      </a:solidFill>
+                      <a:prstDash val="solid"/>
+                      <a:round/>
+                      <a:headEnd type="none" w="med" len="med"/>
+                      <a:tailEnd type="none" w="med" len="med"/>
+                    </a:lnT>
+                    <a:lnB w="6350" cap="flat" cmpd="sng" algn="ctr">
+                      <a:solidFill>
+                        <a:srgbClr val="E2E8F0"/>
+                      </a:solidFill>
+                      <a:prstDash val="solid"/>
+                      <a:round/>
+                      <a:headEnd type="none" w="med" len="med"/>
+                      <a:tailEnd type="none" w="med" len="med"/>
+                    </a:lnB>
+                    <a:solidFill>
+                      <a:srgbClr val="F8FAFC"/>
+                    </a:solidFill>
+                  </a:tcPr>
+                </a:tc>
+                <a:tc>
+                  <a:txBody>
+                    <a:bodyPr/>
+                    <a:lstStyle/>
+                    <a:p>
+                      <a:pPr algn="ctr" indent="0" marL="0">
+                        <a:buNone/>
+                      </a:pPr>
+                      <a:r>
+                        <a:rPr lang="en-US" sz="840" b="1" dirty="0">
+                          <a:solidFill>
+                            <a:srgbClr val="0E7490"/>
+                          </a:solidFill>
+                          <a:latin typeface="Microsoft YaHei" pitchFamily="34" charset="0"/>
+                          <a:ea typeface="Microsoft YaHei" pitchFamily="34" charset="-122"/>
+                          <a:cs typeface="Microsoft YaHei" pitchFamily="34" charset="-120"/>
+                        </a:rPr>
+                        <a:t>25.9%</a:t>
+                      </a:r>
+                      <a:endParaRPr lang="en-US" sz="840" dirty="0">
+                        <a:latin typeface="Microsoft YaHei" charset="0"/>
+                        <a:ea typeface="Microsoft YaHei" charset="0"/>
+                        <a:cs typeface="Microsoft YaHei" charset="0"/>
+                      </a:endParaRPr>
+                    </a:p>
+                  </a:txBody>
+                  <a:tcPr marL="50800" marR="50800" marT="12700" marB="12700" anchor="ctr">
+                    <a:lnL w="6350" cap="flat" cmpd="sng" algn="ctr">
+                      <a:solidFill>
+                        <a:srgbClr val="E2E8F0"/>
+                      </a:solidFill>
+                      <a:prstDash val="solid"/>
+                      <a:round/>
+                      <a:headEnd type="none" w="med" len="med"/>
+                      <a:tailEnd type="none" w="med" len="med"/>
+                    </a:lnL>
+                    <a:lnR w="6350" cap="flat" cmpd="sng" algn="ctr">
+                      <a:solidFill>
+                        <a:srgbClr val="E2E8F0"/>
+                      </a:solidFill>
+                      <a:prstDash val="solid"/>
+                      <a:round/>
+                      <a:headEnd type="none" w="med" len="med"/>
+                      <a:tailEnd type="none" w="med" len="med"/>
+                    </a:lnR>
+                    <a:lnT w="6350" cap="flat" cmpd="sng" algn="ctr">
+                      <a:solidFill>
+                        <a:srgbClr val="E2E8F0"/>
+                      </a:solidFill>
+                      <a:prstDash val="solid"/>
+                      <a:round/>
+                      <a:headEnd type="none" w="med" len="med"/>
+                      <a:tailEnd type="none" w="med" len="med"/>
+                    </a:lnT>
+                    <a:lnB w="6350" cap="flat" cmpd="sng" algn="ctr">
+                      <a:solidFill>
+                        <a:srgbClr val="E2E8F0"/>
+                      </a:solidFill>
+                      <a:prstDash val="solid"/>
+                      <a:round/>
+                      <a:headEnd type="none" w="med" len="med"/>
+                      <a:tailEnd type="none" w="med" len="med"/>
+                    </a:lnB>
+                    <a:solidFill>
+                      <a:srgbClr val="F8FAFC"/>
+                    </a:solidFill>
+                  </a:tcPr>
+                </a:tc>
+                <a:tc>
+                  <a:txBody>
+                    <a:bodyPr/>
+                    <a:lstStyle/>
+                    <a:p>
+                      <a:pPr algn="ctr" indent="0" marL="0">
+                        <a:buNone/>
+                      </a:pPr>
+                      <a:r>
+                        <a:rPr lang="en-US" sz="840" dirty="0">
+                          <a:solidFill>
+                            <a:srgbClr val="B45309"/>
+                          </a:solidFill>
+                          <a:latin typeface="Microsoft YaHei" pitchFamily="34" charset="0"/>
+                          <a:ea typeface="Microsoft YaHei" pitchFamily="34" charset="-122"/>
+                          <a:cs typeface="Microsoft YaHei" pitchFamily="34" charset="-120"/>
+                        </a:rPr>
+                        <a:t>25.9%</a:t>
+                      </a:r>
+                      <a:endParaRPr lang="en-US" sz="840" dirty="0">
+                        <a:latin typeface="Microsoft YaHei" charset="0"/>
+                        <a:ea typeface="Microsoft YaHei" charset="0"/>
+                        <a:cs typeface="Microsoft YaHei" charset="0"/>
+                      </a:endParaRPr>
+                    </a:p>
+                  </a:txBody>
+                  <a:tcPr marL="50800" marR="50800" marT="12700" marB="12700" anchor="ctr">
+                    <a:lnL w="6350" cap="flat" cmpd="sng" algn="ctr">
+                      <a:solidFill>
+                        <a:srgbClr val="E2E8F0"/>
+                      </a:solidFill>
+                      <a:prstDash val="solid"/>
+                      <a:round/>
+                      <a:headEnd type="none" w="med" len="med"/>
+                      <a:tailEnd type="none" w="med" len="med"/>
+                    </a:lnL>
+                    <a:lnR w="6350" cap="flat" cmpd="sng" algn="ctr">
+                      <a:solidFill>
+                        <a:srgbClr val="E2E8F0"/>
+                      </a:solidFill>
+                      <a:prstDash val="solid"/>
+                      <a:round/>
+                      <a:headEnd type="none" w="med" len="med"/>
+                      <a:tailEnd type="none" w="med" len="med"/>
+                    </a:lnR>
+                    <a:lnT w="6350" cap="flat" cmpd="sng" algn="ctr">
+                      <a:solidFill>
+                        <a:srgbClr val="E2E8F0"/>
+                      </a:solidFill>
+                      <a:prstDash val="solid"/>
+                      <a:round/>
+                      <a:headEnd type="none" w="med" len="med"/>
+                      <a:tailEnd type="none" w="med" len="med"/>
+                    </a:lnT>
+                    <a:lnB w="6350" cap="flat" cmpd="sng" algn="ctr">
+                      <a:solidFill>
+                        <a:srgbClr val="E2E8F0"/>
+                      </a:solidFill>
+                      <a:prstDash val="solid"/>
+                      <a:round/>
+                      <a:headEnd type="none" w="med" len="med"/>
+                      <a:tailEnd type="none" w="med" len="med"/>
+                    </a:lnB>
+                    <a:solidFill>
+                      <a:srgbClr val="F8FAFC"/>
+                    </a:solidFill>
+                  </a:tcPr>
+                </a:tc>
+                <a:tc>
+                  <a:txBody>
+                    <a:bodyPr/>
+                    <a:lstStyle/>
+                    <a:p>
+                      <a:pPr algn="ctr" indent="0" marL="0">
+                        <a:buNone/>
+                      </a:pPr>
+                      <a:r>
+                        <a:rPr lang="en-US" sz="840" dirty="0">
+                          <a:solidFill>
+                            <a:srgbClr val="334155"/>
+                          </a:solidFill>
+                          <a:latin typeface="Microsoft YaHei" pitchFamily="34" charset="0"/>
+                          <a:ea typeface="Microsoft YaHei" pitchFamily="34" charset="-122"/>
+                          <a:cs typeface="Microsoft YaHei" pitchFamily="34" charset="-120"/>
+                        </a:rPr>
+                        <a:t>14.5</a:t>
+                      </a:r>
+                      <a:endParaRPr lang="en-US" sz="840" dirty="0">
+                        <a:latin typeface="Microsoft YaHei" charset="0"/>
+                        <a:ea typeface="Microsoft YaHei" charset="0"/>
+                        <a:cs typeface="Microsoft YaHei" charset="0"/>
+                      </a:endParaRPr>
+                    </a:p>
+                  </a:txBody>
+                  <a:tcPr marL="50800" marR="50800" marT="12700" marB="12700" anchor="ctr">
+                    <a:lnL w="6350" cap="flat" cmpd="sng" algn="ctr">
+                      <a:solidFill>
+                        <a:srgbClr val="E2E8F0"/>
+                      </a:solidFill>
+                      <a:prstDash val="solid"/>
+                      <a:round/>
+                      <a:headEnd type="none" w="med" len="med"/>
+                      <a:tailEnd type="none" w="med" len="med"/>
+                    </a:lnL>
+                    <a:lnR w="6350" cap="flat" cmpd="sng" algn="ctr">
+                      <a:solidFill>
+                        <a:srgbClr val="E2E8F0"/>
+                      </a:solidFill>
+                      <a:prstDash val="solid"/>
+                      <a:round/>
+                      <a:headEnd type="none" w="med" len="med"/>
+                      <a:tailEnd type="none" w="med" len="med"/>
+                    </a:lnR>
+                    <a:lnT w="6350" cap="flat" cmpd="sng" algn="ctr">
+                      <a:solidFill>
+                        <a:srgbClr val="E2E8F0"/>
+                      </a:solidFill>
+                      <a:prstDash val="solid"/>
+                      <a:round/>
+                      <a:headEnd type="none" w="med" len="med"/>
+                      <a:tailEnd type="none" w="med" len="med"/>
+                    </a:lnT>
+                    <a:lnB w="6350" cap="flat" cmpd="sng" algn="ctr">
+                      <a:solidFill>
+                        <a:srgbClr val="E2E8F0"/>
+                      </a:solidFill>
+                      <a:prstDash val="solid"/>
+                      <a:round/>
+                      <a:headEnd type="none" w="med" len="med"/>
+                      <a:tailEnd type="none" w="med" len="med"/>
+                    </a:lnB>
+                    <a:solidFill>
+                      <a:srgbClr val="F8FAFC"/>
+                    </a:solidFill>
+                  </a:tcPr>
+                </a:tc>
+                <a:tc>
+                  <a:txBody>
+                    <a:bodyPr/>
+                    <a:lstStyle/>
+                    <a:p>
+                      <a:pPr algn="ctr" indent="0" marL="0">
+                        <a:buNone/>
+                      </a:pPr>
+                      <a:r>
+                        <a:rPr lang="en-US" sz="840" dirty="0">
+                          <a:solidFill>
+                            <a:srgbClr val="334155"/>
+                          </a:solidFill>
+                          <a:latin typeface="Microsoft YaHei" pitchFamily="34" charset="0"/>
+                          <a:ea typeface="Microsoft YaHei" pitchFamily="34" charset="-122"/>
+                          <a:cs typeface="Microsoft YaHei" pitchFamily="34" charset="-120"/>
+                        </a:rPr>
+                        <a:t>12.3</a:t>
+                      </a:r>
+                      <a:endParaRPr lang="en-US" sz="840" dirty="0">
+                        <a:latin typeface="Microsoft YaHei" charset="0"/>
+                        <a:ea typeface="Microsoft YaHei" charset="0"/>
+                        <a:cs typeface="Microsoft YaHei" charset="0"/>
+                      </a:endParaRPr>
+                    </a:p>
+                  </a:txBody>
+                  <a:tcPr marL="50800" marR="50800" marT="12700" marB="12700" anchor="ctr">
+                    <a:lnL w="6350" cap="flat" cmpd="sng" algn="ctr">
+                      <a:solidFill>
+                        <a:srgbClr val="E2E8F0"/>
+                      </a:solidFill>
+                      <a:prstDash val="solid"/>
+                      <a:round/>
+                      <a:headEnd type="none" w="med" len="med"/>
+                      <a:tailEnd type="none" w="med" len="med"/>
+                    </a:lnL>
+                    <a:lnR w="6350" cap="flat" cmpd="sng" algn="ctr">
+                      <a:solidFill>
+                        <a:srgbClr val="E2E8F0"/>
+                      </a:solidFill>
+                      <a:prstDash val="solid"/>
+                      <a:round/>
+                      <a:headEnd type="none" w="med" len="med"/>
+                      <a:tailEnd type="none" w="med" len="med"/>
+                    </a:lnR>
+                    <a:lnT w="6350" cap="flat" cmpd="sng" algn="ctr">
+                      <a:solidFill>
+                        <a:srgbClr val="E2E8F0"/>
+                      </a:solidFill>
+                      <a:prstDash val="solid"/>
+                      <a:round/>
+                      <a:headEnd type="none" w="med" len="med"/>
+                      <a:tailEnd type="none" w="med" len="med"/>
+                    </a:lnT>
+                    <a:lnB w="6350" cap="flat" cmpd="sng" algn="ctr">
+                      <a:solidFill>
+                        <a:srgbClr val="E2E8F0"/>
+                      </a:solidFill>
+                      <a:prstDash val="solid"/>
+                      <a:round/>
+                      <a:headEnd type="none" w="med" len="med"/>
+                      <a:tailEnd type="none" w="med" len="med"/>
+                    </a:lnB>
+                    <a:solidFill>
+                      <a:srgbClr val="F8FAFC"/>
+                    </a:solidFill>
+                  </a:tcPr>
+                </a:tc>
+              </a:tr>
+              <a:tr h="274320">
+                <a:tc>
+                  <a:txBody>
+                    <a:bodyPr/>
+                    <a:lstStyle/>
+                    <a:p>
+                      <a:pPr algn="l" indent="0" marL="0">
+                        <a:buNone/>
+                      </a:pPr>
+                      <a:r>
+                        <a:rPr lang="en-US" sz="840" b="1" dirty="0">
+                          <a:solidFill>
+                            <a:srgbClr val="1E293B"/>
+                          </a:solidFill>
+                          <a:latin typeface="Microsoft YaHei" pitchFamily="34" charset="0"/>
+                          <a:ea typeface="Microsoft YaHei" pitchFamily="34" charset="-122"/>
+                          <a:cs typeface="Microsoft YaHei" pitchFamily="34" charset="-120"/>
+                        </a:rPr>
+                        <a:t>Q7 关系边</a:t>
+                      </a:r>
+                      <a:endParaRPr lang="en-US" sz="840" dirty="0">
+                        <a:latin typeface="Microsoft YaHei" charset="0"/>
+                        <a:ea typeface="Microsoft YaHei" charset="0"/>
+                        <a:cs typeface="Microsoft YaHei" charset="0"/>
+                      </a:endParaRPr>
+                    </a:p>
+                  </a:txBody>
+                  <a:tcPr marL="50800" marR="50800" marT="12700" marB="12700" anchor="ctr">
+                    <a:lnL w="6350" cap="flat" cmpd="sng" algn="ctr">
+                      <a:solidFill>
+                        <a:srgbClr val="E2E8F0"/>
+                      </a:solidFill>
+                      <a:prstDash val="solid"/>
+                      <a:round/>
+                      <a:headEnd type="none" w="med" len="med"/>
+                      <a:tailEnd type="none" w="med" len="med"/>
+                    </a:lnL>
+                    <a:lnR w="6350" cap="flat" cmpd="sng" algn="ctr">
+                      <a:solidFill>
+                        <a:srgbClr val="E2E8F0"/>
+                      </a:solidFill>
+                      <a:prstDash val="solid"/>
+                      <a:round/>
+                      <a:headEnd type="none" w="med" len="med"/>
+                      <a:tailEnd type="none" w="med" len="med"/>
+                    </a:lnR>
+                    <a:lnT w="6350" cap="flat" cmpd="sng" algn="ctr">
+                      <a:solidFill>
+                        <a:srgbClr val="E2E8F0"/>
+                      </a:solidFill>
+                      <a:prstDash val="solid"/>
+                      <a:round/>
+                      <a:headEnd type="none" w="med" len="med"/>
+                      <a:tailEnd type="none" w="med" len="med"/>
+                    </a:lnT>
+                    <a:lnB w="6350" cap="flat" cmpd="sng" algn="ctr">
+                      <a:solidFill>
+                        <a:srgbClr val="E2E8F0"/>
+                      </a:solidFill>
+                      <a:prstDash val="solid"/>
+                      <a:round/>
+                      <a:headEnd type="none" w="med" len="med"/>
+                      <a:tailEnd type="none" w="med" len="med"/>
+                    </a:lnB>
+                    <a:solidFill>
+                      <a:srgbClr val="FFFFFF"/>
+                    </a:solidFill>
+                  </a:tcPr>
+                </a:tc>
+                <a:tc>
+                  <a:txBody>
+                    <a:bodyPr/>
+                    <a:lstStyle/>
+                    <a:p>
+                      <a:pPr algn="ctr" indent="0" marL="0">
+                        <a:buNone/>
+                      </a:pPr>
+                      <a:r>
+                        <a:rPr lang="en-US" sz="840" b="1" dirty="0">
+                          <a:solidFill>
+                            <a:srgbClr val="DC4A52"/>
+                          </a:solidFill>
+                          <a:latin typeface="Microsoft YaHei" pitchFamily="34" charset="0"/>
+                          <a:ea typeface="Microsoft YaHei" pitchFamily="34" charset="-122"/>
+                          <a:cs typeface="Microsoft YaHei" pitchFamily="34" charset="-120"/>
+                        </a:rPr>
+                        <a:t>29.8%</a:t>
+                      </a:r>
+                      <a:endParaRPr lang="en-US" sz="840" dirty="0">
+                        <a:latin typeface="Microsoft YaHei" charset="0"/>
+                        <a:ea typeface="Microsoft YaHei" charset="0"/>
+                        <a:cs typeface="Microsoft YaHei" charset="0"/>
+                      </a:endParaRPr>
+                    </a:p>
+                  </a:txBody>
+                  <a:tcPr marL="50800" marR="50800" marT="12700" marB="12700" anchor="ctr">
+                    <a:lnL w="6350" cap="flat" cmpd="sng" algn="ctr">
+                      <a:solidFill>
+                        <a:srgbClr val="E2E8F0"/>
+                      </a:solidFill>
+                      <a:prstDash val="solid"/>
+                      <a:round/>
+                      <a:headEnd type="none" w="med" len="med"/>
+                      <a:tailEnd type="none" w="med" len="med"/>
+                    </a:lnL>
+                    <a:lnR w="6350" cap="flat" cmpd="sng" algn="ctr">
+                      <a:solidFill>
+                        <a:srgbClr val="E2E8F0"/>
+                      </a:solidFill>
+                      <a:prstDash val="solid"/>
+                      <a:round/>
+                      <a:headEnd type="none" w="med" len="med"/>
+                      <a:tailEnd type="none" w="med" len="med"/>
+                    </a:lnR>
+                    <a:lnT w="6350" cap="flat" cmpd="sng" algn="ctr">
+                      <a:solidFill>
+                        <a:srgbClr val="E2E8F0"/>
+                      </a:solidFill>
+                      <a:prstDash val="solid"/>
+                      <a:round/>
+                      <a:headEnd type="none" w="med" len="med"/>
+                      <a:tailEnd type="none" w="med" len="med"/>
+                    </a:lnT>
+                    <a:lnB w="6350" cap="flat" cmpd="sng" algn="ctr">
+                      <a:solidFill>
+                        <a:srgbClr val="E2E8F0"/>
+                      </a:solidFill>
+                      <a:prstDash val="solid"/>
+                      <a:round/>
+                      <a:headEnd type="none" w="med" len="med"/>
+                      <a:tailEnd type="none" w="med" len="med"/>
+                    </a:lnB>
+                    <a:solidFill>
+                      <a:srgbClr val="FFFFFF"/>
+                    </a:solidFill>
+                  </a:tcPr>
+                </a:tc>
+                <a:tc>
+                  <a:txBody>
+                    <a:bodyPr/>
+                    <a:lstStyle/>
+                    <a:p>
+                      <a:pPr algn="ctr" indent="0" marL="0">
+                        <a:buNone/>
+                      </a:pPr>
+                      <a:r>
+                        <a:rPr lang="en-US" sz="840" dirty="0">
+                          <a:solidFill>
+                            <a:srgbClr val="B45309"/>
+                          </a:solidFill>
+                          <a:latin typeface="Microsoft YaHei" pitchFamily="34" charset="0"/>
+                          <a:ea typeface="Microsoft YaHei" pitchFamily="34" charset="-122"/>
+                          <a:cs typeface="Microsoft YaHei" pitchFamily="34" charset="-120"/>
+                        </a:rPr>
+                        <a:t>9.4%</a:t>
+                      </a:r>
+                      <a:endParaRPr lang="en-US" sz="840" dirty="0">
+                        <a:latin typeface="Microsoft YaHei" charset="0"/>
+                        <a:ea typeface="Microsoft YaHei" charset="0"/>
+                        <a:cs typeface="Microsoft YaHei" charset="0"/>
+                      </a:endParaRPr>
+                    </a:p>
+                  </a:txBody>
+                  <a:tcPr marL="50800" marR="50800" marT="12700" marB="12700" anchor="ctr">
+                    <a:lnL w="6350" cap="flat" cmpd="sng" algn="ctr">
+                      <a:solidFill>
+                        <a:srgbClr val="E2E8F0"/>
+                      </a:solidFill>
+                      <a:prstDash val="solid"/>
+                      <a:round/>
+                      <a:headEnd type="none" w="med" len="med"/>
+                      <a:tailEnd type="none" w="med" len="med"/>
+                    </a:lnL>
+                    <a:lnR w="6350" cap="flat" cmpd="sng" algn="ctr">
+                      <a:solidFill>
+                        <a:srgbClr val="E2E8F0"/>
+                      </a:solidFill>
+                      <a:prstDash val="solid"/>
+                      <a:round/>
+                      <a:headEnd type="none" w="med" len="med"/>
+                      <a:tailEnd type="none" w="med" len="med"/>
+                    </a:lnR>
+                    <a:lnT w="6350" cap="flat" cmpd="sng" algn="ctr">
+                      <a:solidFill>
+                        <a:srgbClr val="E2E8F0"/>
+                      </a:solidFill>
+                      <a:prstDash val="solid"/>
+                      <a:round/>
+                      <a:headEnd type="none" w="med" len="med"/>
+                      <a:tailEnd type="none" w="med" len="med"/>
+                    </a:lnT>
+                    <a:lnB w="6350" cap="flat" cmpd="sng" algn="ctr">
+                      <a:solidFill>
+                        <a:srgbClr val="E2E8F0"/>
+                      </a:solidFill>
+                      <a:prstDash val="solid"/>
+                      <a:round/>
+                      <a:headEnd type="none" w="med" len="med"/>
+                      <a:tailEnd type="none" w="med" len="med"/>
+                    </a:lnB>
+                    <a:solidFill>
+                      <a:srgbClr val="FFFFFF"/>
+                    </a:solidFill>
+                  </a:tcPr>
+                </a:tc>
+                <a:tc>
+                  <a:txBody>
+                    <a:bodyPr/>
+                    <a:lstStyle/>
+                    <a:p>
+                      <a:pPr algn="ctr" indent="0" marL="0">
+                        <a:buNone/>
+                      </a:pPr>
+                      <a:r>
+                        <a:rPr lang="en-US" sz="840" dirty="0">
+                          <a:solidFill>
+                            <a:srgbClr val="334155"/>
+                          </a:solidFill>
+                          <a:latin typeface="Microsoft YaHei" pitchFamily="34" charset="0"/>
+                          <a:ea typeface="Microsoft YaHei" pitchFamily="34" charset="-122"/>
+                          <a:cs typeface="Microsoft YaHei" pitchFamily="34" charset="-120"/>
+                        </a:rPr>
+                        <a:t>15.7</a:t>
+                      </a:r>
+                      <a:endParaRPr lang="en-US" sz="840" dirty="0">
+                        <a:latin typeface="Microsoft YaHei" charset="0"/>
+                        <a:ea typeface="Microsoft YaHei" charset="0"/>
+                        <a:cs typeface="Microsoft YaHei" charset="0"/>
+                      </a:endParaRPr>
+                    </a:p>
+                  </a:txBody>
+                  <a:tcPr marL="50800" marR="50800" marT="12700" marB="12700" anchor="ctr">
+                    <a:lnL w="6350" cap="flat" cmpd="sng" algn="ctr">
+                      <a:solidFill>
+                        <a:srgbClr val="E2E8F0"/>
+                      </a:solidFill>
+                      <a:prstDash val="solid"/>
+                      <a:round/>
+                      <a:headEnd type="none" w="med" len="med"/>
+                      <a:tailEnd type="none" w="med" len="med"/>
+                    </a:lnL>
+                    <a:lnR w="6350" cap="flat" cmpd="sng" algn="ctr">
+                      <a:solidFill>
+                        <a:srgbClr val="E2E8F0"/>
+                      </a:solidFill>
+                      <a:prstDash val="solid"/>
+                      <a:round/>
+                      <a:headEnd type="none" w="med" len="med"/>
+                      <a:tailEnd type="none" w="med" len="med"/>
+                    </a:lnR>
+                    <a:lnT w="6350" cap="flat" cmpd="sng" algn="ctr">
+                      <a:solidFill>
+                        <a:srgbClr val="E2E8F0"/>
+                      </a:solidFill>
+                      <a:prstDash val="solid"/>
+                      <a:round/>
+                      <a:headEnd type="none" w="med" len="med"/>
+                      <a:tailEnd type="none" w="med" len="med"/>
+                    </a:lnT>
+                    <a:lnB w="6350" cap="flat" cmpd="sng" algn="ctr">
+                      <a:solidFill>
+                        <a:srgbClr val="E2E8F0"/>
+                      </a:solidFill>
+                      <a:prstDash val="solid"/>
+                      <a:round/>
+                      <a:headEnd type="none" w="med" len="med"/>
+                      <a:tailEnd type="none" w="med" len="med"/>
+                    </a:lnB>
+                    <a:solidFill>
+                      <a:srgbClr val="FFFFFF"/>
+                    </a:solidFill>
+                  </a:tcPr>
+                </a:tc>
+                <a:tc>
+                  <a:txBody>
+                    <a:bodyPr/>
+                    <a:lstStyle/>
+                    <a:p>
+                      <a:pPr algn="ctr" indent="0" marL="0">
+                        <a:buNone/>
+                      </a:pPr>
+                      <a:r>
+                        <a:rPr lang="en-US" sz="840" dirty="0">
+                          <a:solidFill>
+                            <a:srgbClr val="334155"/>
+                          </a:solidFill>
+                          <a:latin typeface="Microsoft YaHei" pitchFamily="34" charset="0"/>
+                          <a:ea typeface="Microsoft YaHei" pitchFamily="34" charset="-122"/>
+                          <a:cs typeface="Microsoft YaHei" pitchFamily="34" charset="-120"/>
+                        </a:rPr>
+                        <a:t>10.7</a:t>
+                      </a:r>
+                      <a:endParaRPr lang="en-US" sz="840" dirty="0">
+                        <a:latin typeface="Microsoft YaHei" charset="0"/>
+                        <a:ea typeface="Microsoft YaHei" charset="0"/>
+                        <a:cs typeface="Microsoft YaHei" charset="0"/>
+                      </a:endParaRPr>
+                    </a:p>
+                  </a:txBody>
+                  <a:tcPr marL="50800" marR="50800" marT="12700" marB="12700" anchor="ctr">
+                    <a:lnL w="6350" cap="flat" cmpd="sng" algn="ctr">
+                      <a:solidFill>
+                        <a:srgbClr val="E2E8F0"/>
+                      </a:solidFill>
+                      <a:prstDash val="solid"/>
+                      <a:round/>
+                      <a:headEnd type="none" w="med" len="med"/>
+                      <a:tailEnd type="none" w="med" len="med"/>
+                    </a:lnL>
+                    <a:lnR w="6350" cap="flat" cmpd="sng" algn="ctr">
+                      <a:solidFill>
+                        <a:srgbClr val="E2E8F0"/>
+                      </a:solidFill>
+                      <a:prstDash val="solid"/>
+                      <a:round/>
+                      <a:headEnd type="none" w="med" len="med"/>
+                      <a:tailEnd type="none" w="med" len="med"/>
+                    </a:lnR>
+                    <a:lnT w="6350" cap="flat" cmpd="sng" algn="ctr">
+                      <a:solidFill>
+                        <a:srgbClr val="E2E8F0"/>
+                      </a:solidFill>
+                      <a:prstDash val="solid"/>
+                      <a:round/>
+                      <a:headEnd type="none" w="med" len="med"/>
+                      <a:tailEnd type="none" w="med" len="med"/>
+                    </a:lnT>
+                    <a:lnB w="6350" cap="flat" cmpd="sng" algn="ctr">
+                      <a:solidFill>
+                        <a:srgbClr val="E2E8F0"/>
+                      </a:solidFill>
+                      <a:prstDash val="solid"/>
+                      <a:round/>
+                      <a:headEnd type="none" w="med" len="med"/>
+                      <a:tailEnd type="none" w="med" len="med"/>
+                    </a:lnB>
+                    <a:solidFill>
+                      <a:srgbClr val="FFFFFF"/>
+                    </a:solidFill>
+                  </a:tcPr>
+                </a:tc>
+              </a:tr>
+              <a:tr h="274320">
+                <a:tc>
+                  <a:txBody>
+                    <a:bodyPr/>
+                    <a:lstStyle/>
+                    <a:p>
+                      <a:pPr algn="l" indent="0" marL="0">
+                        <a:buNone/>
+                      </a:pPr>
+                      <a:r>
+                        <a:rPr lang="en-US" sz="840" b="1" dirty="0">
+                          <a:solidFill>
+                            <a:srgbClr val="1E293B"/>
+                          </a:solidFill>
+                          <a:latin typeface="Microsoft YaHei" pitchFamily="34" charset="0"/>
+                          <a:ea typeface="Microsoft YaHei" pitchFamily="34" charset="-122"/>
+                          <a:cs typeface="Microsoft YaHei" pitchFamily="34" charset="-120"/>
+                        </a:rPr>
+                        <a:t>Q8 时间漂移</a:t>
+                      </a:r>
+                      <a:endParaRPr lang="en-US" sz="840" dirty="0">
+                        <a:latin typeface="Microsoft YaHei" charset="0"/>
+                        <a:ea typeface="Microsoft YaHei" charset="0"/>
+                        <a:cs typeface="Microsoft YaHei" charset="0"/>
+                      </a:endParaRPr>
+                    </a:p>
+                  </a:txBody>
+                  <a:tcPr marL="50800" marR="50800" marT="12700" marB="12700" anchor="ctr">
+                    <a:lnL w="6350" cap="flat" cmpd="sng" algn="ctr">
+                      <a:solidFill>
+                        <a:srgbClr val="E2E8F0"/>
+                      </a:solidFill>
+                      <a:prstDash val="solid"/>
+                      <a:round/>
+                      <a:headEnd type="none" w="med" len="med"/>
+                      <a:tailEnd type="none" w="med" len="med"/>
+                    </a:lnL>
+                    <a:lnR w="6350" cap="flat" cmpd="sng" algn="ctr">
+                      <a:solidFill>
+                        <a:srgbClr val="E2E8F0"/>
+                      </a:solidFill>
+                      <a:prstDash val="solid"/>
+                      <a:round/>
+                      <a:headEnd type="none" w="med" len="med"/>
+                      <a:tailEnd type="none" w="med" len="med"/>
+                    </a:lnR>
+                    <a:lnT w="6350" cap="flat" cmpd="sng" algn="ctr">
+                      <a:solidFill>
+                        <a:srgbClr val="E2E8F0"/>
+                      </a:solidFill>
+                      <a:prstDash val="solid"/>
+                      <a:round/>
+                      <a:headEnd type="none" w="med" len="med"/>
+                      <a:tailEnd type="none" w="med" len="med"/>
+                    </a:lnT>
+                    <a:lnB w="6350" cap="flat" cmpd="sng" algn="ctr">
+                      <a:solidFill>
+                        <a:srgbClr val="E2E8F0"/>
+                      </a:solidFill>
+                      <a:prstDash val="solid"/>
+                      <a:round/>
+                      <a:headEnd type="none" w="med" len="med"/>
+                      <a:tailEnd type="none" w="med" len="med"/>
+                    </a:lnB>
+                    <a:solidFill>
+                      <a:srgbClr val="F8FAFC"/>
+                    </a:solidFill>
+                  </a:tcPr>
+                </a:tc>
+                <a:tc>
+                  <a:txBody>
+                    <a:bodyPr/>
+                    <a:lstStyle/>
+                    <a:p>
+                      <a:pPr algn="ctr" indent="0" marL="0">
+                        <a:buNone/>
+                      </a:pPr>
+                      <a:r>
+                        <a:rPr lang="en-US" sz="840" b="1" dirty="0">
+                          <a:solidFill>
+                            <a:srgbClr val="0E7490"/>
+                          </a:solidFill>
+                          <a:latin typeface="Microsoft YaHei" pitchFamily="34" charset="0"/>
+                          <a:ea typeface="Microsoft YaHei" pitchFamily="34" charset="-122"/>
+                          <a:cs typeface="Microsoft YaHei" pitchFamily="34" charset="-120"/>
+                        </a:rPr>
+                        <a:t>20.6%</a:t>
+                      </a:r>
+                      <a:endParaRPr lang="en-US" sz="840" dirty="0">
+                        <a:latin typeface="Microsoft YaHei" charset="0"/>
+                        <a:ea typeface="Microsoft YaHei" charset="0"/>
+                        <a:cs typeface="Microsoft YaHei" charset="0"/>
+                      </a:endParaRPr>
+                    </a:p>
+                  </a:txBody>
+                  <a:tcPr marL="50800" marR="50800" marT="12700" marB="12700" anchor="ctr">
+                    <a:lnL w="6350" cap="flat" cmpd="sng" algn="ctr">
+                      <a:solidFill>
+                        <a:srgbClr val="E2E8F0"/>
+                      </a:solidFill>
+                      <a:prstDash val="solid"/>
+                      <a:round/>
+                      <a:headEnd type="none" w="med" len="med"/>
+                      <a:tailEnd type="none" w="med" len="med"/>
+                    </a:lnL>
+                    <a:lnR w="6350" cap="flat" cmpd="sng" algn="ctr">
+                      <a:solidFill>
+                        <a:srgbClr val="E2E8F0"/>
+                      </a:solidFill>
+                      <a:prstDash val="solid"/>
+                      <a:round/>
+                      <a:headEnd type="none" w="med" len="med"/>
+                      <a:tailEnd type="none" w="med" len="med"/>
+                    </a:lnR>
+                    <a:lnT w="6350" cap="flat" cmpd="sng" algn="ctr">
+                      <a:solidFill>
+                        <a:srgbClr val="E2E8F0"/>
+                      </a:solidFill>
+                      <a:prstDash val="solid"/>
+                      <a:round/>
+                      <a:headEnd type="none" w="med" len="med"/>
+                      <a:tailEnd type="none" w="med" len="med"/>
+                    </a:lnT>
+                    <a:lnB w="6350" cap="flat" cmpd="sng" algn="ctr">
+                      <a:solidFill>
+                        <a:srgbClr val="E2E8F0"/>
+                      </a:solidFill>
+                      <a:prstDash val="solid"/>
+                      <a:round/>
+                      <a:headEnd type="none" w="med" len="med"/>
+                      <a:tailEnd type="none" w="med" len="med"/>
+                    </a:lnB>
+                    <a:solidFill>
+                      <a:srgbClr val="F8FAFC"/>
+                    </a:solidFill>
+                  </a:tcPr>
+                </a:tc>
+                <a:tc>
+                  <a:txBody>
+                    <a:bodyPr/>
+                    <a:lstStyle/>
+                    <a:p>
+                      <a:pPr algn="ctr" indent="0" marL="0">
+                        <a:buNone/>
+                      </a:pPr>
+                      <a:r>
+                        <a:rPr lang="en-US" sz="840" dirty="0">
+                          <a:solidFill>
+                            <a:srgbClr val="B45309"/>
+                          </a:solidFill>
+                          <a:latin typeface="Microsoft YaHei" pitchFamily="34" charset="0"/>
+                          <a:ea typeface="Microsoft YaHei" pitchFamily="34" charset="-122"/>
+                          <a:cs typeface="Microsoft YaHei" pitchFamily="34" charset="-120"/>
+                        </a:rPr>
+                        <a:t>12.2%</a:t>
+                      </a:r>
+                      <a:endParaRPr lang="en-US" sz="840" dirty="0">
+                        <a:latin typeface="Microsoft YaHei" charset="0"/>
+                        <a:ea typeface="Microsoft YaHei" charset="0"/>
+                        <a:cs typeface="Microsoft YaHei" charset="0"/>
+                      </a:endParaRPr>
+                    </a:p>
+                  </a:txBody>
+                  <a:tcPr marL="50800" marR="50800" marT="12700" marB="12700" anchor="ctr">
+                    <a:lnL w="6350" cap="flat" cmpd="sng" algn="ctr">
+                      <a:solidFill>
+                        <a:srgbClr val="E2E8F0"/>
+                      </a:solidFill>
+                      <a:prstDash val="solid"/>
+                      <a:round/>
+                      <a:headEnd type="none" w="med" len="med"/>
+                      <a:tailEnd type="none" w="med" len="med"/>
+                    </a:lnL>
+                    <a:lnR w="6350" cap="flat" cmpd="sng" algn="ctr">
+                      <a:solidFill>
+                        <a:srgbClr val="E2E8F0"/>
+                      </a:solidFill>
+                      <a:prstDash val="solid"/>
+                      <a:round/>
+                      <a:headEnd type="none" w="med" len="med"/>
+                      <a:tailEnd type="none" w="med" len="med"/>
+                    </a:lnR>
+                    <a:lnT w="6350" cap="flat" cmpd="sng" algn="ctr">
+                      <a:solidFill>
+                        <a:srgbClr val="E2E8F0"/>
+                      </a:solidFill>
+                      <a:prstDash val="solid"/>
+                      <a:round/>
+                      <a:headEnd type="none" w="med" len="med"/>
+                      <a:tailEnd type="none" w="med" len="med"/>
+                    </a:lnT>
+                    <a:lnB w="6350" cap="flat" cmpd="sng" algn="ctr">
+                      <a:solidFill>
+                        <a:srgbClr val="E2E8F0"/>
+                      </a:solidFill>
+                      <a:prstDash val="solid"/>
+                      <a:round/>
+                      <a:headEnd type="none" w="med" len="med"/>
+                      <a:tailEnd type="none" w="med" len="med"/>
+                    </a:lnB>
+                    <a:solidFill>
+                      <a:srgbClr val="F8FAFC"/>
+                    </a:solidFill>
+                  </a:tcPr>
+                </a:tc>
+                <a:tc>
+                  <a:txBody>
+                    <a:bodyPr/>
+                    <a:lstStyle/>
+                    <a:p>
+                      <a:pPr algn="ctr" indent="0" marL="0">
+                        <a:buNone/>
+                      </a:pPr>
+                      <a:r>
+                        <a:rPr lang="en-US" sz="840" dirty="0">
+                          <a:solidFill>
+                            <a:srgbClr val="334155"/>
+                          </a:solidFill>
+                          <a:latin typeface="Microsoft YaHei" pitchFamily="34" charset="0"/>
+                          <a:ea typeface="Microsoft YaHei" pitchFamily="34" charset="-122"/>
+                          <a:cs typeface="Microsoft YaHei" pitchFamily="34" charset="-120"/>
+                        </a:rPr>
+                        <a:t>12.2</a:t>
+                      </a:r>
+                      <a:endParaRPr lang="en-US" sz="840" dirty="0">
+                        <a:latin typeface="Microsoft YaHei" charset="0"/>
+                        <a:ea typeface="Microsoft YaHei" charset="0"/>
+                        <a:cs typeface="Microsoft YaHei" charset="0"/>
+                      </a:endParaRPr>
+                    </a:p>
+                  </a:txBody>
+                  <a:tcPr marL="50800" marR="50800" marT="12700" marB="12700" anchor="ctr">
+                    <a:lnL w="6350" cap="flat" cmpd="sng" algn="ctr">
+                      <a:solidFill>
+                        <a:srgbClr val="E2E8F0"/>
+                      </a:solidFill>
+                      <a:prstDash val="solid"/>
+                      <a:round/>
+                      <a:headEnd type="none" w="med" len="med"/>
+                      <a:tailEnd type="none" w="med" len="med"/>
+                    </a:lnL>
+                    <a:lnR w="6350" cap="flat" cmpd="sng" algn="ctr">
+                      <a:solidFill>
+                        <a:srgbClr val="E2E8F0"/>
+                      </a:solidFill>
+                      <a:prstDash val="solid"/>
+                      <a:round/>
+                      <a:headEnd type="none" w="med" len="med"/>
+                      <a:tailEnd type="none" w="med" len="med"/>
+                    </a:lnR>
+                    <a:lnT w="6350" cap="flat" cmpd="sng" algn="ctr">
+                      <a:solidFill>
+                        <a:srgbClr val="E2E8F0"/>
+                      </a:solidFill>
+                      <a:prstDash val="solid"/>
+                      <a:round/>
+                      <a:headEnd type="none" w="med" len="med"/>
+                      <a:tailEnd type="none" w="med" len="med"/>
+                    </a:lnT>
+                    <a:lnB w="6350" cap="flat" cmpd="sng" algn="ctr">
+                      <a:solidFill>
+                        <a:srgbClr val="E2E8F0"/>
+                      </a:solidFill>
+                      <a:prstDash val="solid"/>
+                      <a:round/>
+                      <a:headEnd type="none" w="med" len="med"/>
+                      <a:tailEnd type="none" w="med" len="med"/>
+                    </a:lnB>
+                    <a:solidFill>
+                      <a:srgbClr val="F8FAFC"/>
+                    </a:solidFill>
+                  </a:tcPr>
+                </a:tc>
+                <a:tc>
+                  <a:txBody>
+                    <a:bodyPr/>
+                    <a:lstStyle/>
+                    <a:p>
+                      <a:pPr algn="ctr" indent="0" marL="0">
+                        <a:buNone/>
+                      </a:pPr>
+                      <a:r>
+                        <a:rPr lang="en-US" sz="840" dirty="0">
+                          <a:solidFill>
+                            <a:srgbClr val="334155"/>
+                          </a:solidFill>
+                          <a:latin typeface="Microsoft YaHei" pitchFamily="34" charset="0"/>
+                          <a:ea typeface="Microsoft YaHei" pitchFamily="34" charset="-122"/>
+                          <a:cs typeface="Microsoft YaHei" pitchFamily="34" charset="-120"/>
+                        </a:rPr>
+                        <a:t>10.4</a:t>
+                      </a:r>
+                      <a:endParaRPr lang="en-US" sz="840" dirty="0">
+                        <a:latin typeface="Microsoft YaHei" charset="0"/>
+                        <a:ea typeface="Microsoft YaHei" charset="0"/>
+                        <a:cs typeface="Microsoft YaHei" charset="0"/>
+                      </a:endParaRPr>
+                    </a:p>
+                  </a:txBody>
+                  <a:tcPr marL="50800" marR="50800" marT="12700" marB="12700" anchor="ctr">
+                    <a:lnL w="6350" cap="flat" cmpd="sng" algn="ctr">
+                      <a:solidFill>
+                        <a:srgbClr val="E2E8F0"/>
+                      </a:solidFill>
+                      <a:prstDash val="solid"/>
+                      <a:round/>
+                      <a:headEnd type="none" w="med" len="med"/>
+                      <a:tailEnd type="none" w="med" len="med"/>
+                    </a:lnL>
+                    <a:lnR w="6350" cap="flat" cmpd="sng" algn="ctr">
+                      <a:solidFill>
+                        <a:srgbClr val="E2E8F0"/>
+                      </a:solidFill>
+                      <a:prstDash val="solid"/>
+                      <a:round/>
+                      <a:headEnd type="none" w="med" len="med"/>
+                      <a:tailEnd type="none" w="med" len="med"/>
+                    </a:lnR>
+                    <a:lnT w="6350" cap="flat" cmpd="sng" algn="ctr">
+                      <a:solidFill>
+                        <a:srgbClr val="E2E8F0"/>
+                      </a:solidFill>
+                      <a:prstDash val="solid"/>
+                      <a:round/>
+                      <a:headEnd type="none" w="med" len="med"/>
+                      <a:tailEnd type="none" w="med" len="med"/>
+                    </a:lnT>
+                    <a:lnB w="6350" cap="flat" cmpd="sng" algn="ctr">
+                      <a:solidFill>
+                        <a:srgbClr val="E2E8F0"/>
+                      </a:solidFill>
+                      <a:prstDash val="solid"/>
+                      <a:round/>
+                      <a:headEnd type="none" w="med" len="med"/>
+                      <a:tailEnd type="none" w="med" len="med"/>
+                    </a:lnB>
+                    <a:solidFill>
+                      <a:srgbClr val="F8FAFC"/>
+                    </a:solidFill>
+                  </a:tcPr>
+                </a:tc>
+              </a:tr>
+              <a:tr h="274320">
+                <a:tc>
+                  <a:txBody>
+                    <a:bodyPr/>
+                    <a:lstStyle/>
+                    <a:p>
+                      <a:pPr algn="l" indent="0" marL="0">
+                        <a:buNone/>
+                      </a:pPr>
+                      <a:r>
+                        <a:rPr lang="en-US" sz="840" b="1" dirty="0">
+                          <a:solidFill>
+                            <a:srgbClr val="1E293B"/>
+                          </a:solidFill>
+                          <a:latin typeface="Microsoft YaHei" pitchFamily="34" charset="0"/>
+                          <a:ea typeface="Microsoft YaHei" pitchFamily="34" charset="-122"/>
+                          <a:cs typeface="Microsoft YaHei" pitchFamily="34" charset="-120"/>
+                        </a:rPr>
+                        <a:t>Q9 离群成员</a:t>
+                      </a:r>
+                      <a:endParaRPr lang="en-US" sz="840" dirty="0">
+                        <a:latin typeface="Microsoft YaHei" charset="0"/>
+                        <a:ea typeface="Microsoft YaHei" charset="0"/>
+                        <a:cs typeface="Microsoft YaHei" charset="0"/>
+                      </a:endParaRPr>
+                    </a:p>
+                  </a:txBody>
+                  <a:tcPr marL="50800" marR="50800" marT="12700" marB="12700" anchor="ctr">
+                    <a:lnL w="6350" cap="flat" cmpd="sng" algn="ctr">
+                      <a:solidFill>
+                        <a:srgbClr val="E2E8F0"/>
+                      </a:solidFill>
+                      <a:prstDash val="solid"/>
+                      <a:round/>
+                      <a:headEnd type="none" w="med" len="med"/>
+                      <a:tailEnd type="none" w="med" len="med"/>
+                    </a:lnL>
+                    <a:lnR w="6350" cap="flat" cmpd="sng" algn="ctr">
+                      <a:solidFill>
+                        <a:srgbClr val="E2E8F0"/>
+                      </a:solidFill>
+                      <a:prstDash val="solid"/>
+                      <a:round/>
+                      <a:headEnd type="none" w="med" len="med"/>
+                      <a:tailEnd type="none" w="med" len="med"/>
+                    </a:lnR>
+                    <a:lnT w="6350" cap="flat" cmpd="sng" algn="ctr">
+                      <a:solidFill>
+                        <a:srgbClr val="E2E8F0"/>
+                      </a:solidFill>
+                      <a:prstDash val="solid"/>
+                      <a:round/>
+                      <a:headEnd type="none" w="med" len="med"/>
+                      <a:tailEnd type="none" w="med" len="med"/>
+                    </a:lnT>
+                    <a:lnB w="6350" cap="flat" cmpd="sng" algn="ctr">
+                      <a:solidFill>
+                        <a:srgbClr val="E2E8F0"/>
+                      </a:solidFill>
+                      <a:prstDash val="solid"/>
+                      <a:round/>
+                      <a:headEnd type="none" w="med" len="med"/>
+                      <a:tailEnd type="none" w="med" len="med"/>
+                    </a:lnB>
+                    <a:solidFill>
+                      <a:srgbClr val="FFFFFF"/>
+                    </a:solidFill>
+                  </a:tcPr>
+                </a:tc>
+                <a:tc>
+                  <a:txBody>
+                    <a:bodyPr/>
+                    <a:lstStyle/>
+                    <a:p>
+                      <a:pPr algn="ctr" indent="0" marL="0">
+                        <a:buNone/>
+                      </a:pPr>
+                      <a:r>
+                        <a:rPr lang="en-US" sz="840" b="1" dirty="0">
+                          <a:solidFill>
+                            <a:srgbClr val="0E7490"/>
+                          </a:solidFill>
+                          <a:latin typeface="Microsoft YaHei" pitchFamily="34" charset="0"/>
+                          <a:ea typeface="Microsoft YaHei" pitchFamily="34" charset="-122"/>
+                          <a:cs typeface="Microsoft YaHei" pitchFamily="34" charset="-120"/>
+                        </a:rPr>
+                        <a:t>10.0%</a:t>
+                      </a:r>
+                      <a:endParaRPr lang="en-US" sz="840" dirty="0">
+                        <a:latin typeface="Microsoft YaHei" charset="0"/>
+                        <a:ea typeface="Microsoft YaHei" charset="0"/>
+                        <a:cs typeface="Microsoft YaHei" charset="0"/>
+                      </a:endParaRPr>
+                    </a:p>
+                  </a:txBody>
+                  <a:tcPr marL="50800" marR="50800" marT="12700" marB="12700" anchor="ctr">
+                    <a:lnL w="6350" cap="flat" cmpd="sng" algn="ctr">
+                      <a:solidFill>
+                        <a:srgbClr val="E2E8F0"/>
+                      </a:solidFill>
+                      <a:prstDash val="solid"/>
+                      <a:round/>
+                      <a:headEnd type="none" w="med" len="med"/>
+                      <a:tailEnd type="none" w="med" len="med"/>
+                    </a:lnL>
+                    <a:lnR w="6350" cap="flat" cmpd="sng" algn="ctr">
+                      <a:solidFill>
+                        <a:srgbClr val="E2E8F0"/>
+                      </a:solidFill>
+                      <a:prstDash val="solid"/>
+                      <a:round/>
+                      <a:headEnd type="none" w="med" len="med"/>
+                      <a:tailEnd type="none" w="med" len="med"/>
+                    </a:lnR>
+                    <a:lnT w="6350" cap="flat" cmpd="sng" algn="ctr">
+                      <a:solidFill>
+                        <a:srgbClr val="E2E8F0"/>
+                      </a:solidFill>
+                      <a:prstDash val="solid"/>
+                      <a:round/>
+                      <a:headEnd type="none" w="med" len="med"/>
+                      <a:tailEnd type="none" w="med" len="med"/>
+                    </a:lnT>
+                    <a:lnB w="6350" cap="flat" cmpd="sng" algn="ctr">
+                      <a:solidFill>
+                        <a:srgbClr val="E2E8F0"/>
+                      </a:solidFill>
+                      <a:prstDash val="solid"/>
+                      <a:round/>
+                      <a:headEnd type="none" w="med" len="med"/>
+                      <a:tailEnd type="none" w="med" len="med"/>
+                    </a:lnB>
+                    <a:solidFill>
+                      <a:srgbClr val="FFFFFF"/>
+                    </a:solidFill>
+                  </a:tcPr>
+                </a:tc>
+                <a:tc>
+                  <a:txBody>
+                    <a:bodyPr/>
+                    <a:lstStyle/>
+                    <a:p>
+                      <a:pPr algn="ctr" indent="0" marL="0">
+                        <a:buNone/>
+                      </a:pPr>
+                      <a:r>
+                        <a:rPr lang="en-US" sz="840" dirty="0">
+                          <a:solidFill>
+                            <a:srgbClr val="B45309"/>
+                          </a:solidFill>
+                          <a:latin typeface="Microsoft YaHei" pitchFamily="34" charset="0"/>
+                          <a:ea typeface="Microsoft YaHei" pitchFamily="34" charset="-122"/>
+                          <a:cs typeface="Microsoft YaHei" pitchFamily="34" charset="-120"/>
+                        </a:rPr>
+                        <a:t>10.0%</a:t>
+                      </a:r>
+                      <a:endParaRPr lang="en-US" sz="840" dirty="0">
+                        <a:latin typeface="Microsoft YaHei" charset="0"/>
+                        <a:ea typeface="Microsoft YaHei" charset="0"/>
+                        <a:cs typeface="Microsoft YaHei" charset="0"/>
+                      </a:endParaRPr>
+                    </a:p>
+                  </a:txBody>
+                  <a:tcPr marL="50800" marR="50800" marT="12700" marB="12700" anchor="ctr">
+                    <a:lnL w="6350" cap="flat" cmpd="sng" algn="ctr">
+                      <a:solidFill>
+                        <a:srgbClr val="E2E8F0"/>
+                      </a:solidFill>
+                      <a:prstDash val="solid"/>
+                      <a:round/>
+                      <a:headEnd type="none" w="med" len="med"/>
+                      <a:tailEnd type="none" w="med" len="med"/>
+                    </a:lnL>
+                    <a:lnR w="6350" cap="flat" cmpd="sng" algn="ctr">
+                      <a:solidFill>
+                        <a:srgbClr val="E2E8F0"/>
+                      </a:solidFill>
+                      <a:prstDash val="solid"/>
+                      <a:round/>
+                      <a:headEnd type="none" w="med" len="med"/>
+                      <a:tailEnd type="none" w="med" len="med"/>
+                    </a:lnR>
+                    <a:lnT w="6350" cap="flat" cmpd="sng" algn="ctr">
+                      <a:solidFill>
+                        <a:srgbClr val="E2E8F0"/>
+                      </a:solidFill>
+                      <a:prstDash val="solid"/>
+                      <a:round/>
+                      <a:headEnd type="none" w="med" len="med"/>
+                      <a:tailEnd type="none" w="med" len="med"/>
+                    </a:lnT>
+                    <a:lnB w="6350" cap="flat" cmpd="sng" algn="ctr">
+                      <a:solidFill>
+                        <a:srgbClr val="E2E8F0"/>
+                      </a:solidFill>
+                      <a:prstDash val="solid"/>
+                      <a:round/>
+                      <a:headEnd type="none" w="med" len="med"/>
+                      <a:tailEnd type="none" w="med" len="med"/>
+                    </a:lnB>
+                    <a:solidFill>
+                      <a:srgbClr val="FFFFFF"/>
+                    </a:solidFill>
+                  </a:tcPr>
+                </a:tc>
+                <a:tc>
+                  <a:txBody>
+                    <a:bodyPr/>
+                    <a:lstStyle/>
+                    <a:p>
+                      <a:pPr algn="ctr" indent="0" marL="0">
+                        <a:buNone/>
+                      </a:pPr>
+                      <a:r>
+                        <a:rPr lang="en-US" sz="840" dirty="0">
+                          <a:solidFill>
+                            <a:srgbClr val="334155"/>
+                          </a:solidFill>
+                          <a:latin typeface="Microsoft YaHei" pitchFamily="34" charset="0"/>
+                          <a:ea typeface="Microsoft YaHei" pitchFamily="34" charset="-122"/>
+                          <a:cs typeface="Microsoft YaHei" pitchFamily="34" charset="-120"/>
+                        </a:rPr>
+                        <a:t>8.2</a:t>
+                      </a:r>
+                      <a:endParaRPr lang="en-US" sz="840" dirty="0">
+                        <a:latin typeface="Microsoft YaHei" charset="0"/>
+                        <a:ea typeface="Microsoft YaHei" charset="0"/>
+                        <a:cs typeface="Microsoft YaHei" charset="0"/>
+                      </a:endParaRPr>
+                    </a:p>
+                  </a:txBody>
+                  <a:tcPr marL="50800" marR="50800" marT="12700" marB="12700" anchor="ctr">
+                    <a:lnL w="6350" cap="flat" cmpd="sng" algn="ctr">
+                      <a:solidFill>
+                        <a:srgbClr val="E2E8F0"/>
+                      </a:solidFill>
+                      <a:prstDash val="solid"/>
+                      <a:round/>
+                      <a:headEnd type="none" w="med" len="med"/>
+                      <a:tailEnd type="none" w="med" len="med"/>
+                    </a:lnL>
+                    <a:lnR w="6350" cap="flat" cmpd="sng" algn="ctr">
+                      <a:solidFill>
+                        <a:srgbClr val="E2E8F0"/>
+                      </a:solidFill>
+                      <a:prstDash val="solid"/>
+                      <a:round/>
+                      <a:headEnd type="none" w="med" len="med"/>
+                      <a:tailEnd type="none" w="med" len="med"/>
+                    </a:lnR>
+                    <a:lnT w="6350" cap="flat" cmpd="sng" algn="ctr">
+                      <a:solidFill>
+                        <a:srgbClr val="E2E8F0"/>
+                      </a:solidFill>
+                      <a:prstDash val="solid"/>
+                      <a:round/>
+                      <a:headEnd type="none" w="med" len="med"/>
+                      <a:tailEnd type="none" w="med" len="med"/>
+                    </a:lnT>
+                    <a:lnB w="6350" cap="flat" cmpd="sng" algn="ctr">
+                      <a:solidFill>
+                        <a:srgbClr val="E2E8F0"/>
+                      </a:solidFill>
+                      <a:prstDash val="solid"/>
+                      <a:round/>
+                      <a:headEnd type="none" w="med" len="med"/>
+                      <a:tailEnd type="none" w="med" len="med"/>
+                    </a:lnB>
+                    <a:solidFill>
+                      <a:srgbClr val="FFFFFF"/>
+                    </a:solidFill>
+                  </a:tcPr>
+                </a:tc>
+                <a:tc>
+                  <a:txBody>
+                    <a:bodyPr/>
+                    <a:lstStyle/>
+                    <a:p>
+                      <a:pPr algn="ctr" indent="0" marL="0">
+                        <a:buNone/>
+                      </a:pPr>
+                      <a:r>
+                        <a:rPr lang="en-US" sz="840" dirty="0">
+                          <a:solidFill>
+                            <a:srgbClr val="334155"/>
+                          </a:solidFill>
+                          <a:latin typeface="Microsoft YaHei" pitchFamily="34" charset="0"/>
+                          <a:ea typeface="Microsoft YaHei" pitchFamily="34" charset="-122"/>
+                          <a:cs typeface="Microsoft YaHei" pitchFamily="34" charset="-120"/>
+                        </a:rPr>
+                        <a:t>10.4</a:t>
+                      </a:r>
+                      <a:endParaRPr lang="en-US" sz="840" dirty="0">
+                        <a:latin typeface="Microsoft YaHei" charset="0"/>
+                        <a:ea typeface="Microsoft YaHei" charset="0"/>
+                        <a:cs typeface="Microsoft YaHei" charset="0"/>
+                      </a:endParaRPr>
+                    </a:p>
+                  </a:txBody>
+                  <a:tcPr marL="50800" marR="50800" marT="12700" marB="12700" anchor="ctr">
+                    <a:lnL w="6350" cap="flat" cmpd="sng" algn="ctr">
+                      <a:solidFill>
+                        <a:srgbClr val="E2E8F0"/>
+                      </a:solidFill>
+                      <a:prstDash val="solid"/>
+                      <a:round/>
+                      <a:headEnd type="none" w="med" len="med"/>
+                      <a:tailEnd type="none" w="med" len="med"/>
+                    </a:lnL>
+                    <a:lnR w="6350" cap="flat" cmpd="sng" algn="ctr">
+                      <a:solidFill>
+                        <a:srgbClr val="E2E8F0"/>
+                      </a:solidFill>
+                      <a:prstDash val="solid"/>
+                      <a:round/>
+                      <a:headEnd type="none" w="med" len="med"/>
+                      <a:tailEnd type="none" w="med" len="med"/>
+                    </a:lnR>
+                    <a:lnT w="6350" cap="flat" cmpd="sng" algn="ctr">
+                      <a:solidFill>
+                        <a:srgbClr val="E2E8F0"/>
+                      </a:solidFill>
+                      <a:prstDash val="solid"/>
+                      <a:round/>
+                      <a:headEnd type="none" w="med" len="med"/>
+                      <a:tailEnd type="none" w="med" len="med"/>
+                    </a:lnT>
+                    <a:lnB w="6350" cap="flat" cmpd="sng" algn="ctr">
+                      <a:solidFill>
+                        <a:srgbClr val="E2E8F0"/>
+                      </a:solidFill>
+                      <a:prstDash val="solid"/>
+                      <a:round/>
+                      <a:headEnd type="none" w="med" len="med"/>
+                      <a:tailEnd type="none" w="med" len="med"/>
+                    </a:lnB>
+                    <a:solidFill>
+                      <a:srgbClr val="FFFFFF"/>
+                    </a:solidFill>
+                  </a:tcPr>
+                </a:tc>
+              </a:tr>
+              <a:tr h="292608">
+                <a:tc>
+                  <a:txBody>
+                    <a:bodyPr/>
+                    <a:lstStyle/>
+                    <a:p>
+                      <a:pPr algn="l" indent="0" marL="0">
+                        <a:buNone/>
+                      </a:pPr>
+                      <a:r>
+                        <a:rPr lang="en-US" sz="860" b="1" dirty="0">
+                          <a:solidFill>
+                            <a:srgbClr val="FFFFFF"/>
+                          </a:solidFill>
+                          <a:latin typeface="Microsoft YaHei" pitchFamily="34" charset="0"/>
+                          <a:ea typeface="Microsoft YaHei" pitchFamily="34" charset="-122"/>
+                          <a:cs typeface="Microsoft YaHei" pitchFamily="34" charset="-120"/>
+                        </a:rPr>
+                        <a:t>总体</a:t>
+                      </a:r>
+                      <a:endParaRPr lang="en-US" sz="860" dirty="0">
+                        <a:latin typeface="Microsoft YaHei" charset="0"/>
+                        <a:ea typeface="Microsoft YaHei" charset="0"/>
+                        <a:cs typeface="Microsoft YaHei" charset="0"/>
+                      </a:endParaRPr>
+                    </a:p>
+                  </a:txBody>
+                  <a:tcPr marL="50800" marR="50800" marT="12700" marB="12700" anchor="ctr">
+                    <a:lnL w="6350" cap="flat" cmpd="sng" algn="ctr">
+                      <a:solidFill>
+                        <a:srgbClr val="E2E8F0"/>
+                      </a:solidFill>
+                      <a:prstDash val="solid"/>
+                      <a:round/>
+                      <a:headEnd type="none" w="med" len="med"/>
+                      <a:tailEnd type="none" w="med" len="med"/>
+                    </a:lnL>
+                    <a:lnR w="6350" cap="flat" cmpd="sng" algn="ctr">
+                      <a:solidFill>
+                        <a:srgbClr val="E2E8F0"/>
+                      </a:solidFill>
+                      <a:prstDash val="solid"/>
+                      <a:round/>
+                      <a:headEnd type="none" w="med" len="med"/>
+                      <a:tailEnd type="none" w="med" len="med"/>
+                    </a:lnR>
+                    <a:lnT w="6350" cap="flat" cmpd="sng" algn="ctr">
+                      <a:solidFill>
+                        <a:srgbClr val="E2E8F0"/>
+                      </a:solidFill>
+                      <a:prstDash val="solid"/>
+                      <a:round/>
+                      <a:headEnd type="none" w="med" len="med"/>
+                      <a:tailEnd type="none" w="med" len="med"/>
+                    </a:lnT>
+                    <a:lnB w="6350" cap="flat" cmpd="sng" algn="ctr">
+                      <a:solidFill>
+                        <a:srgbClr val="E2E8F0"/>
+                      </a:solidFill>
+                      <a:prstDash val="solid"/>
+                      <a:round/>
+                      <a:headEnd type="none" w="med" len="med"/>
+                      <a:tailEnd type="none" w="med" len="med"/>
+                    </a:lnB>
+                    <a:solidFill>
+                      <a:srgbClr val="12183A"/>
+                    </a:solidFill>
+                  </a:tcPr>
+                </a:tc>
+                <a:tc>
+                  <a:txBody>
+                    <a:bodyPr/>
+                    <a:lstStyle/>
+                    <a:p>
+                      <a:pPr algn="ctr" indent="0" marL="0">
+                        <a:buNone/>
+                      </a:pPr>
+                      <a:r>
+                        <a:rPr lang="en-US" sz="840" b="1" dirty="0">
+                          <a:solidFill>
+                            <a:srgbClr val="FFFFFF"/>
+                          </a:solidFill>
+                          <a:latin typeface="Microsoft YaHei" pitchFamily="34" charset="0"/>
+                          <a:ea typeface="Microsoft YaHei" pitchFamily="34" charset="-122"/>
+                          <a:cs typeface="Microsoft YaHei" pitchFamily="34" charset="-120"/>
+                        </a:rPr>
+                        <a:t>28.6%</a:t>
+                      </a:r>
+                      <a:endParaRPr lang="en-US" sz="840" dirty="0">
+                        <a:latin typeface="Microsoft YaHei" charset="0"/>
+                        <a:ea typeface="Microsoft YaHei" charset="0"/>
+                        <a:cs typeface="Microsoft YaHei" charset="0"/>
+                      </a:endParaRPr>
+                    </a:p>
+                  </a:txBody>
+                  <a:tcPr marL="50800" marR="50800" marT="12700" marB="12700" anchor="ctr">
+                    <a:lnL w="6350" cap="flat" cmpd="sng" algn="ctr">
+                      <a:solidFill>
+                        <a:srgbClr val="E2E8F0"/>
+                      </a:solidFill>
+                      <a:prstDash val="solid"/>
+                      <a:round/>
+                      <a:headEnd type="none" w="med" len="med"/>
+                      <a:tailEnd type="none" w="med" len="med"/>
+                    </a:lnL>
+                    <a:lnR w="6350" cap="flat" cmpd="sng" algn="ctr">
+                      <a:solidFill>
+                        <a:srgbClr val="E2E8F0"/>
+                      </a:solidFill>
+                      <a:prstDash val="solid"/>
+                      <a:round/>
+                      <a:headEnd type="none" w="med" len="med"/>
+                      <a:tailEnd type="none" w="med" len="med"/>
+                    </a:lnR>
+                    <a:lnT w="6350" cap="flat" cmpd="sng" algn="ctr">
+                      <a:solidFill>
+                        <a:srgbClr val="E2E8F0"/>
+                      </a:solidFill>
+                      <a:prstDash val="solid"/>
+                      <a:round/>
+                      <a:headEnd type="none" w="med" len="med"/>
+                      <a:tailEnd type="none" w="med" len="med"/>
+                    </a:lnT>
+                    <a:lnB w="6350" cap="flat" cmpd="sng" algn="ctr">
+                      <a:solidFill>
+                        <a:srgbClr val="E2E8F0"/>
+                      </a:solidFill>
+                      <a:prstDash val="solid"/>
+                      <a:round/>
+                      <a:headEnd type="none" w="med" len="med"/>
+                      <a:tailEnd type="none" w="med" len="med"/>
+                    </a:lnB>
+                    <a:solidFill>
+                      <a:srgbClr val="12183A"/>
+                    </a:solidFill>
+                  </a:tcPr>
+                </a:tc>
+                <a:tc>
+                  <a:txBody>
+                    <a:bodyPr/>
+                    <a:lstStyle/>
+                    <a:p>
+                      <a:pPr algn="ctr" indent="0" marL="0">
+                        <a:buNone/>
+                      </a:pPr>
+                      <a:r>
+                        <a:rPr lang="en-US" sz="840" b="1" dirty="0">
+                          <a:solidFill>
+                            <a:srgbClr val="FFFFFF"/>
+                          </a:solidFill>
+                          <a:latin typeface="Microsoft YaHei" pitchFamily="34" charset="0"/>
+                          <a:ea typeface="Microsoft YaHei" pitchFamily="34" charset="-122"/>
+                          <a:cs typeface="Microsoft YaHei" pitchFamily="34" charset="-120"/>
+                        </a:rPr>
+                        <a:t>13.7%</a:t>
+                      </a:r>
+                      <a:endParaRPr lang="en-US" sz="840" dirty="0">
+                        <a:latin typeface="Microsoft YaHei" charset="0"/>
+                        <a:ea typeface="Microsoft YaHei" charset="0"/>
+                        <a:cs typeface="Microsoft YaHei" charset="0"/>
+                      </a:endParaRPr>
+                    </a:p>
+                  </a:txBody>
+                  <a:tcPr marL="50800" marR="50800" marT="12700" marB="12700" anchor="ctr">
+                    <a:lnL w="6350" cap="flat" cmpd="sng" algn="ctr">
+                      <a:solidFill>
+                        <a:srgbClr val="E2E8F0"/>
+                      </a:solidFill>
+                      <a:prstDash val="solid"/>
+                      <a:round/>
+                      <a:headEnd type="none" w="med" len="med"/>
+                      <a:tailEnd type="none" w="med" len="med"/>
+                    </a:lnL>
+                    <a:lnR w="6350" cap="flat" cmpd="sng" algn="ctr">
+                      <a:solidFill>
+                        <a:srgbClr val="E2E8F0"/>
+                      </a:solidFill>
+                      <a:prstDash val="solid"/>
+                      <a:round/>
+                      <a:headEnd type="none" w="med" len="med"/>
+                      <a:tailEnd type="none" w="med" len="med"/>
+                    </a:lnR>
+                    <a:lnT w="6350" cap="flat" cmpd="sng" algn="ctr">
+                      <a:solidFill>
+                        <a:srgbClr val="E2E8F0"/>
+                      </a:solidFill>
+                      <a:prstDash val="solid"/>
+                      <a:round/>
+                      <a:headEnd type="none" w="med" len="med"/>
+                      <a:tailEnd type="none" w="med" len="med"/>
+                    </a:lnT>
+                    <a:lnB w="6350" cap="flat" cmpd="sng" algn="ctr">
+                      <a:solidFill>
+                        <a:srgbClr val="E2E8F0"/>
+                      </a:solidFill>
+                      <a:prstDash val="solid"/>
+                      <a:round/>
+                      <a:headEnd type="none" w="med" len="med"/>
+                      <a:tailEnd type="none" w="med" len="med"/>
+                    </a:lnB>
+                    <a:solidFill>
+                      <a:srgbClr val="12183A"/>
+                    </a:solidFill>
+                  </a:tcPr>
+                </a:tc>
+                <a:tc>
+                  <a:txBody>
+                    <a:bodyPr/>
+                    <a:lstStyle/>
+                    <a:p>
+                      <a:pPr algn="ctr" indent="0" marL="0">
+                        <a:buNone/>
+                      </a:pPr>
+                      <a:r>
+                        <a:rPr lang="en-US" sz="840" dirty="0">
+                          <a:solidFill>
+                            <a:srgbClr val="FFFFFF"/>
+                          </a:solidFill>
+                          <a:latin typeface="Microsoft YaHei" pitchFamily="34" charset="0"/>
+                          <a:ea typeface="Microsoft YaHei" pitchFamily="34" charset="-122"/>
+                          <a:cs typeface="Microsoft YaHei" pitchFamily="34" charset="-120"/>
+                        </a:rPr>
+                        <a:t>15.7</a:t>
+                      </a:r>
+                      <a:endParaRPr lang="en-US" sz="840" dirty="0">
+                        <a:latin typeface="Microsoft YaHei" charset="0"/>
+                        <a:ea typeface="Microsoft YaHei" charset="0"/>
+                        <a:cs typeface="Microsoft YaHei" charset="0"/>
+                      </a:endParaRPr>
+                    </a:p>
+                  </a:txBody>
+                  <a:tcPr marL="50800" marR="50800" marT="12700" marB="12700" anchor="ctr">
+                    <a:lnL w="6350" cap="flat" cmpd="sng" algn="ctr">
+                      <a:solidFill>
+                        <a:srgbClr val="E2E8F0"/>
+                      </a:solidFill>
+                      <a:prstDash val="solid"/>
+                      <a:round/>
+                      <a:headEnd type="none" w="med" len="med"/>
+                      <a:tailEnd type="none" w="med" len="med"/>
+                    </a:lnL>
+                    <a:lnR w="6350" cap="flat" cmpd="sng" algn="ctr">
+                      <a:solidFill>
+                        <a:srgbClr val="E2E8F0"/>
+                      </a:solidFill>
+                      <a:prstDash val="solid"/>
+                      <a:round/>
+                      <a:headEnd type="none" w="med" len="med"/>
+                      <a:tailEnd type="none" w="med" len="med"/>
+                    </a:lnR>
+                    <a:lnT w="6350" cap="flat" cmpd="sng" algn="ctr">
+                      <a:solidFill>
+                        <a:srgbClr val="E2E8F0"/>
+                      </a:solidFill>
+                      <a:prstDash val="solid"/>
+                      <a:round/>
+                      <a:headEnd type="none" w="med" len="med"/>
+                      <a:tailEnd type="none" w="med" len="med"/>
+                    </a:lnT>
+                    <a:lnB w="6350" cap="flat" cmpd="sng" algn="ctr">
+                      <a:solidFill>
+                        <a:srgbClr val="E2E8F0"/>
+                      </a:solidFill>
+                      <a:prstDash val="solid"/>
+                      <a:round/>
+                      <a:headEnd type="none" w="med" len="med"/>
+                      <a:tailEnd type="none" w="med" len="med"/>
+                    </a:lnB>
+                    <a:solidFill>
+                      <a:srgbClr val="12183A"/>
+                    </a:solidFill>
+                  </a:tcPr>
+                </a:tc>
+                <a:tc>
+                  <a:txBody>
+                    <a:bodyPr/>
+                    <a:lstStyle/>
+                    <a:p>
+                      <a:pPr algn="ctr" indent="0" marL="0">
+                        <a:buNone/>
+                      </a:pPr>
+                      <a:r>
+                        <a:rPr lang="en-US" sz="840" dirty="0">
+                          <a:solidFill>
+                            <a:srgbClr val="FFFFFF"/>
+                          </a:solidFill>
+                          <a:latin typeface="Microsoft YaHei" pitchFamily="34" charset="0"/>
+                          <a:ea typeface="Microsoft YaHei" pitchFamily="34" charset="-122"/>
+                          <a:cs typeface="Microsoft YaHei" pitchFamily="34" charset="-120"/>
+                        </a:rPr>
+                        <a:t>10.5</a:t>
+                      </a:r>
+                      <a:endParaRPr lang="en-US" sz="840" dirty="0">
+                        <a:latin typeface="Microsoft YaHei" charset="0"/>
+                        <a:ea typeface="Microsoft YaHei" charset="0"/>
+                        <a:cs typeface="Microsoft YaHei" charset="0"/>
+                      </a:endParaRPr>
+                    </a:p>
+                  </a:txBody>
+                  <a:tcPr marL="50800" marR="50800" marT="12700" marB="12700" anchor="ctr">
+                    <a:lnL w="6350" cap="flat" cmpd="sng" algn="ctr">
+                      <a:solidFill>
+                        <a:srgbClr val="E2E8F0"/>
+                      </a:solidFill>
+                      <a:prstDash val="solid"/>
+                      <a:round/>
+                      <a:headEnd type="none" w="med" len="med"/>
+                      <a:tailEnd type="none" w="med" len="med"/>
+                    </a:lnL>
+                    <a:lnR w="6350" cap="flat" cmpd="sng" algn="ctr">
+                      <a:solidFill>
+                        <a:srgbClr val="E2E8F0"/>
+                      </a:solidFill>
+                      <a:prstDash val="solid"/>
+                      <a:round/>
+                      <a:headEnd type="none" w="med" len="med"/>
+                      <a:tailEnd type="none" w="med" len="med"/>
+                    </a:lnR>
+                    <a:lnT w="6350" cap="flat" cmpd="sng" algn="ctr">
+                      <a:solidFill>
+                        <a:srgbClr val="E2E8F0"/>
+                      </a:solidFill>
+                      <a:prstDash val="solid"/>
+                      <a:round/>
+                      <a:headEnd type="none" w="med" len="med"/>
+                      <a:tailEnd type="none" w="med" len="med"/>
+                    </a:lnT>
+                    <a:lnB w="6350" cap="flat" cmpd="sng" algn="ctr">
+                      <a:solidFill>
+                        <a:srgbClr val="E2E8F0"/>
+                      </a:solidFill>
+                      <a:prstDash val="solid"/>
+                      <a:round/>
+                      <a:headEnd type="none" w="med" len="med"/>
+                      <a:tailEnd type="none" w="med" len="med"/>
+                    </a:lnB>
+                    <a:solidFill>
+                      <a:srgbClr val="12183A"/>
+                    </a:solidFill>
+                  </a:tcPr>
+                </a:tc>
+              </a:tr>
+            </a:tbl>
+          </a:graphicData>
+        </a:graphic>
+      </p:graphicFrame>
+      <p:sp>
+        <p:nvSpPr>
+          <p:cNvPr id="6" name="Shape 3"/>
+          <p:cNvSpPr/>
+          <p:nvPr/>
+        </p:nvSpPr>
+        <p:spPr>
+          <a:xfrm>
+            <a:off x="457200" y="4526280"/>
+            <a:ext cx="8229600" cy="457200"/>
+          </a:xfrm>
+          <a:prstGeom prst="rect">
+            <a:avLst/>
+          </a:prstGeom>
+          <a:solidFill>
+            <a:srgbClr val="E0F4F9"/>
+          </a:solidFill>
+          <a:ln/>
+          <a:effectLst>
+            <a:outerShdw sx="100000" sy="100000" kx="0" ky="0" algn="bl" rotWithShape="0" blurRad="101600" dist="38100" dir="8100000">
+              <a:srgbClr val="0F172A">
+                <a:alpha val="12000"/>
+              </a:srgbClr>
+            </a:outerShdw>
+          </a:effectLst>
+        </p:spPr>
+      </p:sp>
+      <p:sp>
+        <p:nvSpPr>
+          <p:cNvPr id="7" name="Shape 4"/>
+          <p:cNvSpPr/>
+          <p:nvPr/>
+        </p:nvSpPr>
+        <p:spPr>
+          <a:xfrm>
+            <a:off x="457200" y="4526280"/>
+            <a:ext cx="54864" cy="457200"/>
+          </a:xfrm>
+          <a:prstGeom prst="rect">
+            <a:avLst/>
+          </a:prstGeom>
+          <a:solidFill>
+            <a:srgbClr val="0EA5C4"/>
+          </a:solidFill>
+          <a:ln/>
+        </p:spPr>
+      </p:sp>
+      <p:sp>
+        <p:nvSpPr>
+          <p:cNvPr id="8" name="Text 5"/>
+          <p:cNvSpPr/>
+          <p:nvPr/>
+        </p:nvSpPr>
+        <p:spPr>
+          <a:xfrm>
+            <a:off x="640080" y="4526280"/>
+            <a:ext cx="7863840" cy="457200"/>
+          </a:xfrm>
+          <a:prstGeom prst="rect">
+            <a:avLst/>
+          </a:prstGeom>
+          <a:noFill/>
+          <a:ln/>
+        </p:spPr>
+        <p:txBody>
+          <a:bodyPr wrap="square" lIns="0" tIns="0" rIns="0" bIns="0" rtlCol="0" anchor="ctr"/>
+          <a:lstStyle/>
+          <a:p>
+            <a:pPr indent="0" marL="0">
+              <a:lnSpc>
+                <a:spcPct val="105000"/>
+              </a:lnSpc>
+              <a:buNone/>
+            </a:pPr>
+            <a:r>
+              <a:rPr lang="en-US" sz="860" b="1" dirty="0">
+                <a:solidFill>
+                  <a:srgbClr val="0E7490"/>
+                </a:solidFill>
+                <a:latin typeface="Microsoft YaHei" pitchFamily="34" charset="0"/>
+                <a:ea typeface="Microsoft YaHei" pitchFamily="34" charset="-122"/>
+                <a:cs typeface="Microsoft YaHei" pitchFamily="34" charset="-120"/>
+              </a:rPr>
+              <a:t>看点：</a:t>
+            </a:r>
+            <a:pPr indent="0" marL="0">
+              <a:lnSpc>
+                <a:spcPct val="105000"/>
+              </a:lnSpc>
+              <a:buNone/>
+            </a:pPr>
+            <a:r>
+              <a:rPr lang="en-US" sz="860" dirty="0">
+                <a:solidFill>
+                  <a:srgbClr val="334155"/>
+                </a:solidFill>
+                <a:latin typeface="Microsoft YaHei" pitchFamily="34" charset="0"/>
+                <a:ea typeface="Microsoft YaHei" pitchFamily="34" charset="-122"/>
+                <a:cs typeface="Microsoft YaHei" pitchFamily="34" charset="-120"/>
+              </a:rPr>
+              <a:t>差距最大在 Q4 归属(66→11)、Q5 ToM(38→3)、Q7 关系(30→9) —— Mem0 有损抽取丢了精确归属/关系，正是 speaker-grounded 方法要补的。</a:t>
+            </a:r>
+            <a:endParaRPr lang="en-US" sz="860" dirty="0"/>
+          </a:p>
+        </p:txBody>
+      </p:sp>
+      <p:sp>
+        <p:nvSpPr>
+          <p:cNvPr id="9" name="Text 6"/>
+          <p:cNvSpPr/>
+          <p:nvPr/>
+        </p:nvSpPr>
+        <p:spPr>
+          <a:xfrm>
+            <a:off x="457200" y="4832604"/>
+            <a:ext cx="5486400" cy="237744"/>
+          </a:xfrm>
+          <a:prstGeom prst="rect">
+            <a:avLst/>
+          </a:prstGeom>
+          <a:noFill/>
+          <a:ln/>
+        </p:spPr>
+        <p:txBody>
+          <a:bodyPr wrap="square" lIns="0" tIns="0" rIns="0" bIns="0" rtlCol="0" anchor="ctr"/>
+          <a:lstStyle/>
+          <a:p>
+            <a:pPr indent="0" marL="0">
+              <a:buNone/>
+            </a:pPr>
+            <a:r>
+              <a:rPr lang="en-US" sz="800" dirty="0">
+                <a:solidFill>
+                  <a:srgbClr val="94A3B8"/>
+                </a:solidFill>
+                <a:latin typeface="Microsoft YaHei" pitchFamily="34" charset="0"/>
+                <a:ea typeface="Microsoft YaHei" pitchFamily="34" charset="-122"/>
+                <a:cs typeface="Microsoft YaHei" pitchFamily="34" charset="-120"/>
+              </a:rPr>
+              <a:t>SpeakerMem-R1 · 问题导向汇报 V2 · 2026-06-03</a:t>
+            </a:r>
+            <a:endParaRPr lang="en-US" sz="800" dirty="0"/>
+          </a:p>
+        </p:txBody>
+      </p:sp>
+      <p:sp>
+        <p:nvSpPr>
+          <p:cNvPr id="10" name="Text 7"/>
+          <p:cNvSpPr/>
+          <p:nvPr/>
+        </p:nvSpPr>
+        <p:spPr>
+          <a:xfrm>
+            <a:off x="8046720" y="4832604"/>
+            <a:ext cx="640080" cy="237744"/>
+          </a:xfrm>
+          <a:prstGeom prst="rect">
+            <a:avLst/>
+          </a:prstGeom>
+          <a:noFill/>
+          <a:ln/>
+        </p:spPr>
+        <p:txBody>
+          <a:bodyPr wrap="square" lIns="0" tIns="0" rIns="0" bIns="0" rtlCol="0" anchor="ctr"/>
+          <a:lstStyle/>
+          <a:p>
+            <a:pPr algn="r" indent="0" marL="0">
+              <a:buNone/>
+            </a:pPr>
+            <a:r>
+              <a:rPr lang="en-US" sz="800" dirty="0">
+                <a:solidFill>
+                  <a:srgbClr val="94A3B8"/>
+                </a:solidFill>
+                <a:latin typeface="Microsoft YaHei" pitchFamily="34" charset="0"/>
+                <a:ea typeface="Microsoft YaHei" pitchFamily="34" charset="-122"/>
+                <a:cs typeface="Microsoft YaHei" pitchFamily="34" charset="-120"/>
+              </a:rPr>
+              <a:t>13 / 13</a:t>
             </a:r>
             <a:endParaRPr lang="en-US" sz="800" dirty="0"/>
           </a:p>
@@ -9737,7 +13935,7 @@
                 <a:ea typeface="Microsoft YaHei" pitchFamily="34" charset="-122"/>
                 <a:cs typeface="Microsoft YaHei" pitchFamily="34" charset="-120"/>
               </a:rPr>
-              <a:t>2 / 12</a:t>
+              <a:t>2 / 13</a:t>
             </a:r>
             <a:endParaRPr lang="en-US" sz="800" dirty="0"/>
           </a:p>
@@ -12714,7 +16912,7 @@
                 <a:ea typeface="Microsoft YaHei" pitchFamily="34" charset="-122"/>
                 <a:cs typeface="Microsoft YaHei" pitchFamily="34" charset="-120"/>
               </a:rPr>
-              <a:t>3 / 12</a:t>
+              <a:t>3 / 13</a:t>
             </a:r>
             <a:endParaRPr lang="en-US" sz="800" dirty="0"/>
           </a:p>
@@ -16475,7 +20673,7 @@
                 <a:ea typeface="Microsoft YaHei" pitchFamily="34" charset="-122"/>
                 <a:cs typeface="Microsoft YaHei" pitchFamily="34" charset="-120"/>
               </a:rPr>
-              <a:t>4 / 12</a:t>
+              <a:t>4 / 13</a:t>
             </a:r>
             <a:endParaRPr lang="en-US" sz="800" dirty="0"/>
           </a:p>
@@ -18139,7 +22337,7 @@
                 <a:ea typeface="Microsoft YaHei" pitchFamily="34" charset="-122"/>
                 <a:cs typeface="Microsoft YaHei" pitchFamily="34" charset="-120"/>
               </a:rPr>
-              <a:t>5 / 12</a:t>
+              <a:t>5 / 13</a:t>
             </a:r>
             <a:endParaRPr lang="en-US" sz="800" dirty="0"/>
           </a:p>
@@ -19374,7 +23572,7 @@
                 <a:ea typeface="Microsoft YaHei" pitchFamily="34" charset="-122"/>
                 <a:cs typeface="Microsoft YaHei" pitchFamily="34" charset="-120"/>
               </a:rPr>
-              <a:t>6 / 12</a:t>
+              <a:t>6 / 13</a:t>
             </a:r>
             <a:endParaRPr lang="en-US" sz="800" dirty="0"/>
           </a:p>
@@ -20580,7 +24778,7 @@
                 <a:ea typeface="Microsoft YaHei" pitchFamily="34" charset="-122"/>
                 <a:cs typeface="Microsoft YaHei" pitchFamily="34" charset="-120"/>
               </a:rPr>
-              <a:t>7 / 12</a:t>
+              <a:t>7 / 13</a:t>
             </a:r>
             <a:endParaRPr lang="en-US" sz="800" dirty="0"/>
           </a:p>
@@ -22008,7 +26206,7 @@
                 <a:ea typeface="Microsoft YaHei" pitchFamily="34" charset="-122"/>
                 <a:cs typeface="Microsoft YaHei" pitchFamily="34" charset="-120"/>
               </a:rPr>
-              <a:t>8 / 12</a:t>
+              <a:t>8 / 13</a:t>
             </a:r>
             <a:endParaRPr lang="en-US" sz="800" dirty="0"/>
           </a:p>
@@ -23686,7 +27884,7 @@
                 <a:ea typeface="Microsoft YaHei" pitchFamily="34" charset="-122"/>
                 <a:cs typeface="Microsoft YaHei" pitchFamily="34" charset="-120"/>
               </a:rPr>
-              <a:t>9 / 12</a:t>
+              <a:t>9 / 13</a:t>
             </a:r>
             <a:endParaRPr lang="en-US" sz="800" dirty="0"/>
           </a:p>

</xml_diff>

<commit_message>
A-MEM/HippoRAG SocialMem 全量 + Mem0 失效深度归因 + PPT 更新
四基线 SocialMem(judge acc): HippoRAG 59.0 > A-MEM 48.1 > BM25 28.6 > Mem0 13.7
- 关键发现: SocialMem 上图记忆反超 BM25(与 GroupMem/EverMem 相反); Mem0 三场全垫底
- 新增 analyze_mem0_fail.py: 重建 BM25对/Mem0错 案例两边检索内容, 定位 5+1 失效根因
- 新增 Mem0失效分析.md: 字面值抹平/绑定断裂/说话人丢失/言语行为丢/关系边缺失/更新不追踪
- gen_v2.js 17页: page12 四基线总表 + page13 SocialMem 四基线分类表 + 新增 page14 失效根因
- 更新 实验结果.md(§1/§3 四基线) + CLAUDE.md + README

Co-Authored-By: Claude Opus 4.8 <noreply@anthropic.com>
</commit_message>
<xml_diff>
--- a/SpeakerMem-R1-汇报V2-问题导向.pptx
+++ b/SpeakerMem-R1-汇报V2-问题导向.pptx
@@ -21,9 +21,10 @@
     <p:sldId id="269" r:id="rId15"/>
     <p:sldId id="270" r:id="rId16"/>
     <p:sldId id="271" r:id="rId17"/>
+    <p:sldId id="272" r:id="rId18"/>
   </p:sldIdLst>
   <p:notesMasterIdLst>
-    <p:notesMasterId r:id="rId18"/>
+    <p:notesMasterId r:id="rId19"/>
   </p:notesMasterIdLst>
   <p:sldSz cx="9144000" cy="5143500"/>
   <p:notesSz cx="5143500" cy="9144000"/>
@@ -1157,6 +1158,94 @@
             <a:fld id="{F7021451-1387-4CA6-816F-3879F97B5CBC}" type="slidenum">
               <a:rPr lang="en-US"/>
               <a:t>16</a:t>
+            </a:fld>
+            <a:endParaRPr lang="en-US"/>
+          </a:p>
+        </p:txBody>
+      </p:sp>
+    </p:spTree>
+    <p:extLst>
+      <p:ext uri="{BB962C8B-B14F-4D97-AF65-F5344CB8AC3E}">
+        <p14:creationId xmlns:p14="http://schemas.microsoft.com/office/powerpoint/2010/main" val="1024086991"/>
+      </p:ext>
+    </p:extLst>
+  </p:cSld>
+  <p:clrMapOvr>
+    <a:masterClrMapping/>
+  </p:clrMapOvr>
+</p:notes>
+</file>
+
+<file path=ppt/notesSlides/notesSlide17.xml><?xml version="1.0" encoding="utf-8"?>
+<p:notes xmlns:a="http://schemas.openxmlformats.org/drawingml/2006/main" xmlns:r="http://schemas.openxmlformats.org/officeDocument/2006/relationships" xmlns:p="http://schemas.openxmlformats.org/presentationml/2006/main">
+  <p:cSld>
+    <p:spTree>
+      <p:nvGrpSpPr>
+        <p:cNvPr id="1" name=""/>
+        <p:cNvGrpSpPr/>
+        <p:nvPr/>
+      </p:nvGrpSpPr>
+      <p:grpSpPr>
+        <a:xfrm>
+          <a:off x="0" y="0"/>
+          <a:ext cx="0" cy="0"/>
+          <a:chOff x="0" y="0"/>
+          <a:chExt cx="0" cy="0"/>
+        </a:xfrm>
+      </p:grpSpPr>
+      <p:sp>
+        <p:nvSpPr>
+          <p:cNvPr id="2" name="Slide Image Placeholder 1"/>
+          <p:cNvSpPr>
+            <a:spLocks noGrp="1" noRot="1" noChangeAspect="1"/>
+          </p:cNvSpPr>
+          <p:nvPr>
+            <p:ph type="sldImg"/>
+          </p:nvPr>
+        </p:nvSpPr>
+        <p:spPr/>
+      </p:sp>
+      <p:sp>
+        <p:nvSpPr>
+          <p:cNvPr id="3" name="Notes Placeholder 2"/>
+          <p:cNvSpPr>
+            <a:spLocks noGrp="1"/>
+          </p:cNvSpPr>
+          <p:nvPr>
+            <p:ph type="body" idx="1"/>
+          </p:nvPr>
+        </p:nvSpPr>
+        <p:spPr/>
+        <p:txBody>
+          <a:bodyPr/>
+          <a:lstStyle/>
+          <a:p>
+            <a:r>
+              <a:rPr lang="en-US" dirty="0"/>
+              <a:t/>
+            </a:r>
+            <a:endParaRPr lang="en-US" dirty="0"/>
+          </a:p>
+        </p:txBody>
+      </p:sp>
+      <p:sp>
+        <p:nvSpPr>
+          <p:cNvPr id="4" name="Slide Number Placeholder 3"/>
+          <p:cNvSpPr>
+            <a:spLocks noGrp="1"/>
+          </p:cNvSpPr>
+          <p:nvPr>
+            <p:ph type="sldNum" sz="quarter" idx="10"/>
+          </p:nvPr>
+        </p:nvSpPr>
+        <p:spPr/>
+        <p:txBody>
+          <a:bodyPr/>
+          <a:lstStyle/>
+          <a:p>
+            <a:fld id="{F7021451-1387-4CA6-816F-3879F97B5CBC}" type="slidenum">
+              <a:rPr lang="en-US"/>
+              <a:t>17</a:t>
             </a:fld>
             <a:endParaRPr lang="en-US"/>
           </a:p>
@@ -3151,7 +3240,7 @@
                 <a:ea typeface="Microsoft YaHei" pitchFamily="34" charset="-122"/>
                 <a:cs typeface="Microsoft YaHei" pitchFamily="34" charset="-120"/>
               </a:rPr>
-              <a:t>1 / 16</a:t>
+              <a:t>1 / 17</a:t>
             </a:r>
             <a:endParaRPr lang="en-US" sz="800" dirty="0"/>
           </a:p>
@@ -4357,7 +4446,7 @@
                 <a:ea typeface="Microsoft YaHei" pitchFamily="34" charset="-122"/>
                 <a:cs typeface="Microsoft YaHei" pitchFamily="34" charset="-120"/>
               </a:rPr>
-              <a:t>10 / 16</a:t>
+              <a:t>10 / 17</a:t>
             </a:r>
             <a:endParaRPr lang="en-US" sz="800" dirty="0"/>
           </a:p>
@@ -5785,7 +5874,7 @@
                 <a:ea typeface="Microsoft YaHei" pitchFamily="34" charset="-122"/>
                 <a:cs typeface="Microsoft YaHei" pitchFamily="34" charset="-120"/>
               </a:rPr>
-              <a:t>11 / 16</a:t>
+              <a:t>11 / 17</a:t>
             </a:r>
             <a:endParaRPr lang="en-US" sz="800" dirty="0"/>
           </a:p>
@@ -7463,7 +7552,7 @@
                 <a:ea typeface="Microsoft YaHei" pitchFamily="34" charset="-122"/>
                 <a:cs typeface="Microsoft YaHei" pitchFamily="34" charset="-120"/>
               </a:rPr>
-              <a:t>12 / 16</a:t>
+              <a:t>12 / 17</a:t>
             </a:r>
             <a:endParaRPr lang="en-US" sz="800" dirty="0"/>
           </a:p>
@@ -9153,7 +9242,7 @@
                 <a:ea typeface="Microsoft YaHei" pitchFamily="34" charset="-122"/>
                 <a:cs typeface="Microsoft YaHei" pitchFamily="34" charset="-120"/>
               </a:rPr>
-              <a:t>13 / 16</a:t>
+              <a:t>13 / 17</a:t>
             </a:r>
             <a:endParaRPr lang="en-US" sz="800" dirty="0"/>
           </a:p>
@@ -10505,7 +10594,7 @@
                 <a:ea typeface="Microsoft YaHei" pitchFamily="34" charset="-122"/>
                 <a:cs typeface="Microsoft YaHei" pitchFamily="34" charset="-120"/>
               </a:rPr>
-              <a:t>14 / 16</a:t>
+              <a:t>14 / 17</a:t>
             </a:r>
             <a:endParaRPr lang="en-US" sz="800" dirty="0"/>
           </a:p>
@@ -10596,7 +10685,7 @@
                 <a:ea typeface="Microsoft YaHei" pitchFamily="34" charset="-122"/>
                 <a:cs typeface="Microsoft YaHei" pitchFamily="34" charset="-120"/>
               </a:rPr>
-              <a:t>P4 · 复现进度（DeepSeek 实测，2026-06-09）</a:t>
+              <a:t>P4 · 复现进度（DeepSeek 实测，2026-06-10）</a:t>
             </a:r>
             <a:endParaRPr lang="en-US" sz="1100" dirty="0"/>
           </a:p>
@@ -10635,7 +10724,7 @@
                 <a:ea typeface="Microsoft YaHei" pitchFamily="34" charset="-122"/>
                 <a:cs typeface="Microsoft YaHei" pitchFamily="34" charset="-120"/>
               </a:rPr>
-              <a:t>BM25 三数据集全量：连关键词检索都很能打</a:t>
+              <a:t>四基线全量：Mem0 全场垫底；SocialMem 上图记忆反超</a:t>
             </a:r>
             <a:endParaRPr lang="en-US" sz="2300" dirty="0"/>
           </a:p>
@@ -10664,12 +10753,13 @@
             <a:tbl>
               <a:tblPr/>
               <a:tblGrid>
-                <a:gridCol w="1691640"/>
-                <a:gridCol w="640080"/>
-                <a:gridCol w="1051560"/>
-                <a:gridCol w="1051560"/>
-                <a:gridCol w="1234440"/>
-                <a:gridCol w="2560320"/>
+                <a:gridCol w="1600200"/>
+                <a:gridCol w="566928"/>
+                <a:gridCol w="841248"/>
+                <a:gridCol w="841248"/>
+                <a:gridCol w="841248"/>
+                <a:gridCol w="960120"/>
+                <a:gridCol w="2578608"/>
               </a:tblGrid>
               <a:tr h="310896">
                 <a:tc>
@@ -10698,7 +10788,7 @@
                       </a:endParaRPr>
                     </a:p>
                   </a:txBody>
-                  <a:tcPr marL="63500" marR="63500" marT="25400" marB="25400" anchor="ctr">
+                  <a:tcPr marL="50800" marR="50800" marT="25400" marB="25400" anchor="ctr">
                     <a:lnL w="9525" cap="flat" cmpd="sng" algn="ctr">
                       <a:solidFill>
                         <a:srgbClr val="E2E8F0"/>
@@ -10766,7 +10856,7 @@
                       </a:endParaRPr>
                     </a:p>
                   </a:txBody>
-                  <a:tcPr marL="63500" marR="63500" marT="25400" marB="25400" anchor="ctr">
+                  <a:tcPr marL="50800" marR="50800" marT="25400" marB="25400" anchor="ctr">
                     <a:lnL w="9525" cap="flat" cmpd="sng" algn="ctr">
                       <a:solidFill>
                         <a:srgbClr val="E2E8F0"/>
@@ -10825,7 +10915,7 @@
                           <a:ea typeface="Microsoft YaHei" pitchFamily="34" charset="-122"/>
                           <a:cs typeface="Microsoft YaHei" pitchFamily="34" charset="-120"/>
                         </a:rPr>
-                        <a:t>BM25 acc</a:t>
+                        <a:t>BM25</a:t>
                       </a:r>
                       <a:endParaRPr lang="en-US" sz="950" dirty="0">
                         <a:latin typeface="Microsoft YaHei" charset="0"/>
@@ -10834,7 +10924,7 @@
                       </a:endParaRPr>
                     </a:p>
                   </a:txBody>
-                  <a:tcPr marL="63500" marR="63500" marT="25400" marB="25400" anchor="ctr">
+                  <a:tcPr marL="50800" marR="50800" marT="25400" marB="25400" anchor="ctr">
                     <a:lnL w="9525" cap="flat" cmpd="sng" algn="ctr">
                       <a:solidFill>
                         <a:srgbClr val="E2E8F0"/>
@@ -10893,7 +10983,7 @@
                           <a:ea typeface="Microsoft YaHei" pitchFamily="34" charset="-122"/>
                           <a:cs typeface="Microsoft YaHei" pitchFamily="34" charset="-120"/>
                         </a:rPr>
-                        <a:t>Mem0 acc</a:t>
+                        <a:t>Mem0</a:t>
                       </a:r>
                       <a:endParaRPr lang="en-US" sz="950" dirty="0">
                         <a:latin typeface="Microsoft YaHei" charset="0"/>
@@ -10902,7 +10992,7 @@
                       </a:endParaRPr>
                     </a:p>
                   </a:txBody>
-                  <a:tcPr marL="63500" marR="63500" marT="25400" marB="25400" anchor="ctr">
+                  <a:tcPr marL="50800" marR="50800" marT="25400" marB="25400" anchor="ctr">
                     <a:lnL w="9525" cap="flat" cmpd="sng" algn="ctr">
                       <a:solidFill>
                         <a:srgbClr val="E2E8F0"/>
@@ -10961,7 +11051,7 @@
                           <a:ea typeface="Microsoft YaHei" pitchFamily="34" charset="-122"/>
                           <a:cs typeface="Microsoft YaHei" pitchFamily="34" charset="-120"/>
                         </a:rPr>
-                        <a:t>BM25 EM/F1</a:t>
+                        <a:t>A-MEM</a:t>
                       </a:r>
                       <a:endParaRPr lang="en-US" sz="950" dirty="0">
                         <a:latin typeface="Microsoft YaHei" charset="0"/>
@@ -10970,7 +11060,75 @@
                       </a:endParaRPr>
                     </a:p>
                   </a:txBody>
-                  <a:tcPr marL="63500" marR="63500" marT="25400" marB="25400" anchor="ctr">
+                  <a:tcPr marL="50800" marR="50800" marT="25400" marB="25400" anchor="ctr">
+                    <a:lnL w="9525" cap="flat" cmpd="sng" algn="ctr">
+                      <a:solidFill>
+                        <a:srgbClr val="E2E8F0"/>
+                      </a:solidFill>
+                      <a:prstDash val="solid"/>
+                      <a:round/>
+                      <a:headEnd type="none" w="med" len="med"/>
+                      <a:tailEnd type="none" w="med" len="med"/>
+                    </a:lnL>
+                    <a:lnR w="9525" cap="flat" cmpd="sng" algn="ctr">
+                      <a:solidFill>
+                        <a:srgbClr val="E2E8F0"/>
+                      </a:solidFill>
+                      <a:prstDash val="solid"/>
+                      <a:round/>
+                      <a:headEnd type="none" w="med" len="med"/>
+                      <a:tailEnd type="none" w="med" len="med"/>
+                    </a:lnR>
+                    <a:lnT w="9525" cap="flat" cmpd="sng" algn="ctr">
+                      <a:solidFill>
+                        <a:srgbClr val="E2E8F0"/>
+                      </a:solidFill>
+                      <a:prstDash val="solid"/>
+                      <a:round/>
+                      <a:headEnd type="none" w="med" len="med"/>
+                      <a:tailEnd type="none" w="med" len="med"/>
+                    </a:lnT>
+                    <a:lnB w="9525" cap="flat" cmpd="sng" algn="ctr">
+                      <a:solidFill>
+                        <a:srgbClr val="E2E8F0"/>
+                      </a:solidFill>
+                      <a:prstDash val="solid"/>
+                      <a:round/>
+                      <a:headEnd type="none" w="med" len="med"/>
+                      <a:tailEnd type="none" w="med" len="med"/>
+                    </a:lnB>
+                    <a:solidFill>
+                      <a:srgbClr val="12183A"/>
+                    </a:solidFill>
+                  </a:tcPr>
+                </a:tc>
+                <a:tc>
+                  <a:txBody>
+                    <a:bodyPr/>
+                    <a:lstStyle/>
+                    <a:p>
+                      <a:pPr algn="l" indent="0" marL="0">
+                        <a:buNone/>
+                      </a:pPr>
+                      <a:r>
+                        <a:rPr lang="en-US" sz="950" b="1" dirty="0">
+                          <a:solidFill>
+                            <a:srgbClr val="FFFFFF"/>
+                          </a:solidFill>
+                          <a:latin typeface="Microsoft YaHei" pitchFamily="34" charset="0"/>
+                          <a:ea typeface="Microsoft YaHei" pitchFamily="34" charset="-122"/>
+                          <a:cs typeface="Microsoft YaHei" pitchFamily="34" charset="-120"/>
+                        </a:rPr>
+                        <a:t>HippoRAG</a:t>
+                      </a:r>
+                      <a:endParaRPr lang="en-US" sz="950" dirty="0">
+                        <a:latin typeface="Microsoft YaHei" charset="0"/>
+                        <a:ea typeface="Microsoft YaHei" charset="0"/>
+                        <a:cs typeface="Microsoft YaHei" charset="0"/>
+                      </a:endParaRPr>
+                    </a:p>
+                  </a:txBody>
+                  <a:tcPr marL="50800" marR="50800" marT="25400" marB="25400" anchor="ctr">
                     <a:lnL w="9525" cap="flat" cmpd="sng" algn="ctr">
                       <a:solidFill>
                         <a:srgbClr val="E2E8F0"/>
@@ -11038,7 +11196,7 @@
                       </a:endParaRPr>
                     </a:p>
                   </a:txBody>
-                  <a:tcPr marL="63500" marR="63500" marT="25400" marB="25400" anchor="ctr">
+                  <a:tcPr marL="50800" marR="50800" marT="25400" marB="25400" anchor="ctr">
                     <a:lnL w="9525" cap="flat" cmpd="sng" algn="ctr">
                       <a:solidFill>
                         <a:srgbClr val="E2E8F0"/>
@@ -11081,7 +11239,7 @@
                   </a:tcPr>
                 </a:tc>
               </a:tr>
-              <a:tr h="457200">
+              <a:tr h="475488">
                 <a:tc>
                   <a:txBody>
                     <a:bodyPr/>
@@ -11108,7 +11266,7 @@
                       </a:endParaRPr>
                     </a:p>
                   </a:txBody>
-                  <a:tcPr marL="63500" marR="63500" marT="25400" marB="25400" anchor="ctr">
+                  <a:tcPr marL="50800" marR="50800" marT="25400" marB="25400" anchor="ctr">
                     <a:lnL w="9525" cap="flat" cmpd="sng" algn="ctr">
                       <a:solidFill>
                         <a:srgbClr val="E2E8F0"/>
@@ -11176,7 +11334,7 @@
                       </a:endParaRPr>
                     </a:p>
                   </a:txBody>
-                  <a:tcPr marL="63500" marR="63500" marT="25400" marB="25400" anchor="ctr">
+                  <a:tcPr marL="50800" marR="50800" marT="25400" marB="25400" anchor="ctr">
                     <a:lnL w="9525" cap="flat" cmpd="sng" algn="ctr">
                       <a:solidFill>
                         <a:srgbClr val="E2E8F0"/>
@@ -11244,7 +11402,7 @@
                       </a:endParaRPr>
                     </a:p>
                   </a:txBody>
-                  <a:tcPr marL="63500" marR="63500" marT="25400" marB="25400" anchor="ctr">
+                  <a:tcPr marL="50800" marR="50800" marT="25400" marB="25400" anchor="ctr">
                     <a:lnL w="9525" cap="flat" cmpd="sng" algn="ctr">
                       <a:solidFill>
                         <a:srgbClr val="E2E8F0"/>
@@ -11312,7 +11470,7 @@
                       </a:endParaRPr>
                     </a:p>
                   </a:txBody>
-                  <a:tcPr marL="63500" marR="63500" marT="25400" marB="25400" anchor="ctr">
+                  <a:tcPr marL="50800" marR="50800" marT="25400" marB="25400" anchor="ctr">
                     <a:lnL w="9525" cap="flat" cmpd="sng" algn="ctr">
                       <a:solidFill>
                         <a:srgbClr val="E2E8F0"/>
@@ -11365,13 +11523,13 @@
                       <a:r>
                         <a:rPr lang="en-US" sz="860" dirty="0">
                           <a:solidFill>
-                            <a:srgbClr val="334155"/>
+                            <a:srgbClr val="64748B"/>
                           </a:solidFill>
                           <a:latin typeface="Microsoft YaHei" pitchFamily="34" charset="0"/>
                           <a:ea typeface="Microsoft YaHei" pitchFamily="34" charset="-122"/>
                           <a:cs typeface="Microsoft YaHei" pitchFamily="34" charset="-120"/>
                         </a:rPr>
-                        <a:t>13.8 / 25.0</a:t>
+                        <a:t>—</a:t>
                       </a:r>
                       <a:endParaRPr lang="en-US" sz="860" dirty="0">
                         <a:latin typeface="Microsoft YaHei" charset="0"/>
@@ -11380,7 +11538,75 @@
                       </a:endParaRPr>
                     </a:p>
                   </a:txBody>
-                  <a:tcPr marL="63500" marR="63500" marT="25400" marB="25400" anchor="ctr">
+                  <a:tcPr marL="50800" marR="50800" marT="25400" marB="25400" anchor="ctr">
+                    <a:lnL w="9525" cap="flat" cmpd="sng" algn="ctr">
+                      <a:solidFill>
+                        <a:srgbClr val="E2E8F0"/>
+                      </a:solidFill>
+                      <a:prstDash val="solid"/>
+                      <a:round/>
+                      <a:headEnd type="none" w="med" len="med"/>
+                      <a:tailEnd type="none" w="med" len="med"/>
+                    </a:lnL>
+                    <a:lnR w="9525" cap="flat" cmpd="sng" algn="ctr">
+                      <a:solidFill>
+                        <a:srgbClr val="E2E8F0"/>
+                      </a:solidFill>
+                      <a:prstDash val="solid"/>
+                      <a:round/>
+                      <a:headEnd type="none" w="med" len="med"/>
+                      <a:tailEnd type="none" w="med" len="med"/>
+                    </a:lnR>
+                    <a:lnT w="9525" cap="flat" cmpd="sng" algn="ctr">
+                      <a:solidFill>
+                        <a:srgbClr val="E2E8F0"/>
+                      </a:solidFill>
+                      <a:prstDash val="solid"/>
+                      <a:round/>
+                      <a:headEnd type="none" w="med" len="med"/>
+                      <a:tailEnd type="none" w="med" len="med"/>
+                    </a:lnT>
+                    <a:lnB w="9525" cap="flat" cmpd="sng" algn="ctr">
+                      <a:solidFill>
+                        <a:srgbClr val="E2E8F0"/>
+                      </a:solidFill>
+                      <a:prstDash val="solid"/>
+                      <a:round/>
+                      <a:headEnd type="none" w="med" len="med"/>
+                      <a:tailEnd type="none" w="med" len="med"/>
+                    </a:lnB>
+                    <a:solidFill>
+                      <a:srgbClr val="FFFFFF"/>
+                    </a:solidFill>
+                  </a:tcPr>
+                </a:tc>
+                <a:tc>
+                  <a:txBody>
+                    <a:bodyPr/>
+                    <a:lstStyle/>
+                    <a:p>
+                      <a:pPr algn="ctr" indent="0" marL="0">
+                        <a:buNone/>
+                      </a:pPr>
+                      <a:r>
+                        <a:rPr lang="en-US" sz="860" dirty="0">
+                          <a:solidFill>
+                            <a:srgbClr val="64748B"/>
+                          </a:solidFill>
+                          <a:latin typeface="Microsoft YaHei" pitchFamily="34" charset="0"/>
+                          <a:ea typeface="Microsoft YaHei" pitchFamily="34" charset="-122"/>
+                          <a:cs typeface="Microsoft YaHei" pitchFamily="34" charset="-120"/>
+                        </a:rPr>
+                        <a:t>—</a:t>
+                      </a:r>
+                      <a:endParaRPr lang="en-US" sz="860" dirty="0">
+                        <a:latin typeface="Microsoft YaHei" charset="0"/>
+                        <a:ea typeface="Microsoft YaHei" charset="0"/>
+                        <a:cs typeface="Microsoft YaHei" charset="0"/>
+                      </a:endParaRPr>
+                    </a:p>
+                  </a:txBody>
+                  <a:tcPr marL="50800" marR="50800" marT="25400" marB="25400" anchor="ctr">
                     <a:lnL w="9525" cap="flat" cmpd="sng" algn="ctr">
                       <a:solidFill>
                         <a:srgbClr val="E2E8F0"/>
@@ -11431,9 +11657,9 @@
                         <a:buNone/>
                       </a:pPr>
                       <a:r>
-                        <a:rPr lang="en-US" sz="860" b="1" dirty="0">
+                        <a:rPr lang="en-US" sz="860" dirty="0">
                           <a:solidFill>
-                            <a:srgbClr val="DC4A52"/>
+                            <a:srgbClr val="334155"/>
                           </a:solidFill>
                           <a:latin typeface="Microsoft YaHei" pitchFamily="34" charset="0"/>
                           <a:ea typeface="Microsoft YaHei" pitchFamily="34" charset="-122"/>
@@ -11448,7 +11674,7 @@
                       </a:endParaRPr>
                     </a:p>
                   </a:txBody>
-                  <a:tcPr marL="63500" marR="63500" marT="25400" marB="25400" anchor="ctr">
+                  <a:tcPr marL="50800" marR="50800" marT="25400" marB="25400" anchor="ctr">
                     <a:lnL w="9525" cap="flat" cmpd="sng" algn="ctr">
                       <a:solidFill>
                         <a:srgbClr val="E2E8F0"/>
@@ -11491,7 +11717,7 @@
                   </a:tcPr>
                 </a:tc>
               </a:tr>
-              <a:tr h="457200">
+              <a:tr h="475488">
                 <a:tc>
                   <a:txBody>
                     <a:bodyPr/>
@@ -11518,7 +11744,7 @@
                       </a:endParaRPr>
                     </a:p>
                   </a:txBody>
-                  <a:tcPr marL="63500" marR="63500" marT="25400" marB="25400" anchor="ctr">
+                  <a:tcPr marL="50800" marR="50800" marT="25400" marB="25400" anchor="ctr">
                     <a:lnL w="9525" cap="flat" cmpd="sng" algn="ctr">
                       <a:solidFill>
                         <a:srgbClr val="E2E8F0"/>
@@ -11586,7 +11812,7 @@
                       </a:endParaRPr>
                     </a:p>
                   </a:txBody>
-                  <a:tcPr marL="63500" marR="63500" marT="25400" marB="25400" anchor="ctr">
+                  <a:tcPr marL="50800" marR="50800" marT="25400" marB="25400" anchor="ctr">
                     <a:lnL w="9525" cap="flat" cmpd="sng" algn="ctr">
                       <a:solidFill>
                         <a:srgbClr val="E2E8F0"/>
@@ -11637,9 +11863,9 @@
                         <a:buNone/>
                       </a:pPr>
                       <a:r>
-                        <a:rPr lang="en-US" sz="860" b="1" dirty="0">
+                        <a:rPr lang="en-US" sz="860" dirty="0">
                           <a:solidFill>
-                            <a:srgbClr val="0E7490"/>
+                            <a:srgbClr val="334155"/>
                           </a:solidFill>
                           <a:latin typeface="Microsoft YaHei" pitchFamily="34" charset="0"/>
                           <a:ea typeface="Microsoft YaHei" pitchFamily="34" charset="-122"/>
@@ -11654,7 +11880,7 @@
                       </a:endParaRPr>
                     </a:p>
                   </a:txBody>
-                  <a:tcPr marL="63500" marR="63500" marT="25400" marB="25400" anchor="ctr">
+                  <a:tcPr marL="50800" marR="50800" marT="25400" marB="25400" anchor="ctr">
                     <a:lnL w="9525" cap="flat" cmpd="sng" algn="ctr">
                       <a:solidFill>
                         <a:srgbClr val="E2E8F0"/>
@@ -11722,7 +11948,7 @@
                       </a:endParaRPr>
                     </a:p>
                   </a:txBody>
-                  <a:tcPr marL="63500" marR="63500" marT="25400" marB="25400" anchor="ctr">
+                  <a:tcPr marL="50800" marR="50800" marT="25400" marB="25400" anchor="ctr">
                     <a:lnL w="9525" cap="flat" cmpd="sng" algn="ctr">
                       <a:solidFill>
                         <a:srgbClr val="E2E8F0"/>
@@ -11773,15 +11999,15 @@
                         <a:buNone/>
                       </a:pPr>
                       <a:r>
-                        <a:rPr lang="en-US" sz="860" dirty="0">
+                        <a:rPr lang="en-US" sz="860" b="1" dirty="0">
                           <a:solidFill>
-                            <a:srgbClr val="334155"/>
+                            <a:srgbClr val="0E7490"/>
                           </a:solidFill>
                           <a:latin typeface="Microsoft YaHei" pitchFamily="34" charset="0"/>
                           <a:ea typeface="Microsoft YaHei" pitchFamily="34" charset="-122"/>
                           <a:cs typeface="Microsoft YaHei" pitchFamily="34" charset="-120"/>
                         </a:rPr>
-                        <a:t>3.6 / 15.7</a:t>
+                        <a:t>48.1%</a:t>
                       </a:r>
                       <a:endParaRPr lang="en-US" sz="860" dirty="0">
                         <a:latin typeface="Microsoft YaHei" charset="0"/>
@@ -11790,7 +12016,75 @@
                       </a:endParaRPr>
                     </a:p>
                   </a:txBody>
-                  <a:tcPr marL="63500" marR="63500" marT="25400" marB="25400" anchor="ctr">
+                  <a:tcPr marL="50800" marR="50800" marT="25400" marB="25400" anchor="ctr">
+                    <a:lnL w="9525" cap="flat" cmpd="sng" algn="ctr">
+                      <a:solidFill>
+                        <a:srgbClr val="E2E8F0"/>
+                      </a:solidFill>
+                      <a:prstDash val="solid"/>
+                      <a:round/>
+                      <a:headEnd type="none" w="med" len="med"/>
+                      <a:tailEnd type="none" w="med" len="med"/>
+                    </a:lnL>
+                    <a:lnR w="9525" cap="flat" cmpd="sng" algn="ctr">
+                      <a:solidFill>
+                        <a:srgbClr val="E2E8F0"/>
+                      </a:solidFill>
+                      <a:prstDash val="solid"/>
+                      <a:round/>
+                      <a:headEnd type="none" w="med" len="med"/>
+                      <a:tailEnd type="none" w="med" len="med"/>
+                    </a:lnR>
+                    <a:lnT w="9525" cap="flat" cmpd="sng" algn="ctr">
+                      <a:solidFill>
+                        <a:srgbClr val="E2E8F0"/>
+                      </a:solidFill>
+                      <a:prstDash val="solid"/>
+                      <a:round/>
+                      <a:headEnd type="none" w="med" len="med"/>
+                      <a:tailEnd type="none" w="med" len="med"/>
+                    </a:lnT>
+                    <a:lnB w="9525" cap="flat" cmpd="sng" algn="ctr">
+                      <a:solidFill>
+                        <a:srgbClr val="E2E8F0"/>
+                      </a:solidFill>
+                      <a:prstDash val="solid"/>
+                      <a:round/>
+                      <a:headEnd type="none" w="med" len="med"/>
+                      <a:tailEnd type="none" w="med" len="med"/>
+                    </a:lnB>
+                    <a:solidFill>
+                      <a:srgbClr val="F8FAFC"/>
+                    </a:solidFill>
+                  </a:tcPr>
+                </a:tc>
+                <a:tc>
+                  <a:txBody>
+                    <a:bodyPr/>
+                    <a:lstStyle/>
+                    <a:p>
+                      <a:pPr algn="ctr" indent="0" marL="0">
+                        <a:buNone/>
+                      </a:pPr>
+                      <a:r>
+                        <a:rPr lang="en-US" sz="860" b="1" dirty="0">
+                          <a:solidFill>
+                            <a:srgbClr val="0E9F6E"/>
+                          </a:solidFill>
+                          <a:latin typeface="Microsoft YaHei" pitchFamily="34" charset="0"/>
+                          <a:ea typeface="Microsoft YaHei" pitchFamily="34" charset="-122"/>
+                          <a:cs typeface="Microsoft YaHei" pitchFamily="34" charset="-120"/>
+                        </a:rPr>
+                        <a:t>59.0%</a:t>
+                      </a:r>
+                      <a:endParaRPr lang="en-US" sz="860" dirty="0">
+                        <a:latin typeface="Microsoft YaHei" charset="0"/>
+                        <a:ea typeface="Microsoft YaHei" charset="0"/>
+                        <a:cs typeface="Microsoft YaHei" charset="0"/>
+                      </a:endParaRPr>
+                    </a:p>
+                  </a:txBody>
+                  <a:tcPr marL="50800" marR="50800" marT="25400" marB="25400" anchor="ctr">
                     <a:lnL w="9525" cap="flat" cmpd="sng" algn="ctr">
                       <a:solidFill>
                         <a:srgbClr val="E2E8F0"/>
@@ -11849,7 +12143,7 @@
                           <a:ea typeface="Microsoft YaHei" pitchFamily="34" charset="-122"/>
                           <a:cs typeface="Microsoft YaHei" pitchFamily="34" charset="-120"/>
                         </a:rPr>
-                        <a:t>BM25 完胜 Mem0；Mem0∈0.12–0.18</a:t>
+                        <a:t>图记忆反超 BM25；Mem0 仍垫底</a:t>
                       </a:r>
                       <a:endParaRPr lang="en-US" sz="860" dirty="0">
                         <a:latin typeface="Microsoft YaHei" charset="0"/>
@@ -11858,7 +12152,7 @@
                       </a:endParaRPr>
                     </a:p>
                   </a:txBody>
-                  <a:tcPr marL="63500" marR="63500" marT="25400" marB="25400" anchor="ctr">
+                  <a:tcPr marL="50800" marR="50800" marT="25400" marB="25400" anchor="ctr">
                     <a:lnL w="9525" cap="flat" cmpd="sng" algn="ctr">
                       <a:solidFill>
                         <a:srgbClr val="E2E8F0"/>
@@ -11901,7 +12195,7 @@
                   </a:tcPr>
                 </a:tc>
               </a:tr>
-              <a:tr h="457200">
+              <a:tr h="475488">
                 <a:tc>
                   <a:txBody>
                     <a:bodyPr/>
@@ -11928,7 +12222,7 @@
                       </a:endParaRPr>
                     </a:p>
                   </a:txBody>
-                  <a:tcPr marL="63500" marR="63500" marT="25400" marB="25400" anchor="ctr">
+                  <a:tcPr marL="50800" marR="50800" marT="25400" marB="25400" anchor="ctr">
                     <a:lnL w="9525" cap="flat" cmpd="sng" algn="ctr">
                       <a:solidFill>
                         <a:srgbClr val="E2E8F0"/>
@@ -11996,7 +12290,7 @@
                       </a:endParaRPr>
                     </a:p>
                   </a:txBody>
-                  <a:tcPr marL="63500" marR="63500" marT="25400" marB="25400" anchor="ctr">
+                  <a:tcPr marL="50800" marR="50800" marT="25400" marB="25400" anchor="ctr">
                     <a:lnL w="9525" cap="flat" cmpd="sng" algn="ctr">
                       <a:solidFill>
                         <a:srgbClr val="E2E8F0"/>
@@ -12064,7 +12358,7 @@
                       </a:endParaRPr>
                     </a:p>
                   </a:txBody>
-                  <a:tcPr marL="63500" marR="63500" marT="25400" marB="25400" anchor="ctr">
+                  <a:tcPr marL="50800" marR="50800" marT="25400" marB="25400" anchor="ctr">
                     <a:lnL w="9525" cap="flat" cmpd="sng" algn="ctr">
                       <a:solidFill>
                         <a:srgbClr val="E2E8F0"/>
@@ -12132,7 +12426,7 @@
                       </a:endParaRPr>
                     </a:p>
                   </a:txBody>
-                  <a:tcPr marL="63500" marR="63500" marT="25400" marB="25400" anchor="ctr">
+                  <a:tcPr marL="50800" marR="50800" marT="25400" marB="25400" anchor="ctr">
                     <a:lnL w="9525" cap="flat" cmpd="sng" algn="ctr">
                       <a:solidFill>
                         <a:srgbClr val="E2E8F0"/>
@@ -12185,13 +12479,13 @@
                       <a:r>
                         <a:rPr lang="en-US" sz="860" dirty="0">
                           <a:solidFill>
-                            <a:srgbClr val="334155"/>
+                            <a:srgbClr val="64748B"/>
                           </a:solidFill>
                           <a:latin typeface="Microsoft YaHei" pitchFamily="34" charset="0"/>
                           <a:ea typeface="Microsoft YaHei" pitchFamily="34" charset="-122"/>
                           <a:cs typeface="Microsoft YaHei" pitchFamily="34" charset="-120"/>
                         </a:rPr>
-                        <a:t>4.8 / 9.9</a:t>
+                        <a:t>跑中</a:t>
                       </a:r>
                       <a:endParaRPr lang="en-US" sz="860" dirty="0">
                         <a:latin typeface="Microsoft YaHei" charset="0"/>
@@ -12200,7 +12494,75 @@
                       </a:endParaRPr>
                     </a:p>
                   </a:txBody>
-                  <a:tcPr marL="63500" marR="63500" marT="25400" marB="25400" anchor="ctr">
+                  <a:tcPr marL="50800" marR="50800" marT="25400" marB="25400" anchor="ctr">
+                    <a:lnL w="9525" cap="flat" cmpd="sng" algn="ctr">
+                      <a:solidFill>
+                        <a:srgbClr val="E2E8F0"/>
+                      </a:solidFill>
+                      <a:prstDash val="solid"/>
+                      <a:round/>
+                      <a:headEnd type="none" w="med" len="med"/>
+                      <a:tailEnd type="none" w="med" len="med"/>
+                    </a:lnL>
+                    <a:lnR w="9525" cap="flat" cmpd="sng" algn="ctr">
+                      <a:solidFill>
+                        <a:srgbClr val="E2E8F0"/>
+                      </a:solidFill>
+                      <a:prstDash val="solid"/>
+                      <a:round/>
+                      <a:headEnd type="none" w="med" len="med"/>
+                      <a:tailEnd type="none" w="med" len="med"/>
+                    </a:lnR>
+                    <a:lnT w="9525" cap="flat" cmpd="sng" algn="ctr">
+                      <a:solidFill>
+                        <a:srgbClr val="E2E8F0"/>
+                      </a:solidFill>
+                      <a:prstDash val="solid"/>
+                      <a:round/>
+                      <a:headEnd type="none" w="med" len="med"/>
+                      <a:tailEnd type="none" w="med" len="med"/>
+                    </a:lnT>
+                    <a:lnB w="9525" cap="flat" cmpd="sng" algn="ctr">
+                      <a:solidFill>
+                        <a:srgbClr val="E2E8F0"/>
+                      </a:solidFill>
+                      <a:prstDash val="solid"/>
+                      <a:round/>
+                      <a:headEnd type="none" w="med" len="med"/>
+                      <a:tailEnd type="none" w="med" len="med"/>
+                    </a:lnB>
+                    <a:solidFill>
+                      <a:srgbClr val="FFFFFF"/>
+                    </a:solidFill>
+                  </a:tcPr>
+                </a:tc>
+                <a:tc>
+                  <a:txBody>
+                    <a:bodyPr/>
+                    <a:lstStyle/>
+                    <a:p>
+                      <a:pPr algn="ctr" indent="0" marL="0">
+                        <a:buNone/>
+                      </a:pPr>
+                      <a:r>
+                        <a:rPr lang="en-US" sz="860" dirty="0">
+                          <a:solidFill>
+                            <a:srgbClr val="64748B"/>
+                          </a:solidFill>
+                          <a:latin typeface="Microsoft YaHei" pitchFamily="34" charset="0"/>
+                          <a:ea typeface="Microsoft YaHei" pitchFamily="34" charset="-122"/>
+                          <a:cs typeface="Microsoft YaHei" pitchFamily="34" charset="-120"/>
+                        </a:rPr>
+                        <a:t>跑中</a:t>
+                      </a:r>
+                      <a:endParaRPr lang="en-US" sz="860" dirty="0">
+                        <a:latin typeface="Microsoft YaHei" charset="0"/>
+                        <a:ea typeface="Microsoft YaHei" charset="0"/>
+                        <a:cs typeface="Microsoft YaHei" charset="0"/>
+                      </a:endParaRPr>
+                    </a:p>
+                  </a:txBody>
+                  <a:tcPr marL="50800" marR="50800" marT="25400" marB="25400" anchor="ctr">
                     <a:lnL w="9525" cap="flat" cmpd="sng" algn="ctr">
                       <a:solidFill>
                         <a:srgbClr val="E2E8F0"/>
@@ -12251,9 +12613,9 @@
                         <a:buNone/>
                       </a:pPr>
                       <a:r>
-                        <a:rPr lang="en-US" sz="860" b="1" dirty="0">
+                        <a:rPr lang="en-US" sz="860" dirty="0">
                           <a:solidFill>
-                            <a:srgbClr val="DC4A52"/>
+                            <a:srgbClr val="334155"/>
                           </a:solidFill>
                           <a:latin typeface="Microsoft YaHei" pitchFamily="34" charset="0"/>
                           <a:ea typeface="Microsoft YaHei" pitchFamily="34" charset="-122"/>
@@ -12268,7 +12630,7 @@
                       </a:endParaRPr>
                     </a:p>
                   </a:txBody>
-                  <a:tcPr marL="63500" marR="63500" marT="25400" marB="25400" anchor="ctr">
+                  <a:tcPr marL="50800" marR="50800" marT="25400" marB="25400" anchor="ctr">
                     <a:lnL w="9525" cap="flat" cmpd="sng" algn="ctr">
                       <a:solidFill>
                         <a:srgbClr val="E2E8F0"/>
@@ -12323,8 +12685,8 @@
         </p:nvSpPr>
         <p:spPr>
           <a:xfrm>
-            <a:off x="457200" y="3246120"/>
-            <a:ext cx="8229600" cy="365760"/>
+            <a:off x="457200" y="3273552"/>
+            <a:ext cx="8229600" cy="384048"/>
           </a:xfrm>
           <a:prstGeom prst="rect">
             <a:avLst/>
@@ -12343,7 +12705,7 @@
               <a:buNone/>
             </a:pPr>
             <a:r>
-              <a:rPr lang="en-US" sz="830" i="1" dirty="0">
+              <a:rPr lang="en-US" sz="800" i="1" dirty="0">
                 <a:solidFill>
                   <a:srgbClr val="64748B"/>
                 </a:solidFill>
@@ -12351,9 +12713,9 @@
                 <a:ea typeface="Microsoft YaHei" pitchFamily="34" charset="-122"/>
                 <a:cs typeface="Microsoft YaHei" pitchFamily="34" charset="-120"/>
               </a:rPr>
-              <a:t>指标统一：bench_loaders 归一化为同一 schema(多选拼进问题)，judge acc(主)/EM/F1/per-category 一套代码通吃；agent+judge 均 DeepSeek，16 并发；Mem0=并行无合并变体。详见下一页按类别表。</a:t>
+              <a:t>口径：judge acc(主)，agent+judge 均 DeepSeek、16 并发；Mem0=并行无合并变体；A-MEM/HippoRAG 检索 top-k=10 passage(各8条)上下文更大、judge 偏宽松→绝对值偏高，相对排序为准。GroupMem/EverMem 的图记忆全量待跑。</a:t>
             </a:r>
-            <a:endParaRPr lang="en-US" sz="830" dirty="0"/>
+            <a:endParaRPr lang="en-US" sz="800" dirty="0"/>
           </a:p>
         </p:txBody>
       </p:sp>
@@ -12365,7 +12727,7 @@
         </p:nvSpPr>
         <p:spPr>
           <a:xfrm>
-            <a:off x="457200" y="3703320"/>
+            <a:off x="457200" y="3730752"/>
             <a:ext cx="8229600" cy="786384"/>
           </a:xfrm>
           <a:prstGeom prst="rect">
@@ -12392,7 +12754,7 @@
         </p:nvSpPr>
         <p:spPr>
           <a:xfrm>
-            <a:off x="457200" y="3703320"/>
+            <a:off x="457200" y="3730752"/>
             <a:ext cx="54864" cy="786384"/>
           </a:xfrm>
           <a:prstGeom prst="rect">
@@ -12412,7 +12774,7 @@
         </p:nvSpPr>
         <p:spPr>
           <a:xfrm>
-            <a:off x="640080" y="3703320"/>
+            <a:off x="640080" y="3730752"/>
             <a:ext cx="7863840" cy="786384"/>
           </a:xfrm>
           <a:prstGeom prst="rect">
@@ -12432,7 +12794,7 @@
               <a:buNone/>
             </a:pPr>
             <a:r>
-              <a:rPr lang="en-US" sz="950" b="1" dirty="0">
+              <a:rPr lang="en-US" sz="920" b="1" dirty="0">
                 <a:solidFill>
                   <a:srgbClr val="B45309"/>
                 </a:solidFill>
@@ -12440,7 +12802,7 @@
                 <a:ea typeface="Microsoft YaHei" pitchFamily="34" charset="-122"/>
                 <a:cs typeface="Microsoft YaHei" pitchFamily="34" charset="-120"/>
               </a:rPr>
-              <a:t>motivation 坐实：</a:t>
+              <a:t>叙事升级：</a:t>
             </a:r>
             <a:pPr indent="0" marL="0">
               <a:lnSpc>
@@ -12449,7 +12811,7 @@
               <a:buNone/>
             </a:pPr>
             <a:r>
-              <a:rPr lang="en-US" sz="950" dirty="0">
+              <a:rPr lang="en-US" sz="920" dirty="0">
                 <a:solidFill>
                   <a:srgbClr val="334155"/>
                 </a:solidFill>
@@ -12457,7 +12819,7 @@
                 <a:ea typeface="Microsoft YaHei" pitchFamily="34" charset="-122"/>
                 <a:cs typeface="Microsoft YaHei" pitchFamily="34" charset="-120"/>
               </a:rPr>
-              <a:t>BM25 单凭关键词就追平/超过现有记忆系统 → 现有系统在多方场景把 speaker-/audience-grounded 结构线索抹掉了。</a:t>
+              <a:t>不是「记忆系统都没用」，而是「摧毁 speaker-grounding 的摘要式记忆(Mem0，三场全垫底)失败、保留 who-said-what 结构的图记忆(HippoRAG 59/A-MEM 48，反超 BM25 29)有效」</a:t>
             </a:r>
             <a:pPr indent="0" marL="0">
               <a:lnSpc>
@@ -12466,17 +12828,17 @@
               <a:buNone/>
             </a:pPr>
             <a:r>
-              <a:rPr lang="en-US" sz="950" dirty="0">
+              <a:rPr lang="en-US" sz="920" b="1" dirty="0">
                 <a:solidFill>
-                  <a:srgbClr val="64748B"/>
+                  <a:srgbClr val="DC4A52"/>
                 </a:solidFill>
                 <a:latin typeface="Microsoft YaHei" pitchFamily="34" charset="0"/>
                 <a:ea typeface="Microsoft YaHei" pitchFamily="34" charset="-122"/>
                 <a:cs typeface="Microsoft YaHei" pitchFamily="34" charset="-120"/>
               </a:rPr>
-              <a:t>BM25 三数据集全面碾压 Mem0(44.6&gt;21.6/28.6&gt;13.7/52.5&gt;19.9)。</a:t>
+              <a:t> → 正是 SpeakerMem-R1（speaker-grounded 结构化记忆+RL）的直接动机。</a:t>
             </a:r>
-            <a:endParaRPr lang="en-US" sz="950" dirty="0"/>
+            <a:endParaRPr lang="en-US" sz="920" dirty="0"/>
           </a:p>
         </p:txBody>
       </p:sp>
@@ -12552,7 +12914,7 @@
                 <a:ea typeface="Microsoft YaHei" pitchFamily="34" charset="-122"/>
                 <a:cs typeface="Microsoft YaHei" pitchFamily="34" charset="-120"/>
               </a:rPr>
-              <a:t>15 / 16</a:t>
+              <a:t>15 / 17</a:t>
             </a:r>
             <a:endParaRPr lang="en-US" sz="800" dirty="0"/>
           </a:p>
@@ -12643,7 +13005,7 @@
                 <a:ea typeface="Microsoft YaHei" pitchFamily="34" charset="-122"/>
                 <a:cs typeface="Microsoft YaHei" pitchFamily="34" charset="-120"/>
               </a:rPr>
-              <a:t>P4 · 详细结果（SocialMemBench 1031 题）</a:t>
+              <a:t>P4 · 详细结果（SocialMemBench 1031 题，四基线全量）</a:t>
             </a:r>
             <a:endParaRPr lang="en-US" sz="1100" dirty="0"/>
           </a:p>
@@ -12682,7 +13044,7 @@
                 <a:ea typeface="Microsoft YaHei" pitchFamily="34" charset="-122"/>
                 <a:cs typeface="Microsoft YaHei" pitchFamily="34" charset="-120"/>
               </a:rPr>
-              <a:t>按 9 类拆：BM25 几乎全面压过 Mem0</a:t>
+              <a:t>按 9 类拆：Mem0 全垫底；HippoRAG/A-MEM 在归属·ToM·关系类大幅领先</a:t>
             </a:r>
             <a:endParaRPr lang="en-US" sz="2300" dirty="0"/>
           </a:p>
@@ -12803,7 +13165,7 @@
                           <a:ea typeface="Microsoft YaHei" pitchFamily="34" charset="-122"/>
                           <a:cs typeface="Microsoft YaHei" pitchFamily="34" charset="-120"/>
                         </a:rPr>
-                        <a:t>BM25 acc</a:t>
+                        <a:t>BM25</a:t>
                       </a:r>
                       <a:endParaRPr lang="en-US" sz="950" dirty="0">
                         <a:latin typeface="Microsoft YaHei" charset="0"/>
@@ -12871,7 +13233,7 @@
                           <a:ea typeface="Microsoft YaHei" pitchFamily="34" charset="-122"/>
                           <a:cs typeface="Microsoft YaHei" pitchFamily="34" charset="-120"/>
                         </a:rPr>
-                        <a:t>Mem0 acc</a:t>
+                        <a:t>Mem0</a:t>
                       </a:r>
                       <a:endParaRPr lang="en-US" sz="950" dirty="0">
                         <a:latin typeface="Microsoft YaHei" charset="0"/>
@@ -12939,7 +13301,7 @@
                           <a:ea typeface="Microsoft YaHei" pitchFamily="34" charset="-122"/>
                           <a:cs typeface="Microsoft YaHei" pitchFamily="34" charset="-120"/>
                         </a:rPr>
-                        <a:t>BM25 F1</a:t>
+                        <a:t>A-MEM</a:t>
                       </a:r>
                       <a:endParaRPr lang="en-US" sz="950" dirty="0">
                         <a:latin typeface="Microsoft YaHei" charset="0"/>
@@ -13007,7 +13369,7 @@
                           <a:ea typeface="Microsoft YaHei" pitchFamily="34" charset="-122"/>
                           <a:cs typeface="Microsoft YaHei" pitchFamily="34" charset="-120"/>
                         </a:rPr>
-                        <a:t>Mem0 F1</a:t>
+                        <a:t>HippoRAG</a:t>
                       </a:r>
                       <a:endParaRPr lang="en-US" sz="950" dirty="0">
                         <a:latin typeface="Microsoft YaHei" charset="0"/>
@@ -13069,7 +13431,7 @@
                         <a:buNone/>
                       </a:pPr>
                       <a:r>
-                        <a:rPr lang="en-US" sz="840" b="1" dirty="0">
+                        <a:rPr lang="en-US" sz="820" b="1" dirty="0">
                           <a:solidFill>
                             <a:srgbClr val="1E293B"/>
                           </a:solidFill>
@@ -13079,7 +13441,7 @@
                         </a:rPr>
                         <a:t>Q1 单人召回</a:t>
                       </a:r>
-                      <a:endParaRPr lang="en-US" sz="840" dirty="0">
+                      <a:endParaRPr lang="en-US" sz="820" dirty="0">
                         <a:latin typeface="Microsoft YaHei" charset="0"/>
                         <a:ea typeface="Microsoft YaHei" charset="0"/>
                         <a:cs typeface="Microsoft YaHei" charset="0"/>
@@ -13137,9 +13499,9 @@
                         <a:buNone/>
                       </a:pPr>
                       <a:r>
-                        <a:rPr lang="en-US" sz="840" b="1" dirty="0">
+                        <a:rPr lang="en-US" sz="820" dirty="0">
                           <a:solidFill>
-                            <a:srgbClr val="0E7490"/>
+                            <a:srgbClr val="334155"/>
                           </a:solidFill>
                           <a:latin typeface="Microsoft YaHei" pitchFamily="34" charset="0"/>
                           <a:ea typeface="Microsoft YaHei" pitchFamily="34" charset="-122"/>
@@ -13147,7 +13509,7 @@
                         </a:rPr>
                         <a:t>25.3%</a:t>
                       </a:r>
-                      <a:endParaRPr lang="en-US" sz="840" dirty="0">
+                      <a:endParaRPr lang="en-US" sz="820" dirty="0">
                         <a:latin typeface="Microsoft YaHei" charset="0"/>
                         <a:ea typeface="Microsoft YaHei" charset="0"/>
                         <a:cs typeface="Microsoft YaHei" charset="0"/>
@@ -13205,7 +13567,7 @@
                         <a:buNone/>
                       </a:pPr>
                       <a:r>
-                        <a:rPr lang="en-US" sz="840" dirty="0">
+                        <a:rPr lang="en-US" sz="820" dirty="0">
                           <a:solidFill>
                             <a:srgbClr val="B45309"/>
                           </a:solidFill>
@@ -13215,7 +13577,7 @@
                         </a:rPr>
                         <a:t>20.9%</a:t>
                       </a:r>
-                      <a:endParaRPr lang="en-US" sz="840" dirty="0">
+                      <a:endParaRPr lang="en-US" sz="820" dirty="0">
                         <a:latin typeface="Microsoft YaHei" charset="0"/>
                         <a:ea typeface="Microsoft YaHei" charset="0"/>
                         <a:cs typeface="Microsoft YaHei" charset="0"/>
@@ -13273,7 +13635,7 @@
                         <a:buNone/>
                       </a:pPr>
                       <a:r>
-                        <a:rPr lang="en-US" sz="840" dirty="0">
+                        <a:rPr lang="en-US" sz="820" dirty="0">
                           <a:solidFill>
                             <a:srgbClr val="334155"/>
                           </a:solidFill>
@@ -13281,9 +13643,9 @@
                           <a:ea typeface="Microsoft YaHei" pitchFamily="34" charset="-122"/>
                           <a:cs typeface="Microsoft YaHei" pitchFamily="34" charset="-120"/>
                         </a:rPr>
-                        <a:t>13.8</a:t>
+                        <a:t>56.2%</a:t>
                       </a:r>
-                      <a:endParaRPr lang="en-US" sz="840" dirty="0">
+                      <a:endParaRPr lang="en-US" sz="820" dirty="0">
                         <a:latin typeface="Microsoft YaHei" charset="0"/>
                         <a:ea typeface="Microsoft YaHei" charset="0"/>
                         <a:cs typeface="Microsoft YaHei" charset="0"/>
@@ -13341,17 +13703,17 @@
                         <a:buNone/>
                       </a:pPr>
                       <a:r>
-                        <a:rPr lang="en-US" sz="840" dirty="0">
+                        <a:rPr lang="en-US" sz="820" b="1" dirty="0">
                           <a:solidFill>
-                            <a:srgbClr val="334155"/>
+                            <a:srgbClr val="0E9F6E"/>
                           </a:solidFill>
                           <a:latin typeface="Microsoft YaHei" pitchFamily="34" charset="0"/>
                           <a:ea typeface="Microsoft YaHei" pitchFamily="34" charset="-122"/>
                           <a:cs typeface="Microsoft YaHei" pitchFamily="34" charset="-120"/>
                         </a:rPr>
-                        <a:t>12.0</a:t>
+                        <a:t>62.3%</a:t>
                       </a:r>
-                      <a:endParaRPr lang="en-US" sz="840" dirty="0">
+                      <a:endParaRPr lang="en-US" sz="820" dirty="0">
                         <a:latin typeface="Microsoft YaHei" charset="0"/>
                         <a:ea typeface="Microsoft YaHei" charset="0"/>
                         <a:cs typeface="Microsoft YaHei" charset="0"/>
@@ -13411,7 +13773,7 @@
                         <a:buNone/>
                       </a:pPr>
                       <a:r>
-                        <a:rPr lang="en-US" sz="840" b="1" dirty="0">
+                        <a:rPr lang="en-US" sz="820" b="1" dirty="0">
                           <a:solidFill>
                             <a:srgbClr val="1E293B"/>
                           </a:solidFill>
@@ -13421,7 +13783,7 @@
                         </a:rPr>
                         <a:t>Q2 群体决策</a:t>
                       </a:r>
-                      <a:endParaRPr lang="en-US" sz="840" dirty="0">
+                      <a:endParaRPr lang="en-US" sz="820" dirty="0">
                         <a:latin typeface="Microsoft YaHei" charset="0"/>
                         <a:ea typeface="Microsoft YaHei" charset="0"/>
                         <a:cs typeface="Microsoft YaHei" charset="0"/>
@@ -13479,9 +13841,9 @@
                         <a:buNone/>
                       </a:pPr>
                       <a:r>
-                        <a:rPr lang="en-US" sz="840" b="1" dirty="0">
+                        <a:rPr lang="en-US" sz="820" dirty="0">
                           <a:solidFill>
-                            <a:srgbClr val="0E7490"/>
+                            <a:srgbClr val="334155"/>
                           </a:solidFill>
                           <a:latin typeface="Microsoft YaHei" pitchFamily="34" charset="0"/>
                           <a:ea typeface="Microsoft YaHei" pitchFamily="34" charset="-122"/>
@@ -13489,7 +13851,7 @@
                         </a:rPr>
                         <a:t>24.7%</a:t>
                       </a:r>
-                      <a:endParaRPr lang="en-US" sz="840" dirty="0">
+                      <a:endParaRPr lang="en-US" sz="820" dirty="0">
                         <a:latin typeface="Microsoft YaHei" charset="0"/>
                         <a:ea typeface="Microsoft YaHei" charset="0"/>
                         <a:cs typeface="Microsoft YaHei" charset="0"/>
@@ -13547,7 +13909,7 @@
                         <a:buNone/>
                       </a:pPr>
                       <a:r>
-                        <a:rPr lang="en-US" sz="840" dirty="0">
+                        <a:rPr lang="en-US" sz="820" dirty="0">
                           <a:solidFill>
                             <a:srgbClr val="B45309"/>
                           </a:solidFill>
@@ -13557,7 +13919,7 @@
                         </a:rPr>
                         <a:t>14.8%</a:t>
                       </a:r>
-                      <a:endParaRPr lang="en-US" sz="840" dirty="0">
+                      <a:endParaRPr lang="en-US" sz="820" dirty="0">
                         <a:latin typeface="Microsoft YaHei" charset="0"/>
                         <a:ea typeface="Microsoft YaHei" charset="0"/>
                         <a:cs typeface="Microsoft YaHei" charset="0"/>
@@ -13615,7 +13977,7 @@
                         <a:buNone/>
                       </a:pPr>
                       <a:r>
-                        <a:rPr lang="en-US" sz="840" dirty="0">
+                        <a:rPr lang="en-US" sz="820" dirty="0">
                           <a:solidFill>
                             <a:srgbClr val="334155"/>
                           </a:solidFill>
@@ -13623,9 +13985,9 @@
                           <a:ea typeface="Microsoft YaHei" pitchFamily="34" charset="-122"/>
                           <a:cs typeface="Microsoft YaHei" pitchFamily="34" charset="-120"/>
                         </a:rPr>
-                        <a:t>10.3</a:t>
+                        <a:t>33.3%</a:t>
                       </a:r>
-                      <a:endParaRPr lang="en-US" sz="840" dirty="0">
+                      <a:endParaRPr lang="en-US" sz="820" dirty="0">
                         <a:latin typeface="Microsoft YaHei" charset="0"/>
                         <a:ea typeface="Microsoft YaHei" charset="0"/>
                         <a:cs typeface="Microsoft YaHei" charset="0"/>
@@ -13683,17 +14045,17 @@
                         <a:buNone/>
                       </a:pPr>
                       <a:r>
-                        <a:rPr lang="en-US" sz="840" dirty="0">
+                        <a:rPr lang="en-US" sz="820" b="1" dirty="0">
                           <a:solidFill>
-                            <a:srgbClr val="334155"/>
+                            <a:srgbClr val="0E9F6E"/>
                           </a:solidFill>
                           <a:latin typeface="Microsoft YaHei" pitchFamily="34" charset="0"/>
                           <a:ea typeface="Microsoft YaHei" pitchFamily="34" charset="-122"/>
                           <a:cs typeface="Microsoft YaHei" pitchFamily="34" charset="-120"/>
                         </a:rPr>
-                        <a:t>7.4</a:t>
+                        <a:t>34.6%</a:t>
                       </a:r>
-                      <a:endParaRPr lang="en-US" sz="840" dirty="0">
+                      <a:endParaRPr lang="en-US" sz="820" dirty="0">
                         <a:latin typeface="Microsoft YaHei" charset="0"/>
                         <a:ea typeface="Microsoft YaHei" charset="0"/>
                         <a:cs typeface="Microsoft YaHei" charset="0"/>
@@ -13753,7 +14115,7 @@
                         <a:buNone/>
                       </a:pPr>
                       <a:r>
-                        <a:rPr lang="en-US" sz="840" b="1" dirty="0">
+                        <a:rPr lang="en-US" sz="820" b="1" dirty="0">
                           <a:solidFill>
                             <a:srgbClr val="1E293B"/>
                           </a:solidFill>
@@ -13763,7 +14125,7 @@
                         </a:rPr>
                         <a:t>Q3 多人聚合</a:t>
                       </a:r>
-                      <a:endParaRPr lang="en-US" sz="840" dirty="0">
+                      <a:endParaRPr lang="en-US" sz="820" dirty="0">
                         <a:latin typeface="Microsoft YaHei" charset="0"/>
                         <a:ea typeface="Microsoft YaHei" charset="0"/>
                         <a:cs typeface="Microsoft YaHei" charset="0"/>
@@ -13821,9 +14183,9 @@
                         <a:buNone/>
                       </a:pPr>
                       <a:r>
-                        <a:rPr lang="en-US" sz="840" b="1" dirty="0">
+                        <a:rPr lang="en-US" sz="820" b="1" dirty="0">
                           <a:solidFill>
-                            <a:srgbClr val="0E7490"/>
+                            <a:srgbClr val="0E9F6E"/>
                           </a:solidFill>
                           <a:latin typeface="Microsoft YaHei" pitchFamily="34" charset="0"/>
                           <a:ea typeface="Microsoft YaHei" pitchFamily="34" charset="-122"/>
@@ -13831,7 +14193,7 @@
                         </a:rPr>
                         <a:t>4.5%</a:t>
                       </a:r>
-                      <a:endParaRPr lang="en-US" sz="840" dirty="0">
+                      <a:endParaRPr lang="en-US" sz="820" dirty="0">
                         <a:latin typeface="Microsoft YaHei" charset="0"/>
                         <a:ea typeface="Microsoft YaHei" charset="0"/>
                         <a:cs typeface="Microsoft YaHei" charset="0"/>
@@ -13889,9 +14251,9 @@
                         <a:buNone/>
                       </a:pPr>
                       <a:r>
-                        <a:rPr lang="en-US" sz="840" dirty="0">
+                        <a:rPr lang="en-US" sz="820" b="1" dirty="0">
                           <a:solidFill>
-                            <a:srgbClr val="B45309"/>
+                            <a:srgbClr val="0E9F6E"/>
                           </a:solidFill>
                           <a:latin typeface="Microsoft YaHei" pitchFamily="34" charset="0"/>
                           <a:ea typeface="Microsoft YaHei" pitchFamily="34" charset="-122"/>
@@ -13899,7 +14261,7 @@
                         </a:rPr>
                         <a:t>4.5%</a:t>
                       </a:r>
-                      <a:endParaRPr lang="en-US" sz="840" dirty="0">
+                      <a:endParaRPr lang="en-US" sz="820" dirty="0">
                         <a:latin typeface="Microsoft YaHei" charset="0"/>
                         <a:ea typeface="Microsoft YaHei" charset="0"/>
                         <a:cs typeface="Microsoft YaHei" charset="0"/>
@@ -13957,17 +14319,17 @@
                         <a:buNone/>
                       </a:pPr>
                       <a:r>
-                        <a:rPr lang="en-US" sz="840" dirty="0">
+                        <a:rPr lang="en-US" sz="820" b="1" dirty="0">
                           <a:solidFill>
-                            <a:srgbClr val="334155"/>
+                            <a:srgbClr val="0E9F6E"/>
                           </a:solidFill>
                           <a:latin typeface="Microsoft YaHei" pitchFamily="34" charset="0"/>
                           <a:ea typeface="Microsoft YaHei" pitchFamily="34" charset="-122"/>
                           <a:cs typeface="Microsoft YaHei" pitchFamily="34" charset="-120"/>
                         </a:rPr>
-                        <a:t>12.1</a:t>
+                        <a:t>4.5%</a:t>
                       </a:r>
-                      <a:endParaRPr lang="en-US" sz="840" dirty="0">
+                      <a:endParaRPr lang="en-US" sz="820" dirty="0">
                         <a:latin typeface="Microsoft YaHei" charset="0"/>
                         <a:ea typeface="Microsoft YaHei" charset="0"/>
                         <a:cs typeface="Microsoft YaHei" charset="0"/>
@@ -14025,7 +14387,7 @@
                         <a:buNone/>
                       </a:pPr>
                       <a:r>
-                        <a:rPr lang="en-US" sz="840" dirty="0">
+                        <a:rPr lang="en-US" sz="820" dirty="0">
                           <a:solidFill>
                             <a:srgbClr val="334155"/>
                           </a:solidFill>
@@ -14033,9 +14395,9 @@
                           <a:ea typeface="Microsoft YaHei" pitchFamily="34" charset="-122"/>
                           <a:cs typeface="Microsoft YaHei" pitchFamily="34" charset="-120"/>
                         </a:rPr>
-                        <a:t>15.8</a:t>
+                        <a:t>0.0%</a:t>
                       </a:r>
-                      <a:endParaRPr lang="en-US" sz="840" dirty="0">
+                      <a:endParaRPr lang="en-US" sz="820" dirty="0">
                         <a:latin typeface="Microsoft YaHei" charset="0"/>
                         <a:ea typeface="Microsoft YaHei" charset="0"/>
                         <a:cs typeface="Microsoft YaHei" charset="0"/>
@@ -14095,7 +14457,7 @@
                         <a:buNone/>
                       </a:pPr>
                       <a:r>
-                        <a:rPr lang="en-US" sz="840" b="1" dirty="0">
+                        <a:rPr lang="en-US" sz="820" b="1" dirty="0">
                           <a:solidFill>
                             <a:srgbClr val="1E293B"/>
                           </a:solidFill>
@@ -14105,7 +14467,7 @@
                         </a:rPr>
                         <a:t>Q4 归属探针</a:t>
                       </a:r>
-                      <a:endParaRPr lang="en-US" sz="840" dirty="0">
+                      <a:endParaRPr lang="en-US" sz="820" dirty="0">
                         <a:latin typeface="Microsoft YaHei" charset="0"/>
                         <a:ea typeface="Microsoft YaHei" charset="0"/>
                         <a:cs typeface="Microsoft YaHei" charset="0"/>
@@ -14163,9 +14525,9 @@
                         <a:buNone/>
                       </a:pPr>
                       <a:r>
-                        <a:rPr lang="en-US" sz="840" b="1" dirty="0">
+                        <a:rPr lang="en-US" sz="820" dirty="0">
                           <a:solidFill>
-                            <a:srgbClr val="DC4A52"/>
+                            <a:srgbClr val="334155"/>
                           </a:solidFill>
                           <a:latin typeface="Microsoft YaHei" pitchFamily="34" charset="0"/>
                           <a:ea typeface="Microsoft YaHei" pitchFamily="34" charset="-122"/>
@@ -14173,7 +14535,7 @@
                         </a:rPr>
                         <a:t>66.2%</a:t>
                       </a:r>
-                      <a:endParaRPr lang="en-US" sz="840" dirty="0">
+                      <a:endParaRPr lang="en-US" sz="820" dirty="0">
                         <a:latin typeface="Microsoft YaHei" charset="0"/>
                         <a:ea typeface="Microsoft YaHei" charset="0"/>
                         <a:cs typeface="Microsoft YaHei" charset="0"/>
@@ -14231,7 +14593,7 @@
                         <a:buNone/>
                       </a:pPr>
                       <a:r>
-                        <a:rPr lang="en-US" sz="840" dirty="0">
+                        <a:rPr lang="en-US" sz="820" dirty="0">
                           <a:solidFill>
                             <a:srgbClr val="B45309"/>
                           </a:solidFill>
@@ -14241,7 +14603,7 @@
                         </a:rPr>
                         <a:t>11.2%</a:t>
                       </a:r>
-                      <a:endParaRPr lang="en-US" sz="840" dirty="0">
+                      <a:endParaRPr lang="en-US" sz="820" dirty="0">
                         <a:latin typeface="Microsoft YaHei" charset="0"/>
                         <a:ea typeface="Microsoft YaHei" charset="0"/>
                         <a:cs typeface="Microsoft YaHei" charset="0"/>
@@ -14299,7 +14661,7 @@
                         <a:buNone/>
                       </a:pPr>
                       <a:r>
-                        <a:rPr lang="en-US" sz="840" dirty="0">
+                        <a:rPr lang="en-US" sz="820" dirty="0">
                           <a:solidFill>
                             <a:srgbClr val="334155"/>
                           </a:solidFill>
@@ -14307,9 +14669,9 @@
                           <a:ea typeface="Microsoft YaHei" pitchFamily="34" charset="-122"/>
                           <a:cs typeface="Microsoft YaHei" pitchFamily="34" charset="-120"/>
                         </a:rPr>
-                        <a:t>38.1</a:t>
+                        <a:t>66.2%</a:t>
                       </a:r>
-                      <a:endParaRPr lang="en-US" sz="840" dirty="0">
+                      <a:endParaRPr lang="en-US" sz="820" dirty="0">
                         <a:latin typeface="Microsoft YaHei" charset="0"/>
                         <a:ea typeface="Microsoft YaHei" charset="0"/>
                         <a:cs typeface="Microsoft YaHei" charset="0"/>
@@ -14367,17 +14729,17 @@
                         <a:buNone/>
                       </a:pPr>
                       <a:r>
-                        <a:rPr lang="en-US" sz="840" dirty="0">
+                        <a:rPr lang="en-US" sz="820" b="1" dirty="0">
                           <a:solidFill>
-                            <a:srgbClr val="334155"/>
+                            <a:srgbClr val="0E9F6E"/>
                           </a:solidFill>
                           <a:latin typeface="Microsoft YaHei" pitchFamily="34" charset="0"/>
                           <a:ea typeface="Microsoft YaHei" pitchFamily="34" charset="-122"/>
                           <a:cs typeface="Microsoft YaHei" pitchFamily="34" charset="-120"/>
                         </a:rPr>
-                        <a:t>6.7</a:t>
+                        <a:t>70.0%</a:t>
                       </a:r>
-                      <a:endParaRPr lang="en-US" sz="840" dirty="0">
+                      <a:endParaRPr lang="en-US" sz="820" dirty="0">
                         <a:latin typeface="Microsoft YaHei" charset="0"/>
                         <a:ea typeface="Microsoft YaHei" charset="0"/>
                         <a:cs typeface="Microsoft YaHei" charset="0"/>
@@ -14437,7 +14799,7 @@
                         <a:buNone/>
                       </a:pPr>
                       <a:r>
-                        <a:rPr lang="en-US" sz="840" b="1" dirty="0">
+                        <a:rPr lang="en-US" sz="820" b="1" dirty="0">
                           <a:solidFill>
                             <a:srgbClr val="1E293B"/>
                           </a:solidFill>
@@ -14447,7 +14809,7 @@
                         </a:rPr>
                         <a:t>Q5 ToM 揣测</a:t>
                       </a:r>
-                      <a:endParaRPr lang="en-US" sz="840" dirty="0">
+                      <a:endParaRPr lang="en-US" sz="820" dirty="0">
                         <a:latin typeface="Microsoft YaHei" charset="0"/>
                         <a:ea typeface="Microsoft YaHei" charset="0"/>
                         <a:cs typeface="Microsoft YaHei" charset="0"/>
@@ -14505,9 +14867,9 @@
                         <a:buNone/>
                       </a:pPr>
                       <a:r>
-                        <a:rPr lang="en-US" sz="840" b="1" dirty="0">
+                        <a:rPr lang="en-US" sz="820" dirty="0">
                           <a:solidFill>
-                            <a:srgbClr val="DC4A52"/>
+                            <a:srgbClr val="334155"/>
                           </a:solidFill>
                           <a:latin typeface="Microsoft YaHei" pitchFamily="34" charset="0"/>
                           <a:ea typeface="Microsoft YaHei" pitchFamily="34" charset="-122"/>
@@ -14515,7 +14877,7 @@
                         </a:rPr>
                         <a:t>38.0%</a:t>
                       </a:r>
-                      <a:endParaRPr lang="en-US" sz="840" dirty="0">
+                      <a:endParaRPr lang="en-US" sz="820" dirty="0">
                         <a:latin typeface="Microsoft YaHei" charset="0"/>
                         <a:ea typeface="Microsoft YaHei" charset="0"/>
                         <a:cs typeface="Microsoft YaHei" charset="0"/>
@@ -14573,7 +14935,7 @@
                         <a:buNone/>
                       </a:pPr>
                       <a:r>
-                        <a:rPr lang="en-US" sz="840" dirty="0">
+                        <a:rPr lang="en-US" sz="820" dirty="0">
                           <a:solidFill>
                             <a:srgbClr val="B45309"/>
                           </a:solidFill>
@@ -14583,7 +14945,7 @@
                         </a:rPr>
                         <a:t>3.3%</a:t>
                       </a:r>
-                      <a:endParaRPr lang="en-US" sz="840" dirty="0">
+                      <a:endParaRPr lang="en-US" sz="820" dirty="0">
                         <a:latin typeface="Microsoft YaHei" charset="0"/>
                         <a:ea typeface="Microsoft YaHei" charset="0"/>
                         <a:cs typeface="Microsoft YaHei" charset="0"/>
@@ -14641,7 +15003,7 @@
                         <a:buNone/>
                       </a:pPr>
                       <a:r>
-                        <a:rPr lang="en-US" sz="840" dirty="0">
+                        <a:rPr lang="en-US" sz="820" dirty="0">
                           <a:solidFill>
                             <a:srgbClr val="334155"/>
                           </a:solidFill>
@@ -14649,9 +15011,9 @@
                           <a:ea typeface="Microsoft YaHei" pitchFamily="34" charset="-122"/>
                           <a:cs typeface="Microsoft YaHei" pitchFamily="34" charset="-120"/>
                         </a:rPr>
-                        <a:t>18.7</a:t>
+                        <a:t>60.9%</a:t>
                       </a:r>
-                      <a:endParaRPr lang="en-US" sz="840" dirty="0">
+                      <a:endParaRPr lang="en-US" sz="820" dirty="0">
                         <a:latin typeface="Microsoft YaHei" charset="0"/>
                         <a:ea typeface="Microsoft YaHei" charset="0"/>
                         <a:cs typeface="Microsoft YaHei" charset="0"/>
@@ -14709,17 +15071,17 @@
                         <a:buNone/>
                       </a:pPr>
                       <a:r>
-                        <a:rPr lang="en-US" sz="840" dirty="0">
+                        <a:rPr lang="en-US" sz="820" b="1" dirty="0">
                           <a:solidFill>
-                            <a:srgbClr val="334155"/>
+                            <a:srgbClr val="0E9F6E"/>
                           </a:solidFill>
                           <a:latin typeface="Microsoft YaHei" pitchFamily="34" charset="0"/>
                           <a:ea typeface="Microsoft YaHei" pitchFamily="34" charset="-122"/>
                           <a:cs typeface="Microsoft YaHei" pitchFamily="34" charset="-120"/>
                         </a:rPr>
-                        <a:t>10.4</a:t>
+                        <a:t>73.9%</a:t>
                       </a:r>
-                      <a:endParaRPr lang="en-US" sz="840" dirty="0">
+                      <a:endParaRPr lang="en-US" sz="820" dirty="0">
                         <a:latin typeface="Microsoft YaHei" charset="0"/>
                         <a:ea typeface="Microsoft YaHei" charset="0"/>
                         <a:cs typeface="Microsoft YaHei" charset="0"/>
@@ -14779,7 +15141,7 @@
                         <a:buNone/>
                       </a:pPr>
                       <a:r>
-                        <a:rPr lang="en-US" sz="840" b="1" dirty="0">
+                        <a:rPr lang="en-US" sz="820" b="1" dirty="0">
                           <a:solidFill>
                             <a:srgbClr val="1E293B"/>
                           </a:solidFill>
@@ -14789,7 +15151,7 @@
                         </a:rPr>
                         <a:t>Q6 群规vs个人</a:t>
                       </a:r>
-                      <a:endParaRPr lang="en-US" sz="840" dirty="0">
+                      <a:endParaRPr lang="en-US" sz="820" dirty="0">
                         <a:latin typeface="Microsoft YaHei" charset="0"/>
                         <a:ea typeface="Microsoft YaHei" charset="0"/>
                         <a:cs typeface="Microsoft YaHei" charset="0"/>
@@ -14847,9 +15209,9 @@
                         <a:buNone/>
                       </a:pPr>
                       <a:r>
-                        <a:rPr lang="en-US" sz="840" b="1" dirty="0">
+                        <a:rPr lang="en-US" sz="820" dirty="0">
                           <a:solidFill>
-                            <a:srgbClr val="0E7490"/>
+                            <a:srgbClr val="334155"/>
                           </a:solidFill>
                           <a:latin typeface="Microsoft YaHei" pitchFamily="34" charset="0"/>
                           <a:ea typeface="Microsoft YaHei" pitchFamily="34" charset="-122"/>
@@ -14857,7 +15219,7 @@
                         </a:rPr>
                         <a:t>25.9%</a:t>
                       </a:r>
-                      <a:endParaRPr lang="en-US" sz="840" dirty="0">
+                      <a:endParaRPr lang="en-US" sz="820" dirty="0">
                         <a:latin typeface="Microsoft YaHei" charset="0"/>
                         <a:ea typeface="Microsoft YaHei" charset="0"/>
                         <a:cs typeface="Microsoft YaHei" charset="0"/>
@@ -14915,7 +15277,7 @@
                         <a:buNone/>
                       </a:pPr>
                       <a:r>
-                        <a:rPr lang="en-US" sz="840" dirty="0">
+                        <a:rPr lang="en-US" sz="820" dirty="0">
                           <a:solidFill>
                             <a:srgbClr val="B45309"/>
                           </a:solidFill>
@@ -14925,7 +15287,7 @@
                         </a:rPr>
                         <a:t>25.9%</a:t>
                       </a:r>
-                      <a:endParaRPr lang="en-US" sz="840" dirty="0">
+                      <a:endParaRPr lang="en-US" sz="820" dirty="0">
                         <a:latin typeface="Microsoft YaHei" charset="0"/>
                         <a:ea typeface="Microsoft YaHei" charset="0"/>
                         <a:cs typeface="Microsoft YaHei" charset="0"/>
@@ -14983,7 +15345,7 @@
                         <a:buNone/>
                       </a:pPr>
                       <a:r>
-                        <a:rPr lang="en-US" sz="840" dirty="0">
+                        <a:rPr lang="en-US" sz="820" dirty="0">
                           <a:solidFill>
                             <a:srgbClr val="334155"/>
                           </a:solidFill>
@@ -14991,9 +15353,9 @@
                           <a:ea typeface="Microsoft YaHei" pitchFamily="34" charset="-122"/>
                           <a:cs typeface="Microsoft YaHei" pitchFamily="34" charset="-120"/>
                         </a:rPr>
-                        <a:t>14.5</a:t>
+                        <a:t>33.3%</a:t>
                       </a:r>
-                      <a:endParaRPr lang="en-US" sz="840" dirty="0">
+                      <a:endParaRPr lang="en-US" sz="820" dirty="0">
                         <a:latin typeface="Microsoft YaHei" charset="0"/>
                         <a:ea typeface="Microsoft YaHei" charset="0"/>
                         <a:cs typeface="Microsoft YaHei" charset="0"/>
@@ -15051,17 +15413,17 @@
                         <a:buNone/>
                       </a:pPr>
                       <a:r>
-                        <a:rPr lang="en-US" sz="840" dirty="0">
+                        <a:rPr lang="en-US" sz="820" b="1" dirty="0">
                           <a:solidFill>
-                            <a:srgbClr val="334155"/>
+                            <a:srgbClr val="0E9F6E"/>
                           </a:solidFill>
                           <a:latin typeface="Microsoft YaHei" pitchFamily="34" charset="0"/>
                           <a:ea typeface="Microsoft YaHei" pitchFamily="34" charset="-122"/>
                           <a:cs typeface="Microsoft YaHei" pitchFamily="34" charset="-120"/>
                         </a:rPr>
-                        <a:t>12.3</a:t>
+                        <a:t>46.3%</a:t>
                       </a:r>
-                      <a:endParaRPr lang="en-US" sz="840" dirty="0">
+                      <a:endParaRPr lang="en-US" sz="820" dirty="0">
                         <a:latin typeface="Microsoft YaHei" charset="0"/>
                         <a:ea typeface="Microsoft YaHei" charset="0"/>
                         <a:cs typeface="Microsoft YaHei" charset="0"/>
@@ -15121,7 +15483,7 @@
                         <a:buNone/>
                       </a:pPr>
                       <a:r>
-                        <a:rPr lang="en-US" sz="840" b="1" dirty="0">
+                        <a:rPr lang="en-US" sz="820" b="1" dirty="0">
                           <a:solidFill>
                             <a:srgbClr val="1E293B"/>
                           </a:solidFill>
@@ -15131,7 +15493,7 @@
                         </a:rPr>
                         <a:t>Q7 关系边</a:t>
                       </a:r>
-                      <a:endParaRPr lang="en-US" sz="840" dirty="0">
+                      <a:endParaRPr lang="en-US" sz="820" dirty="0">
                         <a:latin typeface="Microsoft YaHei" charset="0"/>
                         <a:ea typeface="Microsoft YaHei" charset="0"/>
                         <a:cs typeface="Microsoft YaHei" charset="0"/>
@@ -15189,9 +15551,9 @@
                         <a:buNone/>
                       </a:pPr>
                       <a:r>
-                        <a:rPr lang="en-US" sz="840" b="1" dirty="0">
+                        <a:rPr lang="en-US" sz="820" dirty="0">
                           <a:solidFill>
-                            <a:srgbClr val="DC4A52"/>
+                            <a:srgbClr val="334155"/>
                           </a:solidFill>
                           <a:latin typeface="Microsoft YaHei" pitchFamily="34" charset="0"/>
                           <a:ea typeface="Microsoft YaHei" pitchFamily="34" charset="-122"/>
@@ -15199,7 +15561,7 @@
                         </a:rPr>
                         <a:t>29.8%</a:t>
                       </a:r>
-                      <a:endParaRPr lang="en-US" sz="840" dirty="0">
+                      <a:endParaRPr lang="en-US" sz="820" dirty="0">
                         <a:latin typeface="Microsoft YaHei" charset="0"/>
                         <a:ea typeface="Microsoft YaHei" charset="0"/>
                         <a:cs typeface="Microsoft YaHei" charset="0"/>
@@ -15257,7 +15619,7 @@
                         <a:buNone/>
                       </a:pPr>
                       <a:r>
-                        <a:rPr lang="en-US" sz="840" dirty="0">
+                        <a:rPr lang="en-US" sz="820" dirty="0">
                           <a:solidFill>
                             <a:srgbClr val="B45309"/>
                           </a:solidFill>
@@ -15267,7 +15629,7 @@
                         </a:rPr>
                         <a:t>9.4%</a:t>
                       </a:r>
-                      <a:endParaRPr lang="en-US" sz="840" dirty="0">
+                      <a:endParaRPr lang="en-US" sz="820" dirty="0">
                         <a:latin typeface="Microsoft YaHei" charset="0"/>
                         <a:ea typeface="Microsoft YaHei" charset="0"/>
                         <a:cs typeface="Microsoft YaHei" charset="0"/>
@@ -15325,7 +15687,7 @@
                         <a:buNone/>
                       </a:pPr>
                       <a:r>
-                        <a:rPr lang="en-US" sz="840" dirty="0">
+                        <a:rPr lang="en-US" sz="820" dirty="0">
                           <a:solidFill>
                             <a:srgbClr val="334155"/>
                           </a:solidFill>
@@ -15333,9 +15695,9 @@
                           <a:ea typeface="Microsoft YaHei" pitchFamily="34" charset="-122"/>
                           <a:cs typeface="Microsoft YaHei" pitchFamily="34" charset="-120"/>
                         </a:rPr>
-                        <a:t>15.7</a:t>
+                        <a:t>51.9%</a:t>
                       </a:r>
-                      <a:endParaRPr lang="en-US" sz="840" dirty="0">
+                      <a:endParaRPr lang="en-US" sz="820" dirty="0">
                         <a:latin typeface="Microsoft YaHei" charset="0"/>
                         <a:ea typeface="Microsoft YaHei" charset="0"/>
                         <a:cs typeface="Microsoft YaHei" charset="0"/>
@@ -15393,17 +15755,17 @@
                         <a:buNone/>
                       </a:pPr>
                       <a:r>
-                        <a:rPr lang="en-US" sz="840" dirty="0">
+                        <a:rPr lang="en-US" sz="820" b="1" dirty="0">
                           <a:solidFill>
-                            <a:srgbClr val="334155"/>
+                            <a:srgbClr val="0E9F6E"/>
                           </a:solidFill>
                           <a:latin typeface="Microsoft YaHei" pitchFamily="34" charset="0"/>
                           <a:ea typeface="Microsoft YaHei" pitchFamily="34" charset="-122"/>
                           <a:cs typeface="Microsoft YaHei" pitchFamily="34" charset="-120"/>
                         </a:rPr>
-                        <a:t>10.7</a:t>
+                        <a:t>63.0%</a:t>
                       </a:r>
-                      <a:endParaRPr lang="en-US" sz="840" dirty="0">
+                      <a:endParaRPr lang="en-US" sz="820" dirty="0">
                         <a:latin typeface="Microsoft YaHei" charset="0"/>
                         <a:ea typeface="Microsoft YaHei" charset="0"/>
                         <a:cs typeface="Microsoft YaHei" charset="0"/>
@@ -15463,7 +15825,7 @@
                         <a:buNone/>
                       </a:pPr>
                       <a:r>
-                        <a:rPr lang="en-US" sz="840" b="1" dirty="0">
+                        <a:rPr lang="en-US" sz="820" b="1" dirty="0">
                           <a:solidFill>
                             <a:srgbClr val="1E293B"/>
                           </a:solidFill>
@@ -15473,7 +15835,7 @@
                         </a:rPr>
                         <a:t>Q8 时间漂移</a:t>
                       </a:r>
-                      <a:endParaRPr lang="en-US" sz="840" dirty="0">
+                      <a:endParaRPr lang="en-US" sz="820" dirty="0">
                         <a:latin typeface="Microsoft YaHei" charset="0"/>
                         <a:ea typeface="Microsoft YaHei" charset="0"/>
                         <a:cs typeface="Microsoft YaHei" charset="0"/>
@@ -15531,9 +15893,9 @@
                         <a:buNone/>
                       </a:pPr>
                       <a:r>
-                        <a:rPr lang="en-US" sz="840" b="1" dirty="0">
+                        <a:rPr lang="en-US" sz="820" dirty="0">
                           <a:solidFill>
-                            <a:srgbClr val="0E7490"/>
+                            <a:srgbClr val="334155"/>
                           </a:solidFill>
                           <a:latin typeface="Microsoft YaHei" pitchFamily="34" charset="0"/>
                           <a:ea typeface="Microsoft YaHei" pitchFamily="34" charset="-122"/>
@@ -15541,7 +15903,7 @@
                         </a:rPr>
                         <a:t>20.6%</a:t>
                       </a:r>
-                      <a:endParaRPr lang="en-US" sz="840" dirty="0">
+                      <a:endParaRPr lang="en-US" sz="820" dirty="0">
                         <a:latin typeface="Microsoft YaHei" charset="0"/>
                         <a:ea typeface="Microsoft YaHei" charset="0"/>
                         <a:cs typeface="Microsoft YaHei" charset="0"/>
@@ -15599,7 +15961,7 @@
                         <a:buNone/>
                       </a:pPr>
                       <a:r>
-                        <a:rPr lang="en-US" sz="840" dirty="0">
+                        <a:rPr lang="en-US" sz="820" dirty="0">
                           <a:solidFill>
                             <a:srgbClr val="B45309"/>
                           </a:solidFill>
@@ -15609,7 +15971,7 @@
                         </a:rPr>
                         <a:t>12.2%</a:t>
                       </a:r>
-                      <a:endParaRPr lang="en-US" sz="840" dirty="0">
+                      <a:endParaRPr lang="en-US" sz="820" dirty="0">
                         <a:latin typeface="Microsoft YaHei" charset="0"/>
                         <a:ea typeface="Microsoft YaHei" charset="0"/>
                         <a:cs typeface="Microsoft YaHei" charset="0"/>
@@ -15667,7 +16029,7 @@
                         <a:buNone/>
                       </a:pPr>
                       <a:r>
-                        <a:rPr lang="en-US" sz="840" dirty="0">
+                        <a:rPr lang="en-US" sz="820" dirty="0">
                           <a:solidFill>
                             <a:srgbClr val="334155"/>
                           </a:solidFill>
@@ -15675,9 +16037,9 @@
                           <a:ea typeface="Microsoft YaHei" pitchFamily="34" charset="-122"/>
                           <a:cs typeface="Microsoft YaHei" pitchFamily="34" charset="-120"/>
                         </a:rPr>
-                        <a:t>12.2</a:t>
+                        <a:t>39.3%</a:t>
                       </a:r>
-                      <a:endParaRPr lang="en-US" sz="840" dirty="0">
+                      <a:endParaRPr lang="en-US" sz="820" dirty="0">
                         <a:latin typeface="Microsoft YaHei" charset="0"/>
                         <a:ea typeface="Microsoft YaHei" charset="0"/>
                         <a:cs typeface="Microsoft YaHei" charset="0"/>
@@ -15735,17 +16097,17 @@
                         <a:buNone/>
                       </a:pPr>
                       <a:r>
-                        <a:rPr lang="en-US" sz="840" dirty="0">
+                        <a:rPr lang="en-US" sz="820" b="1" dirty="0">
                           <a:solidFill>
-                            <a:srgbClr val="334155"/>
+                            <a:srgbClr val="0E9F6E"/>
                           </a:solidFill>
                           <a:latin typeface="Microsoft YaHei" pitchFamily="34" charset="0"/>
                           <a:ea typeface="Microsoft YaHei" pitchFamily="34" charset="-122"/>
                           <a:cs typeface="Microsoft YaHei" pitchFamily="34" charset="-120"/>
                         </a:rPr>
-                        <a:t>10.4</a:t>
+                        <a:t>58.8%</a:t>
                       </a:r>
-                      <a:endParaRPr lang="en-US" sz="840" dirty="0">
+                      <a:endParaRPr lang="en-US" sz="820" dirty="0">
                         <a:latin typeface="Microsoft YaHei" charset="0"/>
                         <a:ea typeface="Microsoft YaHei" charset="0"/>
                         <a:cs typeface="Microsoft YaHei" charset="0"/>
@@ -15805,7 +16167,7 @@
                         <a:buNone/>
                       </a:pPr>
                       <a:r>
-                        <a:rPr lang="en-US" sz="840" b="1" dirty="0">
+                        <a:rPr lang="en-US" sz="820" b="1" dirty="0">
                           <a:solidFill>
                             <a:srgbClr val="1E293B"/>
                           </a:solidFill>
@@ -15815,7 +16177,7 @@
                         </a:rPr>
                         <a:t>Q9 离群成员</a:t>
                       </a:r>
-                      <a:endParaRPr lang="en-US" sz="840" dirty="0">
+                      <a:endParaRPr lang="en-US" sz="820" dirty="0">
                         <a:latin typeface="Microsoft YaHei" charset="0"/>
                         <a:ea typeface="Microsoft YaHei" charset="0"/>
                         <a:cs typeface="Microsoft YaHei" charset="0"/>
@@ -15873,9 +16235,9 @@
                         <a:buNone/>
                       </a:pPr>
                       <a:r>
-                        <a:rPr lang="en-US" sz="840" b="1" dirty="0">
+                        <a:rPr lang="en-US" sz="820" dirty="0">
                           <a:solidFill>
-                            <a:srgbClr val="0E7490"/>
+                            <a:srgbClr val="334155"/>
                           </a:solidFill>
                           <a:latin typeface="Microsoft YaHei" pitchFamily="34" charset="0"/>
                           <a:ea typeface="Microsoft YaHei" pitchFamily="34" charset="-122"/>
@@ -15883,7 +16245,7 @@
                         </a:rPr>
                         <a:t>10.0%</a:t>
                       </a:r>
-                      <a:endParaRPr lang="en-US" sz="840" dirty="0">
+                      <a:endParaRPr lang="en-US" sz="820" dirty="0">
                         <a:latin typeface="Microsoft YaHei" charset="0"/>
                         <a:ea typeface="Microsoft YaHei" charset="0"/>
                         <a:cs typeface="Microsoft YaHei" charset="0"/>
@@ -15941,7 +16303,7 @@
                         <a:buNone/>
                       </a:pPr>
                       <a:r>
-                        <a:rPr lang="en-US" sz="840" dirty="0">
+                        <a:rPr lang="en-US" sz="820" dirty="0">
                           <a:solidFill>
                             <a:srgbClr val="B45309"/>
                           </a:solidFill>
@@ -15951,7 +16313,7 @@
                         </a:rPr>
                         <a:t>10.0%</a:t>
                       </a:r>
-                      <a:endParaRPr lang="en-US" sz="840" dirty="0">
+                      <a:endParaRPr lang="en-US" sz="820" dirty="0">
                         <a:latin typeface="Microsoft YaHei" charset="0"/>
                         <a:ea typeface="Microsoft YaHei" charset="0"/>
                         <a:cs typeface="Microsoft YaHei" charset="0"/>
@@ -16009,7 +16371,7 @@
                         <a:buNone/>
                       </a:pPr>
                       <a:r>
-                        <a:rPr lang="en-US" sz="840" dirty="0">
+                        <a:rPr lang="en-US" sz="820" dirty="0">
                           <a:solidFill>
                             <a:srgbClr val="334155"/>
                           </a:solidFill>
@@ -16017,9 +16379,9 @@
                           <a:ea typeface="Microsoft YaHei" pitchFamily="34" charset="-122"/>
                           <a:cs typeface="Microsoft YaHei" pitchFamily="34" charset="-120"/>
                         </a:rPr>
-                        <a:t>8.2</a:t>
+                        <a:t>40.0%</a:t>
                       </a:r>
-                      <a:endParaRPr lang="en-US" sz="840" dirty="0">
+                      <a:endParaRPr lang="en-US" sz="820" dirty="0">
                         <a:latin typeface="Microsoft YaHei" charset="0"/>
                         <a:ea typeface="Microsoft YaHei" charset="0"/>
                         <a:cs typeface="Microsoft YaHei" charset="0"/>
@@ -16077,17 +16439,17 @@
                         <a:buNone/>
                       </a:pPr>
                       <a:r>
-                        <a:rPr lang="en-US" sz="840" dirty="0">
+                        <a:rPr lang="en-US" sz="820" b="1" dirty="0">
                           <a:solidFill>
-                            <a:srgbClr val="334155"/>
+                            <a:srgbClr val="0E9F6E"/>
                           </a:solidFill>
                           <a:latin typeface="Microsoft YaHei" pitchFamily="34" charset="0"/>
                           <a:ea typeface="Microsoft YaHei" pitchFamily="34" charset="-122"/>
                           <a:cs typeface="Microsoft YaHei" pitchFamily="34" charset="-120"/>
                         </a:rPr>
-                        <a:t>10.4</a:t>
+                        <a:t>80.0%</a:t>
                       </a:r>
-                      <a:endParaRPr lang="en-US" sz="840" dirty="0">
+                      <a:endParaRPr lang="en-US" sz="820" dirty="0">
                         <a:latin typeface="Microsoft YaHei" charset="0"/>
                         <a:ea typeface="Microsoft YaHei" charset="0"/>
                         <a:cs typeface="Microsoft YaHei" charset="0"/>
@@ -16147,7 +16509,7 @@
                         <a:buNone/>
                       </a:pPr>
                       <a:r>
-                        <a:rPr lang="en-US" sz="860" b="1" dirty="0">
+                        <a:rPr lang="en-US" sz="840" b="1" dirty="0">
                           <a:solidFill>
                             <a:srgbClr val="FFFFFF"/>
                           </a:solidFill>
@@ -16157,7 +16519,7 @@
                         </a:rPr>
                         <a:t>总体</a:t>
                       </a:r>
-                      <a:endParaRPr lang="en-US" sz="860" dirty="0">
+                      <a:endParaRPr lang="en-US" sz="840" dirty="0">
                         <a:latin typeface="Microsoft YaHei" charset="0"/>
                         <a:ea typeface="Microsoft YaHei" charset="0"/>
                         <a:cs typeface="Microsoft YaHei" charset="0"/>
@@ -16215,7 +16577,7 @@
                         <a:buNone/>
                       </a:pPr>
                       <a:r>
-                        <a:rPr lang="en-US" sz="840" b="1" dirty="0">
+                        <a:rPr lang="en-US" sz="820" dirty="0">
                           <a:solidFill>
                             <a:srgbClr val="FFFFFF"/>
                           </a:solidFill>
@@ -16225,7 +16587,7 @@
                         </a:rPr>
                         <a:t>28.6%</a:t>
                       </a:r>
-                      <a:endParaRPr lang="en-US" sz="840" dirty="0">
+                      <a:endParaRPr lang="en-US" sz="820" dirty="0">
                         <a:latin typeface="Microsoft YaHei" charset="0"/>
                         <a:ea typeface="Microsoft YaHei" charset="0"/>
                         <a:cs typeface="Microsoft YaHei" charset="0"/>
@@ -16283,7 +16645,7 @@
                         <a:buNone/>
                       </a:pPr>
                       <a:r>
-                        <a:rPr lang="en-US" sz="840" b="1" dirty="0">
+                        <a:rPr lang="en-US" sz="820" b="1" dirty="0">
                           <a:solidFill>
                             <a:srgbClr val="FFFFFF"/>
                           </a:solidFill>
@@ -16293,7 +16655,7 @@
                         </a:rPr>
                         <a:t>13.7%</a:t>
                       </a:r>
-                      <a:endParaRPr lang="en-US" sz="840" dirty="0">
+                      <a:endParaRPr lang="en-US" sz="820" dirty="0">
                         <a:latin typeface="Microsoft YaHei" charset="0"/>
                         <a:ea typeface="Microsoft YaHei" charset="0"/>
                         <a:cs typeface="Microsoft YaHei" charset="0"/>
@@ -16351,7 +16713,7 @@
                         <a:buNone/>
                       </a:pPr>
                       <a:r>
-                        <a:rPr lang="en-US" sz="840" dirty="0">
+                        <a:rPr lang="en-US" sz="820" b="1" dirty="0">
                           <a:solidFill>
                             <a:srgbClr val="FFFFFF"/>
                           </a:solidFill>
@@ -16359,9 +16721,9 @@
                           <a:ea typeface="Microsoft YaHei" pitchFamily="34" charset="-122"/>
                           <a:cs typeface="Microsoft YaHei" pitchFamily="34" charset="-120"/>
                         </a:rPr>
-                        <a:t>15.7</a:t>
+                        <a:t>48.1%</a:t>
                       </a:r>
-                      <a:endParaRPr lang="en-US" sz="840" dirty="0">
+                      <a:endParaRPr lang="en-US" sz="820" dirty="0">
                         <a:latin typeface="Microsoft YaHei" charset="0"/>
                         <a:ea typeface="Microsoft YaHei" charset="0"/>
                         <a:cs typeface="Microsoft YaHei" charset="0"/>
@@ -16419,17 +16781,17 @@
                         <a:buNone/>
                       </a:pPr>
                       <a:r>
-                        <a:rPr lang="en-US" sz="840" dirty="0">
+                        <a:rPr lang="en-US" sz="820" b="1" dirty="0">
                           <a:solidFill>
-                            <a:srgbClr val="FFFFFF"/>
+                            <a:srgbClr val="0EA5C4"/>
                           </a:solidFill>
                           <a:latin typeface="Microsoft YaHei" pitchFamily="34" charset="0"/>
                           <a:ea typeface="Microsoft YaHei" pitchFamily="34" charset="-122"/>
                           <a:cs typeface="Microsoft YaHei" pitchFamily="34" charset="-120"/>
                         </a:rPr>
-                        <a:t>10.5</a:t>
+                        <a:t>59.0%</a:t>
                       </a:r>
-                      <a:endParaRPr lang="en-US" sz="840" dirty="0">
+                      <a:endParaRPr lang="en-US" sz="820" dirty="0">
                         <a:latin typeface="Microsoft YaHei" charset="0"/>
                         <a:ea typeface="Microsoft YaHei" charset="0"/>
                         <a:cs typeface="Microsoft YaHei" charset="0"/>
@@ -16553,12 +16915,12 @@
           <a:p>
             <a:pPr indent="0" marL="0">
               <a:lnSpc>
-                <a:spcPct val="105000"/>
+                <a:spcPct val="104000"/>
               </a:lnSpc>
               <a:buNone/>
             </a:pPr>
             <a:r>
-              <a:rPr lang="en-US" sz="860" b="1" dirty="0">
+              <a:rPr lang="en-US" sz="840" b="1" dirty="0">
                 <a:solidFill>
                   <a:srgbClr val="0E7490"/>
                 </a:solidFill>
@@ -16570,12 +16932,12 @@
             </a:r>
             <a:pPr indent="0" marL="0">
               <a:lnSpc>
-                <a:spcPct val="105000"/>
+                <a:spcPct val="104000"/>
               </a:lnSpc>
               <a:buNone/>
             </a:pPr>
             <a:r>
-              <a:rPr lang="en-US" sz="860" dirty="0">
+              <a:rPr lang="en-US" sz="840" dirty="0">
                 <a:solidFill>
                   <a:srgbClr val="334155"/>
                 </a:solidFill>
@@ -16583,9 +16945,9 @@
                 <a:ea typeface="Microsoft YaHei" pitchFamily="34" charset="-122"/>
                 <a:cs typeface="Microsoft YaHei" pitchFamily="34" charset="-120"/>
               </a:rPr>
-              <a:t>差距最大在 Q4 归属(66→11)、Q5 ToM(38→3)、Q7 关系(30→9) —— Mem0 有损抽取丢了精确归属/关系，正是 speaker-grounded 方法要补的。</a:t>
+              <a:t>Mem0 每类垫底/并列垫底；Q5 ToM(3→74)、Q9 离群(10→80)、Q7 关系(9→63)、Q4 归属(11→70) 图记忆碾压。唯 Q3 多人聚合四家全崩(≤4.5)——结构化记忆也没解决的硬骨头。</a:t>
             </a:r>
-            <a:endParaRPr lang="en-US" sz="860" dirty="0"/>
+            <a:endParaRPr lang="en-US" sz="840" dirty="0"/>
           </a:p>
         </p:txBody>
       </p:sp>
@@ -16661,7 +17023,1621 @@
                 <a:ea typeface="Microsoft YaHei" pitchFamily="34" charset="-122"/>
                 <a:cs typeface="Microsoft YaHei" pitchFamily="34" charset="-120"/>
               </a:rPr>
-              <a:t>16 / 16</a:t>
+              <a:t>16 / 17</a:t>
+            </a:r>
+            <a:endParaRPr lang="en-US" sz="800" dirty="0"/>
+          </a:p>
+        </p:txBody>
+      </p:sp>
+    </p:spTree>
+  </p:cSld>
+  <p:clrMapOvr>
+    <a:masterClrMapping/>
+  </p:clrMapOvr>
+</p:sld>
+</file>
+
+<file path=ppt/slides/slide17.xml><?xml version="1.0" encoding="utf-8"?>
+<p:sld xmlns:a="http://schemas.openxmlformats.org/drawingml/2006/main" xmlns:r="http://schemas.openxmlformats.org/officeDocument/2006/relationships" xmlns:p="http://schemas.openxmlformats.org/presentationml/2006/main">
+  <p:cSld name="Slide 17">
+    <p:bg>
+      <p:bgPr>
+        <a:solidFill>
+          <a:srgbClr val="FFFFFF"/>
+        </a:solidFill>
+      </p:bgPr>
+    </p:bg>
+    <p:spTree>
+      <p:nvGrpSpPr>
+        <p:cNvPr id="1" name=""/>
+        <p:cNvGrpSpPr/>
+        <p:nvPr/>
+      </p:nvGrpSpPr>
+      <p:grpSpPr>
+        <a:xfrm>
+          <a:off x="0" y="0"/>
+          <a:ext cx="0" cy="0"/>
+          <a:chOff x="0" y="0"/>
+          <a:chExt cx="0" cy="0"/>
+        </a:xfrm>
+      </p:grpSpPr>
+      <p:sp>
+        <p:nvSpPr>
+          <p:cNvPr id="2" name="Shape 0"/>
+          <p:cNvSpPr/>
+          <p:nvPr/>
+        </p:nvSpPr>
+        <p:spPr>
+          <a:xfrm>
+            <a:off x="457200" y="402336"/>
+            <a:ext cx="137160" cy="137160"/>
+          </a:xfrm>
+          <a:prstGeom prst="rect">
+            <a:avLst/>
+          </a:prstGeom>
+          <a:solidFill>
+            <a:srgbClr val="DC4A52"/>
+          </a:solidFill>
+          <a:ln/>
+        </p:spPr>
+      </p:sp>
+      <p:sp>
+        <p:nvSpPr>
+          <p:cNvPr id="3" name="Text 1"/>
+          <p:cNvSpPr/>
+          <p:nvPr/>
+        </p:nvSpPr>
+        <p:spPr>
+          <a:xfrm>
+            <a:off x="685800" y="338328"/>
+            <a:ext cx="8001000" cy="274320"/>
+          </a:xfrm>
+          <a:prstGeom prst="rect">
+            <a:avLst/>
+          </a:prstGeom>
+          <a:noFill/>
+          <a:ln/>
+        </p:spPr>
+        <p:txBody>
+          <a:bodyPr wrap="square" lIns="0" tIns="0" rIns="0" bIns="0" rtlCol="0" anchor="ctr"/>
+          <a:lstStyle/>
+          <a:p>
+            <a:pPr indent="0" marL="0">
+              <a:buNone/>
+            </a:pPr>
+            <a:r>
+              <a:rPr lang="en-US" sz="1100" b="1" spc="100" kern="0" dirty="0">
+                <a:solidFill>
+                  <a:srgbClr val="DC4A52"/>
+                </a:solidFill>
+                <a:latin typeface="Microsoft YaHei" pitchFamily="34" charset="0"/>
+                <a:ea typeface="Microsoft YaHei" pitchFamily="34" charset="-122"/>
+                <a:cs typeface="Microsoft YaHei" pitchFamily="34" charset="-120"/>
+              </a:rPr>
+              <a:t>P4 · Mem0 为何失效（重建两边检索内容归因）</a:t>
+            </a:r>
+            <a:endParaRPr lang="en-US" sz="1100" dirty="0"/>
+          </a:p>
+        </p:txBody>
+      </p:sp>
+      <p:sp>
+        <p:nvSpPr>
+          <p:cNvPr id="4" name="Text 2"/>
+          <p:cNvSpPr/>
+          <p:nvPr/>
+        </p:nvSpPr>
+        <p:spPr>
+          <a:xfrm>
+            <a:off x="457200" y="676656"/>
+            <a:ext cx="8229600" cy="566928"/>
+          </a:xfrm>
+          <a:prstGeom prst="rect">
+            <a:avLst/>
+          </a:prstGeom>
+          <a:noFill/>
+          <a:ln/>
+        </p:spPr>
+        <p:txBody>
+          <a:bodyPr wrap="square" lIns="0" tIns="0" rIns="0" bIns="0" rtlCol="0" anchor="ctr"/>
+          <a:lstStyle/>
+          <a:p>
+            <a:pPr indent="0" marL="0">
+              <a:buNone/>
+            </a:pPr>
+            <a:r>
+              <a:rPr lang="en-US" sz="2300" b="1" dirty="0">
+                <a:solidFill>
+                  <a:srgbClr val="1E293B"/>
+                </a:solidFill>
+                <a:latin typeface="Microsoft YaHei" pitchFamily="34" charset="0"/>
+                <a:ea typeface="Microsoft YaHei" pitchFamily="34" charset="-122"/>
+                <a:cs typeface="Microsoft YaHei" pitchFamily="34" charset="-120"/>
+              </a:rPr>
+              <a:t>对 BM25对/Mem0错 的题，看 Mem0 记忆里到底丢了什么</a:t>
+            </a:r>
+            <a:endParaRPr lang="en-US" sz="2300" dirty="0"/>
+          </a:p>
+        </p:txBody>
+      </p:sp>
+      <p:sp>
+        <p:nvSpPr>
+          <p:cNvPr id="5" name="Shape 3"/>
+          <p:cNvSpPr/>
+          <p:nvPr/>
+        </p:nvSpPr>
+        <p:spPr>
+          <a:xfrm>
+            <a:off x="457200" y="1371600"/>
+            <a:ext cx="2596896" cy="1207008"/>
+          </a:xfrm>
+          <a:prstGeom prst="rect">
+            <a:avLst/>
+          </a:prstGeom>
+          <a:solidFill>
+            <a:srgbClr val="FFFFFF"/>
+          </a:solidFill>
+          <a:ln w="9525">
+            <a:solidFill>
+              <a:srgbClr val="E2E8F0"/>
+            </a:solidFill>
+            <a:prstDash val="solid"/>
+          </a:ln>
+          <a:effectLst>
+            <a:outerShdw sx="100000" sy="100000" kx="0" ky="0" algn="bl" rotWithShape="0" blurRad="101600" dist="38100" dir="8100000">
+              <a:srgbClr val="0F172A">
+                <a:alpha val="12000"/>
+              </a:srgbClr>
+            </a:outerShdw>
+          </a:effectLst>
+        </p:spPr>
+      </p:sp>
+      <p:sp>
+        <p:nvSpPr>
+          <p:cNvPr id="6" name="Shape 4"/>
+          <p:cNvSpPr/>
+          <p:nvPr/>
+        </p:nvSpPr>
+        <p:spPr>
+          <a:xfrm>
+            <a:off x="457200" y="1371600"/>
+            <a:ext cx="54864" cy="1207008"/>
+          </a:xfrm>
+          <a:prstGeom prst="rect">
+            <a:avLst/>
+          </a:prstGeom>
+          <a:solidFill>
+            <a:srgbClr val="0EA5C4"/>
+          </a:solidFill>
+          <a:ln/>
+        </p:spPr>
+      </p:sp>
+      <p:sp>
+        <p:nvSpPr>
+          <p:cNvPr id="7" name="Text 5"/>
+          <p:cNvSpPr/>
+          <p:nvPr/>
+        </p:nvSpPr>
+        <p:spPr>
+          <a:xfrm>
+            <a:off x="603504" y="1463040"/>
+            <a:ext cx="2322576" cy="457200"/>
+          </a:xfrm>
+          <a:prstGeom prst="rect">
+            <a:avLst/>
+          </a:prstGeom>
+          <a:noFill/>
+          <a:ln/>
+        </p:spPr>
+        <p:txBody>
+          <a:bodyPr wrap="square" lIns="0" tIns="0" rIns="0" bIns="0" rtlCol="0" anchor="t"/>
+          <a:lstStyle/>
+          <a:p>
+            <a:pPr indent="0" marL="0">
+              <a:lnSpc>
+                <a:spcPct val="98000"/>
+              </a:lnSpc>
+              <a:buNone/>
+            </a:pPr>
+            <a:r>
+              <a:rPr lang="en-US" sz="1000" b="1" dirty="0">
+                <a:solidFill>
+                  <a:srgbClr val="0EA5C4"/>
+                </a:solidFill>
+                <a:latin typeface="Microsoft YaHei" pitchFamily="34" charset="0"/>
+                <a:ea typeface="Microsoft YaHei" pitchFamily="34" charset="-122"/>
+                <a:cs typeface="Microsoft YaHei" pitchFamily="34" charset="-120"/>
+              </a:rPr>
+              <a:t>① 字面值被摘要抹平</a:t>
+            </a:r>
+            <a:endParaRPr lang="en-US" sz="1000" dirty="0"/>
+          </a:p>
+        </p:txBody>
+      </p:sp>
+      <p:sp>
+        <p:nvSpPr>
+          <p:cNvPr id="8" name="Text 6"/>
+          <p:cNvSpPr/>
+          <p:nvPr/>
+        </p:nvSpPr>
+        <p:spPr>
+          <a:xfrm>
+            <a:off x="603504" y="1883664"/>
+            <a:ext cx="2322576" cy="457200"/>
+          </a:xfrm>
+          <a:prstGeom prst="rect">
+            <a:avLst/>
+          </a:prstGeom>
+          <a:noFill/>
+          <a:ln/>
+        </p:spPr>
+        <p:txBody>
+          <a:bodyPr wrap="square" lIns="0" tIns="0" rIns="0" bIns="0" rtlCol="0" anchor="t"/>
+          <a:lstStyle/>
+          <a:p>
+            <a:pPr indent="0" marL="0">
+              <a:lnSpc>
+                <a:spcPct val="104000"/>
+              </a:lnSpc>
+              <a:buNone/>
+            </a:pPr>
+            <a:r>
+              <a:rPr lang="en-US" sz="800" dirty="0">
+                <a:solidFill>
+                  <a:srgbClr val="334155"/>
+                </a:solidFill>
+                <a:latin typeface="Microsoft YaHei" pitchFamily="34" charset="0"/>
+                <a:ea typeface="Microsoft YaHei" pitchFamily="34" charset="-122"/>
+                <a:cs typeface="Microsoft YaHei" pitchFamily="34" charset="-120"/>
+              </a:rPr>
+              <a:t>截止日 2025-07-18 → Mem0 记忆全是「谁负责审批」，无此日期</a:t>
+            </a:r>
+            <a:endParaRPr lang="en-US" sz="800" dirty="0"/>
+          </a:p>
+        </p:txBody>
+      </p:sp>
+      <p:sp>
+        <p:nvSpPr>
+          <p:cNvPr id="9" name="Shape 7"/>
+          <p:cNvSpPr/>
+          <p:nvPr/>
+        </p:nvSpPr>
+        <p:spPr>
+          <a:xfrm>
+            <a:off x="603504" y="2286000"/>
+            <a:ext cx="2304288" cy="201168"/>
+          </a:xfrm>
+          <a:prstGeom prst="rect">
+            <a:avLst/>
+          </a:prstGeom>
+          <a:solidFill>
+            <a:srgbClr val="F1F5F9"/>
+          </a:solidFill>
+          <a:ln/>
+        </p:spPr>
+      </p:sp>
+      <p:sp>
+        <p:nvSpPr>
+          <p:cNvPr id="10" name="Text 8"/>
+          <p:cNvSpPr/>
+          <p:nvPr/>
+        </p:nvSpPr>
+        <p:spPr>
+          <a:xfrm>
+            <a:off x="676656" y="2276856"/>
+            <a:ext cx="2231136" cy="201168"/>
+          </a:xfrm>
+          <a:prstGeom prst="rect">
+            <a:avLst/>
+          </a:prstGeom>
+          <a:noFill/>
+          <a:ln/>
+        </p:spPr>
+        <p:txBody>
+          <a:bodyPr wrap="square" lIns="0" tIns="0" rIns="0" bIns="0" rtlCol="0" anchor="ctr"/>
+          <a:lstStyle/>
+          <a:p>
+            <a:pPr indent="0" marL="0">
+              <a:buNone/>
+            </a:pPr>
+            <a:r>
+              <a:rPr lang="en-US" sz="720" dirty="0">
+                <a:solidFill>
+                  <a:srgbClr val="64748B"/>
+                </a:solidFill>
+                <a:latin typeface="Microsoft YaHei" pitchFamily="34" charset="0"/>
+                <a:ea typeface="Microsoft YaHei" pitchFamily="34" charset="-122"/>
+                <a:cs typeface="Microsoft YaHei" pitchFamily="34" charset="-120"/>
+              </a:rPr>
+              <a:t>缺口 </a:t>
+            </a:r>
+            <a:pPr indent="0" marL="0">
+              <a:buNone/>
+            </a:pPr>
+            <a:r>
+              <a:rPr lang="en-US" sz="720" b="1" dirty="0">
+                <a:solidFill>
+                  <a:srgbClr val="0EA5C4"/>
+                </a:solidFill>
+                <a:latin typeface="Microsoft YaHei" pitchFamily="34" charset="0"/>
+                <a:ea typeface="Microsoft YaHei" pitchFamily="34" charset="-122"/>
+                <a:cs typeface="Microsoft YaHei" pitchFamily="34" charset="-120"/>
+              </a:rPr>
+              <a:t>时序 +38.9 pt</a:t>
+            </a:r>
+            <a:endParaRPr lang="en-US" sz="720" dirty="0"/>
+          </a:p>
+        </p:txBody>
+      </p:sp>
+      <p:sp>
+        <p:nvSpPr>
+          <p:cNvPr id="11" name="Shape 9"/>
+          <p:cNvSpPr/>
+          <p:nvPr/>
+        </p:nvSpPr>
+        <p:spPr>
+          <a:xfrm>
+            <a:off x="3273552" y="1371600"/>
+            <a:ext cx="2596896" cy="1207008"/>
+          </a:xfrm>
+          <a:prstGeom prst="rect">
+            <a:avLst/>
+          </a:prstGeom>
+          <a:solidFill>
+            <a:srgbClr val="FFFFFF"/>
+          </a:solidFill>
+          <a:ln w="9525">
+            <a:solidFill>
+              <a:srgbClr val="E2E8F0"/>
+            </a:solidFill>
+            <a:prstDash val="solid"/>
+          </a:ln>
+          <a:effectLst>
+            <a:outerShdw sx="100000" sy="100000" kx="0" ky="0" algn="bl" rotWithShape="0" blurRad="101600" dist="38100" dir="8100000">
+              <a:srgbClr val="0F172A">
+                <a:alpha val="12000"/>
+              </a:srgbClr>
+            </a:outerShdw>
+          </a:effectLst>
+        </p:spPr>
+      </p:sp>
+      <p:sp>
+        <p:nvSpPr>
+          <p:cNvPr id="12" name="Shape 10"/>
+          <p:cNvSpPr/>
+          <p:nvPr/>
+        </p:nvSpPr>
+        <p:spPr>
+          <a:xfrm>
+            <a:off x="3273552" y="1371600"/>
+            <a:ext cx="54864" cy="1207008"/>
+          </a:xfrm>
+          <a:prstGeom prst="rect">
+            <a:avLst/>
+          </a:prstGeom>
+          <a:solidFill>
+            <a:srgbClr val="6D5BD0"/>
+          </a:solidFill>
+          <a:ln/>
+        </p:spPr>
+      </p:sp>
+      <p:sp>
+        <p:nvSpPr>
+          <p:cNvPr id="13" name="Text 11"/>
+          <p:cNvSpPr/>
+          <p:nvPr/>
+        </p:nvSpPr>
+        <p:spPr>
+          <a:xfrm>
+            <a:off x="3419856" y="1463040"/>
+            <a:ext cx="2322576" cy="457200"/>
+          </a:xfrm>
+          <a:prstGeom prst="rect">
+            <a:avLst/>
+          </a:prstGeom>
+          <a:noFill/>
+          <a:ln/>
+        </p:spPr>
+        <p:txBody>
+          <a:bodyPr wrap="square" lIns="0" tIns="0" rIns="0" bIns="0" rtlCol="0" anchor="t"/>
+          <a:lstStyle/>
+          <a:p>
+            <a:pPr indent="0" marL="0">
+              <a:lnSpc>
+                <a:spcPct val="98000"/>
+              </a:lnSpc>
+              <a:buNone/>
+            </a:pPr>
+            <a:r>
+              <a:rPr lang="en-US" sz="1000" b="1" dirty="0">
+                <a:solidFill>
+                  <a:srgbClr val="6D5BD0"/>
+                </a:solidFill>
+                <a:latin typeface="Microsoft YaHei" pitchFamily="34" charset="0"/>
+                <a:ea typeface="Microsoft YaHei" pitchFamily="34" charset="-122"/>
+                <a:cs typeface="Microsoft YaHei" pitchFamily="34" charset="-120"/>
+              </a:rPr>
+              <a:t>② 属性-实体绑定断裂</a:t>
+            </a:r>
+            <a:endParaRPr lang="en-US" sz="1000" dirty="0"/>
+          </a:p>
+        </p:txBody>
+      </p:sp>
+      <p:sp>
+        <p:nvSpPr>
+          <p:cNvPr id="14" name="Text 12"/>
+          <p:cNvSpPr/>
+          <p:nvPr/>
+        </p:nvSpPr>
+        <p:spPr>
+          <a:xfrm>
+            <a:off x="3419856" y="1883664"/>
+            <a:ext cx="2322576" cy="457200"/>
+          </a:xfrm>
+          <a:prstGeom prst="rect">
+            <a:avLst/>
+          </a:prstGeom>
+          <a:noFill/>
+          <a:ln/>
+        </p:spPr>
+        <p:txBody>
+          <a:bodyPr wrap="square" lIns="0" tIns="0" rIns="0" bIns="0" rtlCol="0" anchor="t"/>
+          <a:lstStyle/>
+          <a:p>
+            <a:pPr indent="0" marL="0">
+              <a:lnSpc>
+                <a:spcPct val="104000"/>
+              </a:lnSpc>
+              <a:buNone/>
+            </a:pPr>
+            <a:r>
+              <a:rPr lang="en-US" sz="800" dirty="0">
+                <a:solidFill>
+                  <a:srgbClr val="334155"/>
+                </a:solidFill>
+                <a:latin typeface="Microsoft YaHei" pitchFamily="34" charset="0"/>
+                <a:ea typeface="Microsoft YaHei" pitchFamily="34" charset="-122"/>
+                <a:cs typeface="Microsoft YaHei" pitchFamily="34" charset="-120"/>
+              </a:rPr>
+              <a:t>一堆日期没一条绑到「UX Approval 阶段」→ 张冠李戴</a:t>
+            </a:r>
+            <a:endParaRPr lang="en-US" sz="800" dirty="0"/>
+          </a:p>
+        </p:txBody>
+      </p:sp>
+      <p:sp>
+        <p:nvSpPr>
+          <p:cNvPr id="15" name="Shape 13"/>
+          <p:cNvSpPr/>
+          <p:nvPr/>
+        </p:nvSpPr>
+        <p:spPr>
+          <a:xfrm>
+            <a:off x="3419856" y="2286000"/>
+            <a:ext cx="2304288" cy="201168"/>
+          </a:xfrm>
+          <a:prstGeom prst="rect">
+            <a:avLst/>
+          </a:prstGeom>
+          <a:solidFill>
+            <a:srgbClr val="F1F5F9"/>
+          </a:solidFill>
+          <a:ln/>
+        </p:spPr>
+      </p:sp>
+      <p:sp>
+        <p:nvSpPr>
+          <p:cNvPr id="16" name="Text 14"/>
+          <p:cNvSpPr/>
+          <p:nvPr/>
+        </p:nvSpPr>
+        <p:spPr>
+          <a:xfrm>
+            <a:off x="3493008" y="2276856"/>
+            <a:ext cx="2231136" cy="201168"/>
+          </a:xfrm>
+          <a:prstGeom prst="rect">
+            <a:avLst/>
+          </a:prstGeom>
+          <a:noFill/>
+          <a:ln/>
+        </p:spPr>
+        <p:txBody>
+          <a:bodyPr wrap="square" lIns="0" tIns="0" rIns="0" bIns="0" rtlCol="0" anchor="ctr"/>
+          <a:lstStyle/>
+          <a:p>
+            <a:pPr indent="0" marL="0">
+              <a:buNone/>
+            </a:pPr>
+            <a:r>
+              <a:rPr lang="en-US" sz="720" dirty="0">
+                <a:solidFill>
+                  <a:srgbClr val="64748B"/>
+                </a:solidFill>
+                <a:latin typeface="Microsoft YaHei" pitchFamily="34" charset="0"/>
+                <a:ea typeface="Microsoft YaHei" pitchFamily="34" charset="-122"/>
+                <a:cs typeface="Microsoft YaHei" pitchFamily="34" charset="-120"/>
+              </a:rPr>
+              <a:t>缺口 </a:t>
+            </a:r>
+            <a:pPr indent="0" marL="0">
+              <a:buNone/>
+            </a:pPr>
+            <a:r>
+              <a:rPr lang="en-US" sz="720" b="1" dirty="0">
+                <a:solidFill>
+                  <a:srgbClr val="6D5BD0"/>
+                </a:solidFill>
+                <a:latin typeface="Microsoft YaHei" pitchFamily="34" charset="0"/>
+                <a:ea typeface="Microsoft YaHei" pitchFamily="34" charset="-122"/>
+                <a:cs typeface="Microsoft YaHei" pitchFamily="34" charset="-120"/>
+              </a:rPr>
+              <a:t>多跳 +34.6 pt</a:t>
+            </a:r>
+            <a:endParaRPr lang="en-US" sz="720" dirty="0"/>
+          </a:p>
+        </p:txBody>
+      </p:sp>
+      <p:sp>
+        <p:nvSpPr>
+          <p:cNvPr id="17" name="Shape 15"/>
+          <p:cNvSpPr/>
+          <p:nvPr/>
+        </p:nvSpPr>
+        <p:spPr>
+          <a:xfrm>
+            <a:off x="6089904" y="1371600"/>
+            <a:ext cx="2596896" cy="1207008"/>
+          </a:xfrm>
+          <a:prstGeom prst="rect">
+            <a:avLst/>
+          </a:prstGeom>
+          <a:solidFill>
+            <a:srgbClr val="FFFFFF"/>
+          </a:solidFill>
+          <a:ln w="9525">
+            <a:solidFill>
+              <a:srgbClr val="E2E8F0"/>
+            </a:solidFill>
+            <a:prstDash val="solid"/>
+          </a:ln>
+          <a:effectLst>
+            <a:outerShdw sx="100000" sy="100000" kx="0" ky="0" algn="bl" rotWithShape="0" blurRad="101600" dist="38100" dir="8100000">
+              <a:srgbClr val="0F172A">
+                <a:alpha val="12000"/>
+              </a:srgbClr>
+            </a:outerShdw>
+          </a:effectLst>
+        </p:spPr>
+      </p:sp>
+      <p:sp>
+        <p:nvSpPr>
+          <p:cNvPr id="18" name="Shape 16"/>
+          <p:cNvSpPr/>
+          <p:nvPr/>
+        </p:nvSpPr>
+        <p:spPr>
+          <a:xfrm>
+            <a:off x="6089904" y="1371600"/>
+            <a:ext cx="54864" cy="1207008"/>
+          </a:xfrm>
+          <a:prstGeom prst="rect">
+            <a:avLst/>
+          </a:prstGeom>
+          <a:solidFill>
+            <a:srgbClr val="E08A1E"/>
+          </a:solidFill>
+          <a:ln/>
+        </p:spPr>
+      </p:sp>
+      <p:sp>
+        <p:nvSpPr>
+          <p:cNvPr id="19" name="Text 17"/>
+          <p:cNvSpPr/>
+          <p:nvPr/>
+        </p:nvSpPr>
+        <p:spPr>
+          <a:xfrm>
+            <a:off x="6236208" y="1463040"/>
+            <a:ext cx="2322576" cy="457200"/>
+          </a:xfrm>
+          <a:prstGeom prst="rect">
+            <a:avLst/>
+          </a:prstGeom>
+          <a:noFill/>
+          <a:ln/>
+        </p:spPr>
+        <p:txBody>
+          <a:bodyPr wrap="square" lIns="0" tIns="0" rIns="0" bIns="0" rtlCol="0" anchor="t"/>
+          <a:lstStyle/>
+          <a:p>
+            <a:pPr indent="0" marL="0">
+              <a:lnSpc>
+                <a:spcPct val="98000"/>
+              </a:lnSpc>
+              <a:buNone/>
+            </a:pPr>
+            <a:r>
+              <a:rPr lang="en-US" sz="1000" b="1" dirty="0">
+                <a:solidFill>
+                  <a:srgbClr val="E08A1E"/>
+                </a:solidFill>
+                <a:latin typeface="Microsoft YaHei" pitchFamily="34" charset="0"/>
+                <a:ea typeface="Microsoft YaHei" pitchFamily="34" charset="-122"/>
+                <a:cs typeface="Microsoft YaHei" pitchFamily="34" charset="-120"/>
+              </a:rPr>
+              <a:t>③ 说话人/归属丢失</a:t>
+            </a:r>
+            <a:endParaRPr lang="en-US" sz="1000" dirty="0"/>
+          </a:p>
+        </p:txBody>
+      </p:sp>
+      <p:sp>
+        <p:nvSpPr>
+          <p:cNvPr id="20" name="Text 18"/>
+          <p:cNvSpPr/>
+          <p:nvPr/>
+        </p:nvSpPr>
+        <p:spPr>
+          <a:xfrm>
+            <a:off x="6236208" y="1883664"/>
+            <a:ext cx="2322576" cy="457200"/>
+          </a:xfrm>
+          <a:prstGeom prst="rect">
+            <a:avLst/>
+          </a:prstGeom>
+          <a:noFill/>
+          <a:ln/>
+        </p:spPr>
+        <p:txBody>
+          <a:bodyPr wrap="square" lIns="0" tIns="0" rIns="0" bIns="0" rtlCol="0" anchor="t"/>
+          <a:lstStyle/>
+          <a:p>
+            <a:pPr indent="0" marL="0">
+              <a:lnSpc>
+                <a:spcPct val="104000"/>
+              </a:lnSpc>
+              <a:buNone/>
+            </a:pPr>
+            <a:r>
+              <a:rPr lang="en-US" sz="800" dirty="0">
+                <a:solidFill>
+                  <a:srgbClr val="334155"/>
+                </a:solidFill>
+                <a:latin typeface="Microsoft YaHei" pitchFamily="34" charset="0"/>
+                <a:ea typeface="Microsoft YaHei" pitchFamily="34" charset="-122"/>
+                <a:cs typeface="Microsoft YaHei" pitchFamily="34" charset="-120"/>
+              </a:rPr>
+              <a:t>「谁反对圣诞日期」=Emeka；Mem0 只剩「谁要什么菜」</a:t>
+            </a:r>
+            <a:endParaRPr lang="en-US" sz="800" dirty="0"/>
+          </a:p>
+        </p:txBody>
+      </p:sp>
+      <p:sp>
+        <p:nvSpPr>
+          <p:cNvPr id="21" name="Shape 19"/>
+          <p:cNvSpPr/>
+          <p:nvPr/>
+        </p:nvSpPr>
+        <p:spPr>
+          <a:xfrm>
+            <a:off x="6236208" y="2286000"/>
+            <a:ext cx="2304288" cy="201168"/>
+          </a:xfrm>
+          <a:prstGeom prst="rect">
+            <a:avLst/>
+          </a:prstGeom>
+          <a:solidFill>
+            <a:srgbClr val="F1F5F9"/>
+          </a:solidFill>
+          <a:ln/>
+        </p:spPr>
+      </p:sp>
+      <p:sp>
+        <p:nvSpPr>
+          <p:cNvPr id="22" name="Text 20"/>
+          <p:cNvSpPr/>
+          <p:nvPr/>
+        </p:nvSpPr>
+        <p:spPr>
+          <a:xfrm>
+            <a:off x="6309360" y="2276856"/>
+            <a:ext cx="2231136" cy="201168"/>
+          </a:xfrm>
+          <a:prstGeom prst="rect">
+            <a:avLst/>
+          </a:prstGeom>
+          <a:noFill/>
+          <a:ln/>
+        </p:spPr>
+        <p:txBody>
+          <a:bodyPr wrap="square" lIns="0" tIns="0" rIns="0" bIns="0" rtlCol="0" anchor="ctr"/>
+          <a:lstStyle/>
+          <a:p>
+            <a:pPr indent="0" marL="0">
+              <a:buNone/>
+            </a:pPr>
+            <a:r>
+              <a:rPr lang="en-US" sz="720" dirty="0">
+                <a:solidFill>
+                  <a:srgbClr val="64748B"/>
+                </a:solidFill>
+                <a:latin typeface="Microsoft YaHei" pitchFamily="34" charset="0"/>
+                <a:ea typeface="Microsoft YaHei" pitchFamily="34" charset="-122"/>
+                <a:cs typeface="Microsoft YaHei" pitchFamily="34" charset="-120"/>
+              </a:rPr>
+              <a:t>缺口 </a:t>
+            </a:r>
+            <a:pPr indent="0" marL="0">
+              <a:buNone/>
+            </a:pPr>
+            <a:r>
+              <a:rPr lang="en-US" sz="720" b="1" dirty="0">
+                <a:solidFill>
+                  <a:srgbClr val="E08A1E"/>
+                </a:solidFill>
+                <a:latin typeface="Microsoft YaHei" pitchFamily="34" charset="0"/>
+                <a:ea typeface="Microsoft YaHei" pitchFamily="34" charset="-122"/>
+                <a:cs typeface="Microsoft YaHei" pitchFamily="34" charset="-120"/>
+              </a:rPr>
+              <a:t>Q4 归属 +55.0 pt</a:t>
+            </a:r>
+            <a:endParaRPr lang="en-US" sz="720" dirty="0"/>
+          </a:p>
+        </p:txBody>
+      </p:sp>
+      <p:sp>
+        <p:nvSpPr>
+          <p:cNvPr id="23" name="Shape 21"/>
+          <p:cNvSpPr/>
+          <p:nvPr/>
+        </p:nvSpPr>
+        <p:spPr>
+          <a:xfrm>
+            <a:off x="457200" y="2724912"/>
+            <a:ext cx="2596896" cy="1207008"/>
+          </a:xfrm>
+          <a:prstGeom prst="rect">
+            <a:avLst/>
+          </a:prstGeom>
+          <a:solidFill>
+            <a:srgbClr val="FFFFFF"/>
+          </a:solidFill>
+          <a:ln w="9525">
+            <a:solidFill>
+              <a:srgbClr val="E2E8F0"/>
+            </a:solidFill>
+            <a:prstDash val="solid"/>
+          </a:ln>
+          <a:effectLst>
+            <a:outerShdw sx="100000" sy="100000" kx="0" ky="0" algn="bl" rotWithShape="0" blurRad="101600" dist="38100" dir="8100000">
+              <a:srgbClr val="0F172A">
+                <a:alpha val="12000"/>
+              </a:srgbClr>
+            </a:outerShdw>
+          </a:effectLst>
+        </p:spPr>
+      </p:sp>
+      <p:sp>
+        <p:nvSpPr>
+          <p:cNvPr id="24" name="Shape 22"/>
+          <p:cNvSpPr/>
+          <p:nvPr/>
+        </p:nvSpPr>
+        <p:spPr>
+          <a:xfrm>
+            <a:off x="457200" y="2724912"/>
+            <a:ext cx="54864" cy="1207008"/>
+          </a:xfrm>
+          <a:prstGeom prst="rect">
+            <a:avLst/>
+          </a:prstGeom>
+          <a:solidFill>
+            <a:srgbClr val="0E9F6E"/>
+          </a:solidFill>
+          <a:ln/>
+        </p:spPr>
+      </p:sp>
+      <p:sp>
+        <p:nvSpPr>
+          <p:cNvPr id="25" name="Text 23"/>
+          <p:cNvSpPr/>
+          <p:nvPr/>
+        </p:nvSpPr>
+        <p:spPr>
+          <a:xfrm>
+            <a:off x="603504" y="2816352"/>
+            <a:ext cx="2322576" cy="457200"/>
+          </a:xfrm>
+          <a:prstGeom prst="rect">
+            <a:avLst/>
+          </a:prstGeom>
+          <a:noFill/>
+          <a:ln/>
+        </p:spPr>
+        <p:txBody>
+          <a:bodyPr wrap="square" lIns="0" tIns="0" rIns="0" bIns="0" rtlCol="0" anchor="t"/>
+          <a:lstStyle/>
+          <a:p>
+            <a:pPr indent="0" marL="0">
+              <a:lnSpc>
+                <a:spcPct val="98000"/>
+              </a:lnSpc>
+              <a:buNone/>
+            </a:pPr>
+            <a:r>
+              <a:rPr lang="en-US" sz="1000" b="1" dirty="0">
+                <a:solidFill>
+                  <a:srgbClr val="0E9F6E"/>
+                </a:solidFill>
+                <a:latin typeface="Microsoft YaHei" pitchFamily="34" charset="0"/>
+                <a:ea typeface="Microsoft YaHei" pitchFamily="34" charset="-122"/>
+                <a:cs typeface="Microsoft YaHei" pitchFamily="34" charset="-120"/>
+              </a:rPr>
+              <a:t>④ 言语行为被丢</a:t>
+            </a:r>
+            <a:endParaRPr lang="en-US" sz="1000" dirty="0"/>
+          </a:p>
+        </p:txBody>
+      </p:sp>
+      <p:sp>
+        <p:nvSpPr>
+          <p:cNvPr id="26" name="Text 24"/>
+          <p:cNvSpPr/>
+          <p:nvPr/>
+        </p:nvSpPr>
+        <p:spPr>
+          <a:xfrm>
+            <a:off x="603504" y="3236976"/>
+            <a:ext cx="2322576" cy="457200"/>
+          </a:xfrm>
+          <a:prstGeom prst="rect">
+            <a:avLst/>
+          </a:prstGeom>
+          <a:noFill/>
+          <a:ln/>
+        </p:spPr>
+        <p:txBody>
+          <a:bodyPr wrap="square" lIns="0" tIns="0" rIns="0" bIns="0" rtlCol="0" anchor="t"/>
+          <a:lstStyle/>
+          <a:p>
+            <a:pPr indent="0" marL="0">
+              <a:lnSpc>
+                <a:spcPct val="104000"/>
+              </a:lnSpc>
+              <a:buNone/>
+            </a:pPr>
+            <a:r>
+              <a:rPr lang="en-US" sz="800" dirty="0">
+                <a:solidFill>
+                  <a:srgbClr val="334155"/>
+                </a:solidFill>
+                <a:latin typeface="Microsoft YaHei" pitchFamily="34" charset="0"/>
+                <a:ea typeface="Microsoft YaHei" pitchFamily="34" charset="-122"/>
+                <a:cs typeface="Microsoft YaHei" pitchFamily="34" charset="-120"/>
+              </a:rPr>
+              <a:t>「Bev 替 Cass 问素食」动作没了，只留高频观鸟话题</a:t>
+            </a:r>
+            <a:endParaRPr lang="en-US" sz="800" dirty="0"/>
+          </a:p>
+        </p:txBody>
+      </p:sp>
+      <p:sp>
+        <p:nvSpPr>
+          <p:cNvPr id="27" name="Shape 25"/>
+          <p:cNvSpPr/>
+          <p:nvPr/>
+        </p:nvSpPr>
+        <p:spPr>
+          <a:xfrm>
+            <a:off x="603504" y="3639312"/>
+            <a:ext cx="2304288" cy="201168"/>
+          </a:xfrm>
+          <a:prstGeom prst="rect">
+            <a:avLst/>
+          </a:prstGeom>
+          <a:solidFill>
+            <a:srgbClr val="F1F5F9"/>
+          </a:solidFill>
+          <a:ln/>
+        </p:spPr>
+      </p:sp>
+      <p:sp>
+        <p:nvSpPr>
+          <p:cNvPr id="28" name="Text 26"/>
+          <p:cNvSpPr/>
+          <p:nvPr/>
+        </p:nvSpPr>
+        <p:spPr>
+          <a:xfrm>
+            <a:off x="676656" y="3630168"/>
+            <a:ext cx="2231136" cy="201168"/>
+          </a:xfrm>
+          <a:prstGeom prst="rect">
+            <a:avLst/>
+          </a:prstGeom>
+          <a:noFill/>
+          <a:ln/>
+        </p:spPr>
+        <p:txBody>
+          <a:bodyPr wrap="square" lIns="0" tIns="0" rIns="0" bIns="0" rtlCol="0" anchor="ctr"/>
+          <a:lstStyle/>
+          <a:p>
+            <a:pPr indent="0" marL="0">
+              <a:buNone/>
+            </a:pPr>
+            <a:r>
+              <a:rPr lang="en-US" sz="720" dirty="0">
+                <a:solidFill>
+                  <a:srgbClr val="64748B"/>
+                </a:solidFill>
+                <a:latin typeface="Microsoft YaHei" pitchFamily="34" charset="0"/>
+                <a:ea typeface="Microsoft YaHei" pitchFamily="34" charset="-122"/>
+                <a:cs typeface="Microsoft YaHei" pitchFamily="34" charset="-120"/>
+              </a:rPr>
+              <a:t>缺口 </a:t>
+            </a:r>
+            <a:pPr indent="0" marL="0">
+              <a:buNone/>
+            </a:pPr>
+            <a:r>
+              <a:rPr lang="en-US" sz="720" b="1" dirty="0">
+                <a:solidFill>
+                  <a:srgbClr val="0E9F6E"/>
+                </a:solidFill>
+                <a:latin typeface="Microsoft YaHei" pitchFamily="34" charset="0"/>
+                <a:ea typeface="Microsoft YaHei" pitchFamily="34" charset="-122"/>
+                <a:cs typeface="Microsoft YaHei" pitchFamily="34" charset="-120"/>
+              </a:rPr>
+              <a:t>Q5 ToM +34.8 pt</a:t>
+            </a:r>
+            <a:endParaRPr lang="en-US" sz="720" dirty="0"/>
+          </a:p>
+        </p:txBody>
+      </p:sp>
+      <p:sp>
+        <p:nvSpPr>
+          <p:cNvPr id="29" name="Shape 27"/>
+          <p:cNvSpPr/>
+          <p:nvPr/>
+        </p:nvSpPr>
+        <p:spPr>
+          <a:xfrm>
+            <a:off x="3273552" y="2724912"/>
+            <a:ext cx="2596896" cy="1207008"/>
+          </a:xfrm>
+          <a:prstGeom prst="rect">
+            <a:avLst/>
+          </a:prstGeom>
+          <a:solidFill>
+            <a:srgbClr val="FFFFFF"/>
+          </a:solidFill>
+          <a:ln w="9525">
+            <a:solidFill>
+              <a:srgbClr val="E2E8F0"/>
+            </a:solidFill>
+            <a:prstDash val="solid"/>
+          </a:ln>
+          <a:effectLst>
+            <a:outerShdw sx="100000" sy="100000" kx="0" ky="0" algn="bl" rotWithShape="0" blurRad="101600" dist="38100" dir="8100000">
+              <a:srgbClr val="0F172A">
+                <a:alpha val="12000"/>
+              </a:srgbClr>
+            </a:outerShdw>
+          </a:effectLst>
+        </p:spPr>
+      </p:sp>
+      <p:sp>
+        <p:nvSpPr>
+          <p:cNvPr id="30" name="Shape 28"/>
+          <p:cNvSpPr/>
+          <p:nvPr/>
+        </p:nvSpPr>
+        <p:spPr>
+          <a:xfrm>
+            <a:off x="3273552" y="2724912"/>
+            <a:ext cx="54864" cy="1207008"/>
+          </a:xfrm>
+          <a:prstGeom prst="rect">
+            <a:avLst/>
+          </a:prstGeom>
+          <a:solidFill>
+            <a:srgbClr val="0E7490"/>
+          </a:solidFill>
+          <a:ln/>
+        </p:spPr>
+      </p:sp>
+      <p:sp>
+        <p:nvSpPr>
+          <p:cNvPr id="31" name="Text 29"/>
+          <p:cNvSpPr/>
+          <p:nvPr/>
+        </p:nvSpPr>
+        <p:spPr>
+          <a:xfrm>
+            <a:off x="3419856" y="2816352"/>
+            <a:ext cx="2322576" cy="457200"/>
+          </a:xfrm>
+          <a:prstGeom prst="rect">
+            <a:avLst/>
+          </a:prstGeom>
+          <a:noFill/>
+          <a:ln/>
+        </p:spPr>
+        <p:txBody>
+          <a:bodyPr wrap="square" lIns="0" tIns="0" rIns="0" bIns="0" rtlCol="0" anchor="t"/>
+          <a:lstStyle/>
+          <a:p>
+            <a:pPr indent="0" marL="0">
+              <a:lnSpc>
+                <a:spcPct val="98000"/>
+              </a:lnSpc>
+              <a:buNone/>
+            </a:pPr>
+            <a:r>
+              <a:rPr lang="en-US" sz="1000" b="1" dirty="0">
+                <a:solidFill>
+                  <a:srgbClr val="0E7490"/>
+                </a:solidFill>
+                <a:latin typeface="Microsoft YaHei" pitchFamily="34" charset="0"/>
+                <a:ea typeface="Microsoft YaHei" pitchFamily="34" charset="-122"/>
+                <a:cs typeface="Microsoft YaHei" pitchFamily="34" charset="-120"/>
+              </a:rPr>
+              <a:t>⑤ 关系边缺失+显著性偏置</a:t>
+            </a:r>
+            <a:endParaRPr lang="en-US" sz="1000" dirty="0"/>
+          </a:p>
+        </p:txBody>
+      </p:sp>
+      <p:sp>
+        <p:nvSpPr>
+          <p:cNvPr id="32" name="Text 30"/>
+          <p:cNvSpPr/>
+          <p:nvPr/>
+        </p:nvSpPr>
+        <p:spPr>
+          <a:xfrm>
+            <a:off x="3419856" y="3236976"/>
+            <a:ext cx="2322576" cy="457200"/>
+          </a:xfrm>
+          <a:prstGeom prst="rect">
+            <a:avLst/>
+          </a:prstGeom>
+          <a:noFill/>
+          <a:ln/>
+        </p:spPr>
+        <p:txBody>
+          <a:bodyPr wrap="square" lIns="0" tIns="0" rIns="0" bIns="0" rtlCol="0" anchor="t"/>
+          <a:lstStyle/>
+          <a:p>
+            <a:pPr indent="0" marL="0">
+              <a:lnSpc>
+                <a:spcPct val="104000"/>
+              </a:lnSpc>
+              <a:buNone/>
+            </a:pPr>
+            <a:r>
+              <a:rPr lang="en-US" sz="800" dirty="0">
+                <a:solidFill>
+                  <a:srgbClr val="334155"/>
+                </a:solidFill>
+                <a:latin typeface="Microsoft YaHei" pitchFamily="34" charset="0"/>
+                <a:ea typeface="Microsoft YaHei" pitchFamily="34" charset="-122"/>
+                <a:cs typeface="Microsoft YaHei" pitchFamily="34" charset="-120"/>
+              </a:rPr>
+              <a:t>Priya–Lena 亲密关系→Mem0 答「无特定关系」</a:t>
+            </a:r>
+            <a:endParaRPr lang="en-US" sz="800" dirty="0"/>
+          </a:p>
+        </p:txBody>
+      </p:sp>
+      <p:sp>
+        <p:nvSpPr>
+          <p:cNvPr id="33" name="Shape 31"/>
+          <p:cNvSpPr/>
+          <p:nvPr/>
+        </p:nvSpPr>
+        <p:spPr>
+          <a:xfrm>
+            <a:off x="3419856" y="3639312"/>
+            <a:ext cx="2304288" cy="201168"/>
+          </a:xfrm>
+          <a:prstGeom prst="rect">
+            <a:avLst/>
+          </a:prstGeom>
+          <a:solidFill>
+            <a:srgbClr val="F1F5F9"/>
+          </a:solidFill>
+          <a:ln/>
+        </p:spPr>
+      </p:sp>
+      <p:sp>
+        <p:nvSpPr>
+          <p:cNvPr id="34" name="Text 32"/>
+          <p:cNvSpPr/>
+          <p:nvPr/>
+        </p:nvSpPr>
+        <p:spPr>
+          <a:xfrm>
+            <a:off x="3493008" y="3630168"/>
+            <a:ext cx="2231136" cy="201168"/>
+          </a:xfrm>
+          <a:prstGeom prst="rect">
+            <a:avLst/>
+          </a:prstGeom>
+          <a:noFill/>
+          <a:ln/>
+        </p:spPr>
+        <p:txBody>
+          <a:bodyPr wrap="square" lIns="0" tIns="0" rIns="0" bIns="0" rtlCol="0" anchor="ctr"/>
+          <a:lstStyle/>
+          <a:p>
+            <a:pPr indent="0" marL="0">
+              <a:buNone/>
+            </a:pPr>
+            <a:r>
+              <a:rPr lang="en-US" sz="720" dirty="0">
+                <a:solidFill>
+                  <a:srgbClr val="64748B"/>
+                </a:solidFill>
+                <a:latin typeface="Microsoft YaHei" pitchFamily="34" charset="0"/>
+                <a:ea typeface="Microsoft YaHei" pitchFamily="34" charset="-122"/>
+                <a:cs typeface="Microsoft YaHei" pitchFamily="34" charset="-120"/>
+              </a:rPr>
+              <a:t>缺口 </a:t>
+            </a:r>
+            <a:pPr indent="0" marL="0">
+              <a:buNone/>
+            </a:pPr>
+            <a:r>
+              <a:rPr lang="en-US" sz="720" b="1" dirty="0">
+                <a:solidFill>
+                  <a:srgbClr val="0E7490"/>
+                </a:solidFill>
+                <a:latin typeface="Microsoft YaHei" pitchFamily="34" charset="0"/>
+                <a:ea typeface="Microsoft YaHei" pitchFamily="34" charset="-122"/>
+                <a:cs typeface="Microsoft YaHei" pitchFamily="34" charset="-120"/>
+              </a:rPr>
+              <a:t>Q7 关系 +20.4 pt</a:t>
+            </a:r>
+            <a:endParaRPr lang="en-US" sz="720" dirty="0"/>
+          </a:p>
+        </p:txBody>
+      </p:sp>
+      <p:sp>
+        <p:nvSpPr>
+          <p:cNvPr id="35" name="Shape 33"/>
+          <p:cNvSpPr/>
+          <p:nvPr/>
+        </p:nvSpPr>
+        <p:spPr>
+          <a:xfrm>
+            <a:off x="6089904" y="2724912"/>
+            <a:ext cx="2596896" cy="1207008"/>
+          </a:xfrm>
+          <a:prstGeom prst="rect">
+            <a:avLst/>
+          </a:prstGeom>
+          <a:solidFill>
+            <a:srgbClr val="FFFFFF"/>
+          </a:solidFill>
+          <a:ln w="9525">
+            <a:solidFill>
+              <a:srgbClr val="E2E8F0"/>
+            </a:solidFill>
+            <a:prstDash val="solid"/>
+          </a:ln>
+          <a:effectLst>
+            <a:outerShdw sx="100000" sy="100000" kx="0" ky="0" algn="bl" rotWithShape="0" blurRad="101600" dist="38100" dir="8100000">
+              <a:srgbClr val="0F172A">
+                <a:alpha val="12000"/>
+              </a:srgbClr>
+            </a:outerShdw>
+          </a:effectLst>
+        </p:spPr>
+      </p:sp>
+      <p:sp>
+        <p:nvSpPr>
+          <p:cNvPr id="36" name="Shape 34"/>
+          <p:cNvSpPr/>
+          <p:nvPr/>
+        </p:nvSpPr>
+        <p:spPr>
+          <a:xfrm>
+            <a:off x="6089904" y="2724912"/>
+            <a:ext cx="54864" cy="1207008"/>
+          </a:xfrm>
+          <a:prstGeom prst="rect">
+            <a:avLst/>
+          </a:prstGeom>
+          <a:solidFill>
+            <a:srgbClr val="DC4A52"/>
+          </a:solidFill>
+          <a:ln/>
+        </p:spPr>
+      </p:sp>
+      <p:sp>
+        <p:nvSpPr>
+          <p:cNvPr id="37" name="Text 35"/>
+          <p:cNvSpPr/>
+          <p:nvPr/>
+        </p:nvSpPr>
+        <p:spPr>
+          <a:xfrm>
+            <a:off x="6236208" y="2816352"/>
+            <a:ext cx="2322576" cy="457200"/>
+          </a:xfrm>
+          <a:prstGeom prst="rect">
+            <a:avLst/>
+          </a:prstGeom>
+          <a:noFill/>
+          <a:ln/>
+        </p:spPr>
+        <p:txBody>
+          <a:bodyPr wrap="square" lIns="0" tIns="0" rIns="0" bIns="0" rtlCol="0" anchor="t"/>
+          <a:lstStyle/>
+          <a:p>
+            <a:pPr indent="0" marL="0">
+              <a:lnSpc>
+                <a:spcPct val="98000"/>
+              </a:lnSpc>
+              <a:buNone/>
+            </a:pPr>
+            <a:r>
+              <a:rPr lang="en-US" sz="1000" b="1" dirty="0">
+                <a:solidFill>
+                  <a:srgbClr val="DC4A52"/>
+                </a:solidFill>
+                <a:latin typeface="Microsoft YaHei" pitchFamily="34" charset="0"/>
+                <a:ea typeface="Microsoft YaHei" pitchFamily="34" charset="-122"/>
+                <a:cs typeface="Microsoft YaHei" pitchFamily="34" charset="-120"/>
+              </a:rPr>
+              <a:t>⑥ 更新不追踪</a:t>
+            </a:r>
+            <a:endParaRPr lang="en-US" sz="1000" dirty="0"/>
+          </a:p>
+        </p:txBody>
+      </p:sp>
+      <p:sp>
+        <p:nvSpPr>
+          <p:cNvPr id="38" name="Text 36"/>
+          <p:cNvSpPr/>
+          <p:nvPr/>
+        </p:nvSpPr>
+        <p:spPr>
+          <a:xfrm>
+            <a:off x="6236208" y="3236976"/>
+            <a:ext cx="2322576" cy="457200"/>
+          </a:xfrm>
+          <a:prstGeom prst="rect">
+            <a:avLst/>
+          </a:prstGeom>
+          <a:noFill/>
+          <a:ln/>
+        </p:spPr>
+        <p:txBody>
+          <a:bodyPr wrap="square" lIns="0" tIns="0" rIns="0" bIns="0" rtlCol="0" anchor="t"/>
+          <a:lstStyle/>
+          <a:p>
+            <a:pPr indent="0" marL="0">
+              <a:lnSpc>
+                <a:spcPct val="104000"/>
+              </a:lnSpc>
+              <a:buNone/>
+            </a:pPr>
+            <a:r>
+              <a:rPr lang="en-US" sz="800" dirty="0">
+                <a:solidFill>
+                  <a:srgbClr val="334155"/>
+                </a:solidFill>
+                <a:latin typeface="Microsoft YaHei" pitchFamily="34" charset="0"/>
+                <a:ea typeface="Microsoft YaHei" pitchFamily="34" charset="-122"/>
+                <a:cs typeface="Microsoft YaHei" pitchFamily="34" charset="-120"/>
+              </a:rPr>
+              <a:t>新旧合并做法并存，「当前做法」答成旧的</a:t>
+            </a:r>
+            <a:endParaRPr lang="en-US" sz="800" dirty="0"/>
+          </a:p>
+        </p:txBody>
+      </p:sp>
+      <p:sp>
+        <p:nvSpPr>
+          <p:cNvPr id="39" name="Shape 37"/>
+          <p:cNvSpPr/>
+          <p:nvPr/>
+        </p:nvSpPr>
+        <p:spPr>
+          <a:xfrm>
+            <a:off x="6236208" y="3639312"/>
+            <a:ext cx="2304288" cy="201168"/>
+          </a:xfrm>
+          <a:prstGeom prst="rect">
+            <a:avLst/>
+          </a:prstGeom>
+          <a:solidFill>
+            <a:srgbClr val="F1F5F9"/>
+          </a:solidFill>
+          <a:ln/>
+        </p:spPr>
+      </p:sp>
+      <p:sp>
+        <p:nvSpPr>
+          <p:cNvPr id="40" name="Text 38"/>
+          <p:cNvSpPr/>
+          <p:nvPr/>
+        </p:nvSpPr>
+        <p:spPr>
+          <a:xfrm>
+            <a:off x="6309360" y="3630168"/>
+            <a:ext cx="2231136" cy="201168"/>
+          </a:xfrm>
+          <a:prstGeom prst="rect">
+            <a:avLst/>
+          </a:prstGeom>
+          <a:noFill/>
+          <a:ln/>
+        </p:spPr>
+        <p:txBody>
+          <a:bodyPr wrap="square" lIns="0" tIns="0" rIns="0" bIns="0" rtlCol="0" anchor="ctr"/>
+          <a:lstStyle/>
+          <a:p>
+            <a:pPr indent="0" marL="0">
+              <a:buNone/>
+            </a:pPr>
+            <a:r>
+              <a:rPr lang="en-US" sz="720" dirty="0">
+                <a:solidFill>
+                  <a:srgbClr val="64748B"/>
+                </a:solidFill>
+                <a:latin typeface="Microsoft YaHei" pitchFamily="34" charset="0"/>
+                <a:ea typeface="Microsoft YaHei" pitchFamily="34" charset="-122"/>
+                <a:cs typeface="Microsoft YaHei" pitchFamily="34" charset="-120"/>
+              </a:rPr>
+              <a:t>缺口 </a:t>
+            </a:r>
+            <a:pPr indent="0" marL="0">
+              <a:buNone/>
+            </a:pPr>
+            <a:r>
+              <a:rPr lang="en-US" sz="720" b="1" dirty="0">
+                <a:solidFill>
+                  <a:srgbClr val="DC4A52"/>
+                </a:solidFill>
+                <a:latin typeface="Microsoft YaHei" pitchFamily="34" charset="0"/>
+                <a:ea typeface="Microsoft YaHei" pitchFamily="34" charset="-122"/>
+                <a:cs typeface="Microsoft YaHei" pitchFamily="34" charset="-120"/>
+              </a:rPr>
+              <a:t>知识更新 +17.8 pt</a:t>
+            </a:r>
+            <a:endParaRPr lang="en-US" sz="720" dirty="0"/>
+          </a:p>
+        </p:txBody>
+      </p:sp>
+      <p:sp>
+        <p:nvSpPr>
+          <p:cNvPr id="41" name="Shape 39"/>
+          <p:cNvSpPr/>
+          <p:nvPr/>
+        </p:nvSpPr>
+        <p:spPr>
+          <a:xfrm>
+            <a:off x="457200" y="4114800"/>
+            <a:ext cx="8229600" cy="841248"/>
+          </a:xfrm>
+          <a:prstGeom prst="rect">
+            <a:avLst/>
+          </a:prstGeom>
+          <a:solidFill>
+            <a:srgbClr val="12183A"/>
+          </a:solidFill>
+          <a:ln/>
+          <a:effectLst>
+            <a:outerShdw sx="100000" sy="100000" kx="0" ky="0" algn="bl" rotWithShape="0" blurRad="101600" dist="38100" dir="8100000">
+              <a:srgbClr val="0F172A">
+                <a:alpha val="12000"/>
+              </a:srgbClr>
+            </a:outerShdw>
+          </a:effectLst>
+        </p:spPr>
+      </p:sp>
+      <p:sp>
+        <p:nvSpPr>
+          <p:cNvPr id="42" name="Shape 40"/>
+          <p:cNvSpPr/>
+          <p:nvPr/>
+        </p:nvSpPr>
+        <p:spPr>
+          <a:xfrm>
+            <a:off x="457200" y="4114800"/>
+            <a:ext cx="54864" cy="841248"/>
+          </a:xfrm>
+          <a:prstGeom prst="rect">
+            <a:avLst/>
+          </a:prstGeom>
+          <a:solidFill>
+            <a:srgbClr val="0EA5C4"/>
+          </a:solidFill>
+          <a:ln/>
+        </p:spPr>
+      </p:sp>
+      <p:sp>
+        <p:nvSpPr>
+          <p:cNvPr id="43" name="Text 41"/>
+          <p:cNvSpPr/>
+          <p:nvPr/>
+        </p:nvSpPr>
+        <p:spPr>
+          <a:xfrm>
+            <a:off x="640080" y="4114800"/>
+            <a:ext cx="7863840" cy="841248"/>
+          </a:xfrm>
+          <a:prstGeom prst="rect">
+            <a:avLst/>
+          </a:prstGeom>
+          <a:noFill/>
+          <a:ln/>
+        </p:spPr>
+        <p:txBody>
+          <a:bodyPr wrap="square" lIns="0" tIns="0" rIns="0" bIns="0" rtlCol="0" anchor="ctr"/>
+          <a:lstStyle/>
+          <a:p>
+            <a:pPr indent="0" marL="0">
+              <a:lnSpc>
+                <a:spcPct val="112000"/>
+              </a:lnSpc>
+              <a:buNone/>
+            </a:pPr>
+            <a:r>
+              <a:rPr lang="en-US" sz="900" b="1" dirty="0">
+                <a:solidFill>
+                  <a:srgbClr val="0EA5C4"/>
+                </a:solidFill>
+                <a:latin typeface="Microsoft YaHei" pitchFamily="34" charset="0"/>
+                <a:ea typeface="Microsoft YaHei" pitchFamily="34" charset="-122"/>
+                <a:cs typeface="Microsoft YaHei" pitchFamily="34" charset="-120"/>
+              </a:rPr>
+              <a:t>本质：</a:t>
+            </a:r>
+            <a:pPr indent="0" marL="0">
+              <a:lnSpc>
+                <a:spcPct val="112000"/>
+              </a:lnSpc>
+              <a:buNone/>
+            </a:pPr>
+            <a:r>
+              <a:rPr lang="en-US" sz="900" dirty="0">
+                <a:solidFill>
+                  <a:srgbClr val="DDE6F5"/>
+                </a:solidFill>
+                <a:latin typeface="Microsoft YaHei" pitchFamily="34" charset="0"/>
+                <a:ea typeface="Microsoft YaHei" pitchFamily="34" charset="-122"/>
+                <a:cs typeface="Microsoft YaHei" pitchFamily="34" charset="-120"/>
+              </a:rPr>
+              <a:t>Mem0 不是「检索差」，而是入库时 LLM 摘要把多方对话最关键的三样——精确字面值 / 说话人归属 / 人际关系——压缩没了。</a:t>
+            </a:r>
+            <a:pPr indent="0" marL="0">
+              <a:lnSpc>
+                <a:spcPct val="112000"/>
+              </a:lnSpc>
+              <a:buNone/>
+            </a:pPr>
+            <a:endParaRPr lang="en-US" sz="900" dirty="0"/>
+          </a:p>
+          <a:p>
+            <a:pPr indent="0" marL="0">
+              <a:lnSpc>
+                <a:spcPct val="112000"/>
+              </a:lnSpc>
+              <a:buNone/>
+            </a:pPr>
+            <a:r>
+              <a:rPr lang="en-US" sz="900" dirty="0">
+                <a:solidFill>
+                  <a:srgbClr val="94A3B8"/>
+                </a:solidFill>
+                <a:latin typeface="Microsoft YaHei" pitchFamily="34" charset="0"/>
+                <a:ea typeface="Microsoft YaHei" pitchFamily="34" charset="-122"/>
+                <a:cs typeface="Microsoft YaHei" pitchFamily="34" charset="-120"/>
+              </a:rPr>
+              <a:t>BM25 赢=逐字原文+全元数据不丢；HippoRAG/A-MEM 赢=建实体-关系图/笔记链接，保 who-said-what。</a:t>
+            </a:r>
+            <a:endParaRPr lang="en-US" sz="900" dirty="0"/>
+          </a:p>
+          <a:p>
+            <a:pPr indent="0" marL="0">
+              <a:lnSpc>
+                <a:spcPct val="112000"/>
+              </a:lnSpc>
+              <a:buNone/>
+            </a:pPr>
+            <a:r>
+              <a:rPr lang="en-US" sz="900" b="1" dirty="0">
+                <a:solidFill>
+                  <a:srgbClr val="0EA5C4"/>
+                </a:solidFill>
+                <a:latin typeface="Microsoft YaHei" pitchFamily="34" charset="0"/>
+                <a:ea typeface="Microsoft YaHei" pitchFamily="34" charset="-122"/>
+                <a:cs typeface="Microsoft YaHei" pitchFamily="34" charset="-120"/>
+              </a:rPr>
+              <a:t> → 直接、可量化地论证 speaker-grounded 结构化记忆的必要。</a:t>
+            </a:r>
+            <a:endParaRPr lang="en-US" sz="900" dirty="0"/>
+          </a:p>
+        </p:txBody>
+      </p:sp>
+      <p:sp>
+        <p:nvSpPr>
+          <p:cNvPr id="44" name="Text 42"/>
+          <p:cNvSpPr/>
+          <p:nvPr/>
+        </p:nvSpPr>
+        <p:spPr>
+          <a:xfrm>
+            <a:off x="457200" y="4832604"/>
+            <a:ext cx="5486400" cy="237744"/>
+          </a:xfrm>
+          <a:prstGeom prst="rect">
+            <a:avLst/>
+          </a:prstGeom>
+          <a:noFill/>
+          <a:ln/>
+        </p:spPr>
+        <p:txBody>
+          <a:bodyPr wrap="square" lIns="0" tIns="0" rIns="0" bIns="0" rtlCol="0" anchor="ctr"/>
+          <a:lstStyle/>
+          <a:p>
+            <a:pPr indent="0" marL="0">
+              <a:buNone/>
+            </a:pPr>
+            <a:r>
+              <a:rPr lang="en-US" sz="800" dirty="0">
+                <a:solidFill>
+                  <a:srgbClr val="94A3B8"/>
+                </a:solidFill>
+                <a:latin typeface="Microsoft YaHei" pitchFamily="34" charset="0"/>
+                <a:ea typeface="Microsoft YaHei" pitchFamily="34" charset="-122"/>
+                <a:cs typeface="Microsoft YaHei" pitchFamily="34" charset="-120"/>
+              </a:rPr>
+              <a:t>SpeakerMem-R1 · 问题导向汇报 V2 · 2026-06-03</a:t>
+            </a:r>
+            <a:endParaRPr lang="en-US" sz="800" dirty="0"/>
+          </a:p>
+        </p:txBody>
+      </p:sp>
+      <p:sp>
+        <p:nvSpPr>
+          <p:cNvPr id="45" name="Text 43"/>
+          <p:cNvSpPr/>
+          <p:nvPr/>
+        </p:nvSpPr>
+        <p:spPr>
+          <a:xfrm>
+            <a:off x="8046720" y="4832604"/>
+            <a:ext cx="640080" cy="237744"/>
+          </a:xfrm>
+          <a:prstGeom prst="rect">
+            <a:avLst/>
+          </a:prstGeom>
+          <a:noFill/>
+          <a:ln/>
+        </p:spPr>
+        <p:txBody>
+          <a:bodyPr wrap="square" lIns="0" tIns="0" rIns="0" bIns="0" rtlCol="0" anchor="ctr"/>
+          <a:lstStyle/>
+          <a:p>
+            <a:pPr algn="r" indent="0" marL="0">
+              <a:buNone/>
+            </a:pPr>
+            <a:r>
+              <a:rPr lang="en-US" sz="800" dirty="0">
+                <a:solidFill>
+                  <a:srgbClr val="94A3B8"/>
+                </a:solidFill>
+                <a:latin typeface="Microsoft YaHei" pitchFamily="34" charset="0"/>
+                <a:ea typeface="Microsoft YaHei" pitchFamily="34" charset="-122"/>
+                <a:cs typeface="Microsoft YaHei" pitchFamily="34" charset="-120"/>
+              </a:rPr>
+              <a:t>17 / 17</a:t>
             </a:r>
             <a:endParaRPr lang="en-US" sz="800" dirty="0"/>
           </a:p>
@@ -18514,7 +20490,7 @@
                 <a:ea typeface="Microsoft YaHei" pitchFamily="34" charset="-122"/>
                 <a:cs typeface="Microsoft YaHei" pitchFamily="34" charset="-120"/>
               </a:rPr>
-              <a:t>2 / 16</a:t>
+              <a:t>2 / 17</a:t>
             </a:r>
             <a:endParaRPr lang="en-US" sz="800" dirty="0"/>
           </a:p>
@@ -23714,7 +25690,7 @@
                 <a:ea typeface="Microsoft YaHei" pitchFamily="34" charset="-122"/>
                 <a:cs typeface="Microsoft YaHei" pitchFamily="34" charset="-120"/>
               </a:rPr>
-              <a:t>3 / 16</a:t>
+              <a:t>3 / 17</a:t>
             </a:r>
             <a:endParaRPr lang="en-US" sz="800" dirty="0"/>
           </a:p>
@@ -30753,7 +32729,7 @@
                 <a:ea typeface="Microsoft YaHei" pitchFamily="34" charset="-122"/>
                 <a:cs typeface="Microsoft YaHei" pitchFamily="34" charset="-120"/>
               </a:rPr>
-              <a:t>4 / 16</a:t>
+              <a:t>4 / 17</a:t>
             </a:r>
             <a:endParaRPr lang="en-US" sz="800" dirty="0"/>
           </a:p>
@@ -35542,7 +37518,7 @@
                 <a:ea typeface="Microsoft YaHei" pitchFamily="34" charset="-122"/>
                 <a:cs typeface="Microsoft YaHei" pitchFamily="34" charset="-120"/>
               </a:rPr>
-              <a:t>5 / 16</a:t>
+              <a:t>5 / 17</a:t>
             </a:r>
             <a:endParaRPr lang="en-US" sz="800" dirty="0"/>
           </a:p>
@@ -38519,7 +40495,7 @@
                 <a:ea typeface="Microsoft YaHei" pitchFamily="34" charset="-122"/>
                 <a:cs typeface="Microsoft YaHei" pitchFamily="34" charset="-120"/>
               </a:rPr>
-              <a:t>6 / 16</a:t>
+              <a:t>6 / 17</a:t>
             </a:r>
             <a:endParaRPr lang="en-US" sz="800" dirty="0"/>
           </a:p>
@@ -42280,7 +44256,7 @@
                 <a:ea typeface="Microsoft YaHei" pitchFamily="34" charset="-122"/>
                 <a:cs typeface="Microsoft YaHei" pitchFamily="34" charset="-120"/>
               </a:rPr>
-              <a:t>7 / 16</a:t>
+              <a:t>7 / 17</a:t>
             </a:r>
             <a:endParaRPr lang="en-US" sz="800" dirty="0"/>
           </a:p>
@@ -43944,7 +45920,7 @@
                 <a:ea typeface="Microsoft YaHei" pitchFamily="34" charset="-122"/>
                 <a:cs typeface="Microsoft YaHei" pitchFamily="34" charset="-120"/>
               </a:rPr>
-              <a:t>8 / 16</a:t>
+              <a:t>8 / 17</a:t>
             </a:r>
             <a:endParaRPr lang="en-US" sz="800" dirty="0"/>
           </a:p>
@@ -45179,7 +47155,7 @@
                 <a:ea typeface="Microsoft YaHei" pitchFamily="34" charset="-122"/>
                 <a:cs typeface="Microsoft YaHei" pitchFamily="34" charset="-120"/>
               </a:rPr>
-              <a:t>9 / 16</a:t>
+              <a:t>9 / 17</a:t>
             </a:r>
             <a:endParaRPr lang="en-US" sz="800" dirty="0"/>
           </a:p>

</xml_diff>